<commit_message>
docs: upgrade presentation to hybrid enterprise template
</commit_message>
<xml_diff>
--- a/CRC_Project_Documentation.pptx
+++ b/CRC_Project_Documentation.pptx
@@ -14,6 +14,7 @@
     <p:sldId id="262" r:id="rId13"/>
     <p:sldId id="263" r:id="rId14"/>
     <p:sldId id="264" r:id="rId15"/>
+    <p:sldId id="265" r:id="rId16"/>
   </p:sldIdLst>
   <p:sldSz cx="12191695" cy="6858000" type="screen4x3"/>
   <p:notesSz cx="6858000" cy="9144000"/>
@@ -3092,7 +3093,7 @@
     <p:bg>
       <p:bgPr>
         <a:solidFill>
-          <a:srgbClr val="0A0D1A"/>
+          <a:srgbClr val="0B192C"/>
         </a:solidFill>
         <a:effectLst/>
       </p:bgPr>
@@ -3119,7 +3120,7 @@
             <a:avLst/>
           </a:prstGeom>
           <a:solidFill>
-            <a:srgbClr val="0EA5E9"/>
+            <a:srgbClr val="0284C7"/>
           </a:solidFill>
           <a:ln>
             <a:noFill/>
@@ -3155,8 +3156,8 @@
         </p:nvSpPr>
         <p:spPr>
           <a:xfrm>
-            <a:off x="1097280" y="2011680"/>
-            <a:ext cx="10058400" cy="2926080"/>
+            <a:off x="1097280" y="1828800"/>
+            <a:ext cx="10058400" cy="3200400"/>
           </a:xfrm>
           <a:prstGeom prst="rect">
             <a:avLst/>
@@ -3175,29 +3176,29 @@
               </a:spcAft>
               <a:defRPr sz="4400" b="1">
                 <a:solidFill>
-                  <a:srgbClr val="F8FAFC"/>
-                </a:solidFill>
-                <a:latin typeface="Microsoft JhengHei"/>
-              </a:defRPr>
-            </a:pPr>
-            <a:r>
-              <a:t>CRC 中學學務實踐平台</a:t>
-            </a:r>
-          </a:p>
-          <a:p>
-            <a:pPr>
-              <a:spcAft>
-                <a:spcPts val="4000"/>
+                  <a:srgbClr val="FFFFFF"/>
+                </a:solidFill>
+                <a:latin typeface="Microsoft JhengHei"/>
+              </a:defRPr>
+            </a:pPr>
+            <a:r>
+              <a:t>CRC 中學學務實踐培力平台</a:t>
+            </a:r>
+          </a:p>
+          <a:p>
+            <a:pPr>
+              <a:spcAft>
+                <a:spcPts val="4500"/>
               </a:spcAft>
               <a:defRPr sz="1800">
                 <a:solidFill>
-                  <a:srgbClr val="0EA5E9"/>
-                </a:solidFill>
-                <a:latin typeface="Microsoft JhengHei"/>
-              </a:defRPr>
-            </a:pPr>
-            <a:r>
-              <a:t>HTML 互動簡報、情境模擬遊戲與 Google Sheets 後端串接技術手冊</a:t>
+                  <a:srgbClr val="0284C7"/>
+                </a:solidFill>
+                <a:latin typeface="Microsoft JhengHei"/>
+              </a:defRPr>
+            </a:pPr>
+            <a:r>
+              <a:t>HTML5 互動簡報、情境模擬遊戲與 Google Sheets 後端串接技術手冊</a:t>
             </a:r>
           </a:p>
           <a:p>
@@ -3207,17 +3208,201 @@
               </a:lnSpc>
               <a:defRPr sz="1200">
                 <a:solidFill>
-                  <a:srgbClr val="94A3B8"/>
-                </a:solidFill>
-                <a:latin typeface="Microsoft JhengHei"/>
-              </a:defRPr>
-            </a:pPr>
-            <a:r>
-              <a:t>專案開發者：AI 師培教材設計團隊</a:t>
+                  <a:srgbClr val="CBD5E1"/>
+                </a:solidFill>
+                <a:latin typeface="Microsoft JhengHei"/>
+              </a:defRPr>
+            </a:pPr>
+            <a:r>
+              <a:t>製作團隊：AI 師培數位教材開發組</a:t>
             </a:r>
             <a:br/>
             <a:r>
-              <a:t>對象：大二師培生數位學習平台開發紀錄</a:t>
+              <a:t>發行對象：大二師培生「中學學生事務實踐」學術發表與技術手冊</a:t>
+            </a:r>
+          </a:p>
+        </p:txBody>
+      </p:sp>
+    </p:spTree>
+  </p:cSld>
+  <p:clrMapOvr>
+    <a:masterClrMapping/>
+  </p:clrMapOvr>
+</p:sld>
+</file>
+
+<file path=ppt/slides/slide10.xml><?xml version="1.0" encoding="utf-8"?>
+<p:sld xmlns:a="http://schemas.openxmlformats.org/drawingml/2006/main" xmlns:p="http://schemas.openxmlformats.org/presentationml/2006/main" xmlns:r="http://schemas.openxmlformats.org/officeDocument/2006/relationships">
+  <p:cSld>
+    <p:bg>
+      <p:bgPr>
+        <a:solidFill>
+          <a:srgbClr val="0B192C"/>
+        </a:solidFill>
+        <a:effectLst/>
+      </p:bgPr>
+    </p:bg>
+    <p:spTree>
+      <p:nvGrpSpPr>
+        <p:cNvPr id="1" name=""/>
+        <p:cNvGrpSpPr/>
+        <p:nvPr/>
+      </p:nvGrpSpPr>
+      <p:grpSpPr/>
+      <p:sp>
+        <p:nvSpPr>
+          <p:cNvPr id="2" name="Rectangle 1"/>
+          <p:cNvSpPr/>
+          <p:nvPr/>
+        </p:nvSpPr>
+        <p:spPr>
+          <a:xfrm>
+            <a:off x="0" y="0"/>
+            <a:ext cx="365760" cy="6858000"/>
+          </a:xfrm>
+          <a:prstGeom prst="rect">
+            <a:avLst/>
+          </a:prstGeom>
+          <a:solidFill>
+            <a:srgbClr val="7E22CE"/>
+          </a:solidFill>
+          <a:ln>
+            <a:noFill/>
+          </a:ln>
+        </p:spPr>
+        <p:style>
+          <a:lnRef idx="1">
+            <a:schemeClr val="accent1"/>
+          </a:lnRef>
+          <a:fillRef idx="3">
+            <a:schemeClr val="accent1"/>
+          </a:fillRef>
+          <a:effectRef idx="2">
+            <a:schemeClr val="accent1"/>
+          </a:effectRef>
+          <a:fontRef idx="minor">
+            <a:schemeClr val="lt1"/>
+          </a:fontRef>
+        </p:style>
+        <p:txBody>
+          <a:bodyPr rtlCol="0" anchor="ctr"/>
+          <a:lstStyle/>
+          <a:p>
+            <a:pPr algn="ctr"/>
+          </a:p>
+        </p:txBody>
+      </p:sp>
+      <p:sp>
+        <p:nvSpPr>
+          <p:cNvPr id="3" name="TextBox 2"/>
+          <p:cNvSpPr txBox="1"/>
+          <p:nvPr/>
+        </p:nvSpPr>
+        <p:spPr>
+          <a:xfrm>
+            <a:off x="1097280" y="1645920"/>
+            <a:ext cx="10058400" cy="4114800"/>
+          </a:xfrm>
+          <a:prstGeom prst="rect">
+            <a:avLst/>
+          </a:prstGeom>
+          <a:noFill/>
+        </p:spPr>
+        <p:txBody>
+          <a:bodyPr wrap="square">
+            <a:spAutoFit/>
+          </a:bodyPr>
+          <a:lstStyle/>
+          <a:p>
+            <a:pPr>
+              <a:spcAft>
+                <a:spcPts val="2500"/>
+              </a:spcAft>
+              <a:defRPr sz="3600" b="1">
+                <a:solidFill>
+                  <a:srgbClr val="FFFFFF"/>
+                </a:solidFill>
+                <a:latin typeface="Microsoft JhengHei"/>
+              </a:defRPr>
+            </a:pPr>
+            <a:r>
+              <a:t>結論與未來展望：師培數位化學習新典範</a:t>
+            </a:r>
+          </a:p>
+          <a:p>
+            <a:pPr>
+              <a:lnSpc>
+                <a:spcPct val="130000"/>
+              </a:lnSpc>
+              <a:spcAft>
+                <a:spcPts val="1200"/>
+              </a:spcAft>
+              <a:defRPr sz="1300">
+                <a:solidFill>
+                  <a:srgbClr val="0284C7"/>
+                </a:solidFill>
+                <a:latin typeface="Microsoft JhengHei"/>
+              </a:defRPr>
+            </a:pPr>
+            <a:r>
+              <a:t>🌟 雙軌引擎，相輔相成 —— 以 50 頁互動簡報奠定 CRC 法理基礎；透過四階段情境遊戲淬鍊學務抉擇。雙管齊下，打造高品質、高互動性的培力平台。</a:t>
+            </a:r>
+          </a:p>
+          <a:p>
+            <a:pPr>
+              <a:lnSpc>
+                <a:spcPct val="130000"/>
+              </a:lnSpc>
+              <a:spcAft>
+                <a:spcPts val="1200"/>
+              </a:spcAft>
+              <a:defRPr sz="1300">
+                <a:solidFill>
+                  <a:srgbClr val="FFFFFF"/>
+                </a:solidFill>
+                <a:latin typeface="Microsoft JhengHei"/>
+              </a:defRPr>
+            </a:pPr>
+            <a:r>
+              <a:t>⚡ 輕量架構，永續運作 —— 以 Google Sheets 代替傳統資料庫，免除伺服器維護成本與資料庫租金，適合教育研究及課堂教學長期託管。</a:t>
+            </a:r>
+          </a:p>
+          <a:p>
+            <a:pPr>
+              <a:lnSpc>
+                <a:spcPct val="130000"/>
+              </a:lnSpc>
+              <a:spcAft>
+                <a:spcPts val="1200"/>
+              </a:spcAft>
+              <a:defRPr sz="1300">
+                <a:solidFill>
+                  <a:srgbClr val="0284C7"/>
+                </a:solidFill>
+                <a:latin typeface="Microsoft JhengHei"/>
+              </a:defRPr>
+            </a:pPr>
+            <a:r>
+              <a:t>🛡️ 高容錯率，靈活擴充 —— 獨創 Web App 跨域 no-cors 傳送與 Code.gs 表頭動態遷移 (Schema Migration) 技術，未來課程內容微調無須改動資料庫架構。</a:t>
+            </a:r>
+          </a:p>
+          <a:p>
+            <a:pPr>
+              <a:lnSpc>
+                <a:spcPct val="130000"/>
+              </a:lnSpc>
+              <a:spcAft>
+                <a:spcPts val="1200"/>
+              </a:spcAft>
+              <a:defRPr sz="1300">
+                <a:solidFill>
+                  <a:srgbClr val="FFFFFF"/>
+                </a:solidFill>
+                <a:latin typeface="Microsoft JhengHei"/>
+              </a:defRPr>
+            </a:pPr>
+            <a:r>
+              <a:t>🎓 師培啟航，人權扎根 —— 本平台成功協助大二師培學員將「兒童權利公約」融入中學導師帶班實務，培育新世代兼具「人權信念」與「法規專業」的優秀教師！</a:t>
             </a:r>
           </a:p>
         </p:txBody>
@@ -3236,7 +3421,7 @@
     <p:bg>
       <p:bgPr>
         <a:solidFill>
-          <a:srgbClr val="0A0D1A"/>
+          <a:srgbClr val="F8FAFC"/>
         </a:solidFill>
         <a:effectLst/>
       </p:bgPr>
@@ -3273,13 +3458,13 @@
             <a:pPr>
               <a:defRPr sz="1000" b="1">
                 <a:solidFill>
-                  <a:srgbClr val="A855F7"/>
+                  <a:srgbClr val="7E22CE"/>
                 </a:solidFill>
                 <a:latin typeface="Arial"/>
               </a:defRPr>
             </a:pPr>
             <a:r>
-              <a:t>專案技術手冊</a:t>
+              <a:t>CRC 專案開發與後端串接手冊</a:t>
             </a:r>
           </a:p>
         </p:txBody>
@@ -3309,7 +3494,7 @@
             <a:pPr>
               <a:defRPr sz="2600" b="1">
                 <a:solidFill>
-                  <a:srgbClr val="F8FAFC"/>
+                  <a:srgbClr val="0F172A"/>
                 </a:solidFill>
                 <a:latin typeface="Microsoft JhengHei"/>
               </a:defRPr>
@@ -3335,7 +3520,7 @@
             <a:avLst/>
           </a:prstGeom>
           <a:solidFill>
-            <a:srgbClr val="334155"/>
+            <a:srgbClr val="E2E8F0"/>
           </a:solidFill>
           <a:ln>
             <a:noFill/>
@@ -3372,17 +3557,17 @@
         <p:spPr>
           <a:xfrm>
             <a:off x="685800" y="1645920"/>
-            <a:ext cx="5120640" cy="4389120"/>
+            <a:ext cx="5212080" cy="4480560"/>
           </a:xfrm>
           <a:prstGeom prst="rect">
             <a:avLst/>
           </a:prstGeom>
           <a:solidFill>
-            <a:srgbClr val="151D3B"/>
+            <a:srgbClr val="FFFFFF"/>
           </a:solidFill>
           <a:ln w="19050">
             <a:solidFill>
-              <a:srgbClr val="0EA5E9"/>
+              <a:srgbClr val="0284C7"/>
             </a:solidFill>
           </a:ln>
         </p:spPr>
@@ -3416,8 +3601,8 @@
         </p:nvSpPr>
         <p:spPr>
           <a:xfrm>
-            <a:off x="1051560" y="1920240"/>
-            <a:ext cx="4389120" cy="3840480"/>
+            <a:off x="960120" y="1828800"/>
+            <a:ext cx="4663440" cy="4114800"/>
           </a:xfrm>
           <a:prstGeom prst="rect">
             <a:avLst/>
@@ -3432,11 +3617,11 @@
           <a:p>
             <a:pPr>
               <a:spcAft>
-                <a:spcPts val="1500"/>
+                <a:spcPts val="1200"/>
               </a:spcAft>
               <a:defRPr sz="1800" b="1">
                 <a:solidFill>
-                  <a:srgbClr val="0EA5E9"/>
+                  <a:srgbClr val="0284C7"/>
                 </a:solidFill>
                 <a:latin typeface="Microsoft JhengHei"/>
               </a:defRPr>
@@ -3448,17 +3633,17 @@
           <a:p>
             <a:pPr>
               <a:spcAft>
-                <a:spcPts val="1500"/>
+                <a:spcPts val="1200"/>
               </a:spcAft>
               <a:defRPr sz="1300">
                 <a:solidFill>
-                  <a:srgbClr val="F8FAFC"/>
-                </a:solidFill>
-                <a:latin typeface="Microsoft JhengHei"/>
-              </a:defRPr>
-            </a:pPr>
-            <a:r>
-              <a:t>本專案針對大二師培生設計，將「兒童權利公約 (CRC)」與中學學生事務實踐深度結合。利用 HTML5 互動媒介，幫助未來教師建立人權管理信念，達成以下教育目的：</a:t>
+                  <a:srgbClr val="0F172A"/>
+                </a:solidFill>
+                <a:latin typeface="Microsoft JhengHei"/>
+              </a:defRPr>
+            </a:pPr>
+            <a:r>
+              <a:t>本專案為大二師培生量身設計，聚焦於「兒童權利公約 (CRC)」在校園實務之運用。藉由 HTML5 網頁互動媒介，擺脫傳統威權管理思維，培養以下關鍵能力：</a:t>
             </a:r>
           </a:p>
           <a:p>
@@ -3466,15 +3651,15 @@
               <a:spcAft>
                 <a:spcPts val="800"/>
               </a:spcAft>
-              <a:defRPr sz="1200">
-                <a:solidFill>
-                  <a:srgbClr val="94A3B8"/>
-                </a:solidFill>
-                <a:latin typeface="Microsoft JhengHei"/>
-              </a:defRPr>
-            </a:pPr>
-            <a:r>
-              <a:t>• 理解 CRC 四大基本原則於校園管理的具體意涵。</a:t>
+              <a:defRPr sz="1150">
+                <a:solidFill>
+                  <a:srgbClr val="475569"/>
+                </a:solidFill>
+                <a:latin typeface="Microsoft JhengHei"/>
+              </a:defRPr>
+            </a:pPr>
+            <a:r>
+              <a:t>• 理解與體現 CRC 四大核心原則於中學生活規約中。</a:t>
             </a:r>
           </a:p>
           <a:p>
@@ -3482,15 +3667,15 @@
               <a:spcAft>
                 <a:spcPts val="800"/>
               </a:spcAft>
-              <a:defRPr sz="1200">
-                <a:solidFill>
-                  <a:srgbClr val="94A3B8"/>
-                </a:solidFill>
-                <a:latin typeface="Microsoft JhengHei"/>
-              </a:defRPr>
-            </a:pPr>
-            <a:r>
-              <a:t>• 應用教育部最新生活規約，擺脫過時威權管教迷思。</a:t>
+              <a:defRPr sz="1150">
+                <a:solidFill>
+                  <a:srgbClr val="475569"/>
+                </a:solidFill>
+                <a:latin typeface="Microsoft JhengHei"/>
+              </a:defRPr>
+            </a:pPr>
+            <a:r>
+              <a:t>• 對接教育部最新學生事務處理要點，淘汰過時威權管教。</a:t>
             </a:r>
           </a:p>
           <a:p>
@@ -3498,15 +3683,15 @@
               <a:spcAft>
                 <a:spcPts val="800"/>
               </a:spcAft>
-              <a:defRPr sz="1200">
-                <a:solidFill>
-                  <a:srgbClr val="94A3B8"/>
-                </a:solidFill>
-                <a:latin typeface="Microsoft JhengHei"/>
-              </a:defRPr>
-            </a:pPr>
-            <a:r>
-              <a:t>• 培力批判性思考，具備體檢及修正不合理校規之素養。</a:t>
+              <a:defRPr sz="1150">
+                <a:solidFill>
+                  <a:srgbClr val="475569"/>
+                </a:solidFill>
+                <a:latin typeface="Microsoft JhengHei"/>
+              </a:defRPr>
+            </a:pPr>
+            <a:r>
+              <a:t>• 批判思考不合理校規，具備民主協商與條文修正能力。</a:t>
             </a:r>
           </a:p>
           <a:p>
@@ -3514,15 +3699,15 @@
               <a:spcAft>
                 <a:spcPts val="800"/>
               </a:spcAft>
-              <a:defRPr sz="1200">
-                <a:solidFill>
-                  <a:srgbClr val="94A3B8"/>
-                </a:solidFill>
-                <a:latin typeface="Microsoft JhengHei"/>
-              </a:defRPr>
-            </a:pPr>
-            <a:r>
-              <a:t>• 實踐共創班規與修復式正義對話之創造成果。</a:t>
+              <a:defRPr sz="1150">
+                <a:solidFill>
+                  <a:srgbClr val="475569"/>
+                </a:solidFill>
+                <a:latin typeface="Microsoft JhengHei"/>
+              </a:defRPr>
+            </a:pPr>
+            <a:r>
+              <a:t>• 實作班級自治規章共創與修復式對話的溝通實踐。</a:t>
             </a:r>
           </a:p>
         </p:txBody>
@@ -3535,18 +3720,18 @@
         </p:nvSpPr>
         <p:spPr>
           <a:xfrm>
-            <a:off x="6382512" y="1645920"/>
-            <a:ext cx="5120640" cy="4389120"/>
+            <a:off x="6291072" y="1645920"/>
+            <a:ext cx="5212080" cy="4480560"/>
           </a:xfrm>
           <a:prstGeom prst="rect">
             <a:avLst/>
           </a:prstGeom>
           <a:solidFill>
-            <a:srgbClr val="151D3B"/>
+            <a:srgbClr val="FFFFFF"/>
           </a:solidFill>
           <a:ln w="19050">
             <a:solidFill>
-              <a:srgbClr val="A855F7"/>
+              <a:srgbClr val="7E22CE"/>
             </a:solidFill>
           </a:ln>
         </p:spPr>
@@ -3580,8 +3765,8 @@
         </p:nvSpPr>
         <p:spPr>
           <a:xfrm>
-            <a:off x="6748272" y="1920240"/>
-            <a:ext cx="4389120" cy="3840480"/>
+            <a:off x="6565392" y="1828800"/>
+            <a:ext cx="4663440" cy="4114800"/>
           </a:xfrm>
           <a:prstGeom prst="rect">
             <a:avLst/>
@@ -3596,11 +3781,11 @@
           <a:p>
             <a:pPr>
               <a:spcAft>
-                <a:spcPts val="1500"/>
+                <a:spcPts val="1200"/>
               </a:spcAft>
               <a:defRPr sz="1800" b="1">
                 <a:solidFill>
-                  <a:srgbClr val="A855F7"/>
+                  <a:srgbClr val="7E22CE"/>
                 </a:solidFill>
                 <a:latin typeface="Microsoft JhengHei"/>
               </a:defRPr>
@@ -3612,75 +3797,75 @@
           <a:p>
             <a:pPr>
               <a:spcAft>
-                <a:spcPts val="400"/>
-              </a:spcAft>
-              <a:defRPr sz="1400" b="1">
-                <a:solidFill>
-                  <a:srgbClr val="F8FAFC"/>
-                </a:solidFill>
-                <a:latin typeface="Microsoft JhengHei"/>
-              </a:defRPr>
-            </a:pPr>
-            <a:r>
-              <a:t>📖 50頁 HTML 互動簡報</a:t>
-            </a:r>
-          </a:p>
-          <a:p>
-            <a:pPr>
-              <a:spcAft>
-                <a:spcPts val="1200"/>
+                <a:spcPts val="300"/>
+              </a:spcAft>
+              <a:defRPr sz="1300" b="1">
+                <a:solidFill>
+                  <a:srgbClr val="0F172A"/>
+                </a:solidFill>
+                <a:latin typeface="Microsoft JhengHei"/>
+              </a:defRPr>
+            </a:pPr>
+            <a:r>
+              <a:t>📖 50頁 HTML 互動簡報 (Reveal.js)</a:t>
+            </a:r>
+          </a:p>
+          <a:p>
+            <a:pPr>
+              <a:spcAft>
+                <a:spcPts val="1000"/>
               </a:spcAft>
               <a:defRPr sz="1100">
                 <a:solidFill>
-                  <a:srgbClr val="94A3B8"/>
-                </a:solidFill>
-                <a:latin typeface="Microsoft JhengHei"/>
-              </a:defRPr>
-            </a:pPr>
-            <a:r>
-              <a:t>使用 Reveal.js 嵌入式開發，具備左側同步目錄導覽與 P13 對比拉桿，內嵌 6 道素養討論題，收集學生反思寫入 Sheet。</a:t>
-            </a:r>
-          </a:p>
-          <a:p>
-            <a:pPr>
-              <a:spcAft>
-                <a:spcPts val="400"/>
-              </a:spcAft>
-              <a:defRPr sz="1400" b="1">
-                <a:solidFill>
-                  <a:srgbClr val="F8FAFC"/>
-                </a:solidFill>
-                <a:latin typeface="Microsoft JhengHei"/>
-              </a:defRPr>
-            </a:pPr>
-            <a:r>
-              <a:t>🎮 四階段冒險闖關遊戲</a:t>
-            </a:r>
-          </a:p>
-          <a:p>
-            <a:pPr>
-              <a:spcAft>
-                <a:spcPts val="1200"/>
+                  <a:srgbClr val="475569"/>
+                </a:solidFill>
+                <a:latin typeface="Microsoft JhengHei"/>
+              </a:defRPr>
+            </a:pPr>
+            <a:r>
+              <a:t>嵌入式簡報開發，具備左側同步導覽側欄、P13 人權對比拉桿，並內嵌 6 道探究討論框，反思紀錄自動寫入 Sheets。</a:t>
+            </a:r>
+          </a:p>
+          <a:p>
+            <a:pPr>
+              <a:spcAft>
+                <a:spcPts val="300"/>
+              </a:spcAft>
+              <a:defRPr sz="1300" b="1">
+                <a:solidFill>
+                  <a:srgbClr val="0F172A"/>
+                </a:solidFill>
+                <a:latin typeface="Microsoft JhengHei"/>
+              </a:defRPr>
+            </a:pPr>
+            <a:r>
+              <a:t>🎮 四階段情境模擬闖關遊戲</a:t>
+            </a:r>
+          </a:p>
+          <a:p>
+            <a:pPr>
+              <a:spcAft>
+                <a:spcPts val="1000"/>
               </a:spcAft>
               <a:defRPr sz="1100">
                 <a:solidFill>
-                  <a:srgbClr val="94A3B8"/>
-                </a:solidFill>
-                <a:latin typeface="Microsoft JhengHei"/>
-              </a:defRPr>
-            </a:pPr>
-            <a:r>
-              <a:t>包含單選題、連連看配對、不低於50字規章體檢簡答、修復式對話排序等題型。強制 20 分鐘研討長度，串接同一個 Google Sheet API。</a:t>
-            </a:r>
-          </a:p>
-          <a:p>
-            <a:pPr>
-              <a:spcAft>
-                <a:spcPts val="400"/>
-              </a:spcAft>
-              <a:defRPr sz="1400" b="1">
-                <a:solidFill>
-                  <a:srgbClr val="F8FAFC"/>
+                  <a:srgbClr val="475569"/>
+                </a:solidFill>
+                <a:latin typeface="Microsoft JhengHei"/>
+              </a:defRPr>
+            </a:pPr>
+            <a:r>
+              <a:t>包含法規選擇、點選式卡牌配對、不低於 50 字規章體檢與對話排序。設有時長防呆限制，提供深度學習回饋。</a:t>
+            </a:r>
+          </a:p>
+          <a:p>
+            <a:pPr>
+              <a:spcAft>
+                <a:spcPts val="300"/>
+              </a:spcAft>
+              <a:defRPr sz="1300" b="1">
+                <a:solidFill>
+                  <a:srgbClr val="0F172A"/>
                 </a:solidFill>
                 <a:latin typeface="Microsoft JhengHei"/>
               </a:defRPr>
@@ -3692,17 +3877,17 @@
           <a:p>
             <a:pPr>
               <a:spcAft>
-                <a:spcPts val="1200"/>
+                <a:spcPts val="1000"/>
               </a:spcAft>
               <a:defRPr sz="1100">
                 <a:solidFill>
-                  <a:srgbClr val="94A3B8"/>
-                </a:solidFill>
-                <a:latin typeface="Microsoft JhengHei"/>
-              </a:defRPr>
-            </a:pPr>
-            <a:r>
-              <a:t>以 Google Apps Script 為 API 橋樑，串接 Google Sheets。支援欄位自動遷移功能（舊表自動追加簡答欄位）。</a:t>
+                  <a:srgbClr val="475569"/>
+                </a:solidFill>
+                <a:latin typeface="Microsoft JhengHei"/>
+              </a:defRPr>
+            </a:pPr>
+            <a:r>
+              <a:t>以 Google Apps Script 部署 Web App 作為 API，零成本串接 Sheets。支援動態表頭自動遷移，保障未來擴充彈性。</a:t>
             </a:r>
           </a:p>
         </p:txBody>
@@ -3721,7 +3906,7 @@
     <p:bg>
       <p:bgPr>
         <a:solidFill>
-          <a:srgbClr val="0A0D1A"/>
+          <a:srgbClr val="F8FAFC"/>
         </a:solidFill>
         <a:effectLst/>
       </p:bgPr>
@@ -3758,13 +3943,13 @@
             <a:pPr>
               <a:defRPr sz="1000" b="1">
                 <a:solidFill>
-                  <a:srgbClr val="A855F7"/>
+                  <a:srgbClr val="7E22CE"/>
                 </a:solidFill>
                 <a:latin typeface="Arial"/>
               </a:defRPr>
             </a:pPr>
             <a:r>
-              <a:t>專案技術手冊</a:t>
+              <a:t>CRC 專案開發與後端串接手冊</a:t>
             </a:r>
           </a:p>
         </p:txBody>
@@ -3794,7 +3979,7 @@
             <a:pPr>
               <a:defRPr sz="2600" b="1">
                 <a:solidFill>
-                  <a:srgbClr val="F8FAFC"/>
+                  <a:srgbClr val="0F172A"/>
                 </a:solidFill>
                 <a:latin typeface="Microsoft JhengHei"/>
               </a:defRPr>
@@ -3820,7 +4005,7 @@
             <a:avLst/>
           </a:prstGeom>
           <a:solidFill>
-            <a:srgbClr val="334155"/>
+            <a:srgbClr val="E2E8F0"/>
           </a:solidFill>
           <a:ln>
             <a:noFill/>
@@ -3857,7 +4042,7 @@
         <p:spPr>
           <a:xfrm>
             <a:off x="685800" y="1645920"/>
-            <a:ext cx="10789920" cy="731520"/>
+            <a:ext cx="10789920" cy="548640"/>
           </a:xfrm>
           <a:prstGeom prst="rect">
             <a:avLst/>
@@ -3873,13 +4058,13 @@
             <a:pPr>
               <a:defRPr sz="1300">
                 <a:solidFill>
-                  <a:srgbClr val="F8FAFC"/>
-                </a:solidFill>
-                <a:latin typeface="Microsoft JhengHei"/>
-              </a:defRPr>
-            </a:pPr>
-            <a:r>
-              <a:t>平台採取「前端託管 + Serverless API 後端 + Google Sheet 資料庫」之現代輕量化架構，不向前端暴露 API 金鑰，且能抵禦跨網域 (CORS) 阻擋。</a:t>
+                  <a:srgbClr val="0F172A"/>
+                </a:solidFill>
+                <a:latin typeface="Microsoft JhengHei"/>
+              </a:defRPr>
+            </a:pPr>
+            <a:r>
+              <a:t>平台採取「前端託管 + Serverless API 後端 + Google Sheet 雲端資料庫」之現代架構，保障 API 安全性，並徹底解決跨網域 (CORS) 阻擋。</a:t>
             </a:r>
           </a:p>
         </p:txBody>
@@ -3892,18 +4077,18 @@
         </p:nvSpPr>
         <p:spPr>
           <a:xfrm>
-            <a:off x="685800" y="2377440"/>
-            <a:ext cx="2468880" cy="3474720"/>
+            <a:off x="746150" y="2286000"/>
+            <a:ext cx="2468880" cy="3657600"/>
           </a:xfrm>
           <a:prstGeom prst="rect">
             <a:avLst/>
           </a:prstGeom>
           <a:solidFill>
-            <a:srgbClr val="151D3B"/>
+            <a:srgbClr val="FFFFFF"/>
           </a:solidFill>
           <a:ln w="19050">
             <a:solidFill>
-              <a:srgbClr val="0EA5E9"/>
+              <a:srgbClr val="0284C7"/>
             </a:solidFill>
           </a:ln>
         </p:spPr>
@@ -3937,8 +4122,8 @@
         </p:nvSpPr>
         <p:spPr>
           <a:xfrm>
-            <a:off x="822960" y="2560320"/>
-            <a:ext cx="2194560" cy="3108960"/>
+            <a:off x="883310" y="2468880"/>
+            <a:ext cx="2194560" cy="3291840"/>
           </a:xfrm>
           <a:prstGeom prst="rect">
             <a:avLst/>
@@ -3953,11 +4138,11 @@
           <a:p>
             <a:pPr>
               <a:spcAft>
-                <a:spcPts val="500"/>
-              </a:spcAft>
-              <a:defRPr sz="1600" b="1">
-                <a:solidFill>
-                  <a:srgbClr val="0EA5E9"/>
+                <a:spcPts val="400"/>
+              </a:spcAft>
+              <a:defRPr sz="1500" b="1">
+                <a:solidFill>
+                  <a:srgbClr val="0284C7"/>
                 </a:solidFill>
                 <a:latin typeface="Microsoft JhengHei"/>
               </a:defRPr>
@@ -3969,11 +4154,11 @@
           <a:p>
             <a:pPr>
               <a:spcAft>
-                <a:spcPts val="1500"/>
+                <a:spcPts val="1200"/>
               </a:spcAft>
               <a:defRPr sz="1100" b="1">
                 <a:solidFill>
-                  <a:srgbClr val="F8FAFC"/>
+                  <a:srgbClr val="0F172A"/>
                 </a:solidFill>
                 <a:latin typeface="Microsoft JhengHei"/>
               </a:defRPr>
@@ -3987,15 +4172,15 @@
               <a:lnSpc>
                 <a:spcPct val="130000"/>
               </a:lnSpc>
-              <a:defRPr sz="1150">
-                <a:solidFill>
-                  <a:srgbClr val="94A3B8"/>
-                </a:solidFill>
-                <a:latin typeface="Microsoft JhengHei"/>
-              </a:defRPr>
-            </a:pPr>
-            <a:r>
-              <a:t>以相對路徑整合 HTML5 / CSS3 / Vanilla JS 引擎，靜態網頁可極速加載，無伺服器維護成本。</a:t>
+              <a:defRPr sz="1100">
+                <a:solidFill>
+                  <a:srgbClr val="475569"/>
+                </a:solidFill>
+                <a:latin typeface="Microsoft JhengHei"/>
+              </a:defRPr>
+            </a:pPr>
+            <a:r>
+              <a:t>以相對路徑整合 HTML5 / CSS3 / JS，靜態資源極速載入，免除伺服器維護成本與負載問題。</a:t>
             </a:r>
           </a:p>
         </p:txBody>
@@ -4008,18 +4193,18 @@
         </p:nvSpPr>
         <p:spPr>
           <a:xfrm>
-            <a:off x="3429000" y="2377440"/>
-            <a:ext cx="2468880" cy="3474720"/>
+            <a:off x="3489350" y="2286000"/>
+            <a:ext cx="2468880" cy="3657600"/>
           </a:xfrm>
           <a:prstGeom prst="rect">
             <a:avLst/>
           </a:prstGeom>
           <a:solidFill>
-            <a:srgbClr val="151D3B"/>
+            <a:srgbClr val="FFFFFF"/>
           </a:solidFill>
           <a:ln w="19050">
             <a:solidFill>
-              <a:srgbClr val="A855F7"/>
+              <a:srgbClr val="7E22CE"/>
             </a:solidFill>
           </a:ln>
         </p:spPr>
@@ -4053,8 +4238,8 @@
         </p:nvSpPr>
         <p:spPr>
           <a:xfrm>
-            <a:off x="3566160" y="2560320"/>
-            <a:ext cx="2194560" cy="3108960"/>
+            <a:off x="3626510" y="2468880"/>
+            <a:ext cx="2194560" cy="3291840"/>
           </a:xfrm>
           <a:prstGeom prst="rect">
             <a:avLst/>
@@ -4069,11 +4254,11 @@
           <a:p>
             <a:pPr>
               <a:spcAft>
-                <a:spcPts val="500"/>
-              </a:spcAft>
-              <a:defRPr sz="1600" b="1">
-                <a:solidFill>
-                  <a:srgbClr val="A855F7"/>
+                <a:spcPts val="400"/>
+              </a:spcAft>
+              <a:defRPr sz="1500" b="1">
+                <a:solidFill>
+                  <a:srgbClr val="7E22CE"/>
                 </a:solidFill>
                 <a:latin typeface="Microsoft JhengHei"/>
               </a:defRPr>
@@ -4085,17 +4270,17 @@
           <a:p>
             <a:pPr>
               <a:spcAft>
-                <a:spcPts val="1500"/>
+                <a:spcPts val="1200"/>
               </a:spcAft>
               <a:defRPr sz="1100" b="1">
                 <a:solidFill>
-                  <a:srgbClr val="F8FAFC"/>
-                </a:solidFill>
-                <a:latin typeface="Microsoft JhengHei"/>
-              </a:defRPr>
-            </a:pPr>
-            <a:r>
-              <a:t>HTTPS POST (No-CORS)</a:t>
+                  <a:srgbClr val="0F172A"/>
+                </a:solidFill>
+                <a:latin typeface="Microsoft JhengHei"/>
+              </a:defRPr>
+            </a:pPr>
+            <a:r>
+              <a:t>HTTPS POST (no-cors)</a:t>
             </a:r>
           </a:p>
           <a:p>
@@ -4103,15 +4288,15 @@
               <a:lnSpc>
                 <a:spcPct val="130000"/>
               </a:lnSpc>
-              <a:defRPr sz="1150">
-                <a:solidFill>
-                  <a:srgbClr val="94A3B8"/>
-                </a:solidFill>
-                <a:latin typeface="Microsoft JhengHei"/>
-              </a:defRPr>
-            </a:pPr>
-            <a:r>
-              <a:t>前端 ConfigManager 將簡報反思與遊戲得分封裝為 JSON，使用 no-cors 模式發送至 GAS，免除 pre-flight 阻擋。</a:t>
+              <a:defRPr sz="1100">
+                <a:solidFill>
+                  <a:srgbClr val="475569"/>
+                </a:solidFill>
+                <a:latin typeface="Microsoft JhengHei"/>
+              </a:defRPr>
+            </a:pPr>
+            <a:r>
+              <a:t>ConfigManager 將數據打包為 JSON，使用 no-cors 模式發送，避免瀏覽器 Pre-flight OPTIONS 安全阻擋。</a:t>
             </a:r>
           </a:p>
         </p:txBody>
@@ -4124,18 +4309,18 @@
         </p:nvSpPr>
         <p:spPr>
           <a:xfrm>
-            <a:off x="6172200" y="2377440"/>
-            <a:ext cx="2468880" cy="3474720"/>
+            <a:off x="6232550" y="2286000"/>
+            <a:ext cx="2468880" cy="3657600"/>
           </a:xfrm>
           <a:prstGeom prst="rect">
             <a:avLst/>
           </a:prstGeom>
           <a:solidFill>
-            <a:srgbClr val="151D3B"/>
+            <a:srgbClr val="FFFFFF"/>
           </a:solidFill>
           <a:ln w="19050">
             <a:solidFill>
-              <a:srgbClr val="0EA5E9"/>
+              <a:srgbClr val="0284C7"/>
             </a:solidFill>
           </a:ln>
         </p:spPr>
@@ -4169,8 +4354,8 @@
         </p:nvSpPr>
         <p:spPr>
           <a:xfrm>
-            <a:off x="6309360" y="2560320"/>
-            <a:ext cx="2194560" cy="3108960"/>
+            <a:off x="6369710" y="2468880"/>
+            <a:ext cx="2194560" cy="3291840"/>
           </a:xfrm>
           <a:prstGeom prst="rect">
             <a:avLst/>
@@ -4185,11 +4370,11 @@
           <a:p>
             <a:pPr>
               <a:spcAft>
-                <a:spcPts val="500"/>
-              </a:spcAft>
-              <a:defRPr sz="1600" b="1">
-                <a:solidFill>
-                  <a:srgbClr val="0EA5E9"/>
+                <a:spcPts val="400"/>
+              </a:spcAft>
+              <a:defRPr sz="1500" b="1">
+                <a:solidFill>
+                  <a:srgbClr val="0284C7"/>
                 </a:solidFill>
                 <a:latin typeface="Microsoft JhengHei"/>
               </a:defRPr>
@@ -4201,11 +4386,11 @@
           <a:p>
             <a:pPr>
               <a:spcAft>
-                <a:spcPts val="1500"/>
+                <a:spcPts val="1200"/>
               </a:spcAft>
               <a:defRPr sz="1100" b="1">
                 <a:solidFill>
-                  <a:srgbClr val="F8FAFC"/>
+                  <a:srgbClr val="0F172A"/>
                 </a:solidFill>
                 <a:latin typeface="Microsoft JhengHei"/>
               </a:defRPr>
@@ -4219,15 +4404,15 @@
               <a:lnSpc>
                 <a:spcPct val="130000"/>
               </a:lnSpc>
-              <a:defRPr sz="1150">
-                <a:solidFill>
-                  <a:srgbClr val="94A3B8"/>
-                </a:solidFill>
-                <a:latin typeface="Microsoft JhengHei"/>
-              </a:defRPr>
-            </a:pPr>
-            <a:r>
-              <a:t>執行部署為 Web App 的 Code.gs 腳本，以「版主帳號執行」身分取得 Sheets 寫入權限，安全隔離金鑰。</a:t>
+              <a:defRPr sz="1100">
+                <a:solidFill>
+                  <a:srgbClr val="475569"/>
+                </a:solidFill>
+                <a:latin typeface="Microsoft JhengHei"/>
+              </a:defRPr>
+            </a:pPr>
+            <a:r>
+              <a:t>執行部署為 Web App 的 Code.gs，以「版主帳號執行」權限寫入 Sheet，保護 API 金鑰不外洩。</a:t>
             </a:r>
           </a:p>
         </p:txBody>
@@ -4240,18 +4425,18 @@
         </p:nvSpPr>
         <p:spPr>
           <a:xfrm>
-            <a:off x="8915400" y="2377440"/>
-            <a:ext cx="2468880" cy="3474720"/>
+            <a:off x="8975750" y="2286000"/>
+            <a:ext cx="2468880" cy="3657600"/>
           </a:xfrm>
           <a:prstGeom prst="rect">
             <a:avLst/>
           </a:prstGeom>
           <a:solidFill>
-            <a:srgbClr val="151D3B"/>
+            <a:srgbClr val="FFFFFF"/>
           </a:solidFill>
           <a:ln w="19050">
             <a:solidFill>
-              <a:srgbClr val="A855F7"/>
+              <a:srgbClr val="7E22CE"/>
             </a:solidFill>
           </a:ln>
         </p:spPr>
@@ -4285,8 +4470,8 @@
         </p:nvSpPr>
         <p:spPr>
           <a:xfrm>
-            <a:off x="9052560" y="2560320"/>
-            <a:ext cx="2194560" cy="3108960"/>
+            <a:off x="9112910" y="2468880"/>
+            <a:ext cx="2194560" cy="3291840"/>
           </a:xfrm>
           <a:prstGeom prst="rect">
             <a:avLst/>
@@ -4301,11 +4486,11 @@
           <a:p>
             <a:pPr>
               <a:spcAft>
-                <a:spcPts val="500"/>
-              </a:spcAft>
-              <a:defRPr sz="1600" b="1">
-                <a:solidFill>
-                  <a:srgbClr val="A855F7"/>
+                <a:spcPts val="400"/>
+              </a:spcAft>
+              <a:defRPr sz="1500" b="1">
+                <a:solidFill>
+                  <a:srgbClr val="7E22CE"/>
                 </a:solidFill>
                 <a:latin typeface="Microsoft JhengHei"/>
               </a:defRPr>
@@ -4317,11 +4502,11 @@
           <a:p>
             <a:pPr>
               <a:spcAft>
-                <a:spcPts val="1500"/>
+                <a:spcPts val="1200"/>
               </a:spcAft>
               <a:defRPr sz="1100" b="1">
                 <a:solidFill>
-                  <a:srgbClr val="F8FAFC"/>
+                  <a:srgbClr val="0F172A"/>
                 </a:solidFill>
                 <a:latin typeface="Microsoft JhengHei"/>
               </a:defRPr>
@@ -4335,15 +4520,15 @@
               <a:lnSpc>
                 <a:spcPct val="130000"/>
               </a:lnSpc>
-              <a:defRPr sz="1150">
-                <a:solidFill>
-                  <a:srgbClr val="94A3B8"/>
-                </a:solidFill>
-                <a:latin typeface="Microsoft JhengHei"/>
-              </a:defRPr>
-            </a:pPr>
-            <a:r>
-              <a:t>自動化新增分頁 slides_feedback 與 game_scores，提供自動表頭遷移與資料記錄列追增。</a:t>
+              <a:defRPr sz="1100">
+                <a:solidFill>
+                  <a:srgbClr val="475569"/>
+                </a:solidFill>
+                <a:latin typeface="Microsoft JhengHei"/>
+              </a:defRPr>
+            </a:pPr>
+            <a:r>
+              <a:t>自動新增 slides_feedback 與 game_scores 工作表，支援自動表頭遷移與防呆資料列追加。</a:t>
             </a:r>
           </a:p>
         </p:txBody>
@@ -4362,7 +4547,7 @@
     <p:bg>
       <p:bgPr>
         <a:solidFill>
-          <a:srgbClr val="0A0D1A"/>
+          <a:srgbClr val="F8FAFC"/>
         </a:solidFill>
         <a:effectLst/>
       </p:bgPr>
@@ -4399,13 +4584,13 @@
             <a:pPr>
               <a:defRPr sz="1000" b="1">
                 <a:solidFill>
-                  <a:srgbClr val="A855F7"/>
+                  <a:srgbClr val="7E22CE"/>
                 </a:solidFill>
                 <a:latin typeface="Arial"/>
               </a:defRPr>
             </a:pPr>
             <a:r>
-              <a:t>專案技術手冊</a:t>
+              <a:t>CRC 專案開發與後端串接手冊</a:t>
             </a:r>
           </a:p>
         </p:txBody>
@@ -4435,7 +4620,7 @@
             <a:pPr>
               <a:defRPr sz="2600" b="1">
                 <a:solidFill>
-                  <a:srgbClr val="F8FAFC"/>
+                  <a:srgbClr val="0F172A"/>
                 </a:solidFill>
                 <a:latin typeface="Microsoft JhengHei"/>
               </a:defRPr>
@@ -4461,7 +4646,7 @@
             <a:avLst/>
           </a:prstGeom>
           <a:solidFill>
-            <a:srgbClr val="334155"/>
+            <a:srgbClr val="E2E8F0"/>
           </a:solidFill>
           <a:ln>
             <a:noFill/>
@@ -4498,17 +4683,17 @@
         <p:spPr>
           <a:xfrm>
             <a:off x="685800" y="1645920"/>
-            <a:ext cx="5303520" cy="4389120"/>
+            <a:ext cx="5303520" cy="4480560"/>
           </a:xfrm>
           <a:prstGeom prst="rect">
             <a:avLst/>
           </a:prstGeom>
           <a:solidFill>
-            <a:srgbClr val="151D3B"/>
+            <a:srgbClr val="FFFFFF"/>
           </a:solidFill>
           <a:ln w="19050">
             <a:solidFill>
-              <a:srgbClr val="0EA5E9"/>
+              <a:srgbClr val="0284C7"/>
             </a:solidFill>
           </a:ln>
         </p:spPr>
@@ -4542,8 +4727,8 @@
         </p:nvSpPr>
         <p:spPr>
           <a:xfrm>
-            <a:off x="1005840" y="1920240"/>
-            <a:ext cx="4663440" cy="3840480"/>
+            <a:off x="960120" y="1828800"/>
+            <a:ext cx="4754880" cy="4114800"/>
           </a:xfrm>
           <a:prstGeom prst="rect">
             <a:avLst/>
@@ -4558,11 +4743,11 @@
           <a:p>
             <a:pPr>
               <a:spcAft>
-                <a:spcPts val="1500"/>
+                <a:spcPts val="1200"/>
               </a:spcAft>
               <a:defRPr sz="1800" b="1">
                 <a:solidFill>
-                  <a:srgbClr val="0EA5E9"/>
+                  <a:srgbClr val="0284C7"/>
                 </a:solidFill>
                 <a:latin typeface="Microsoft JhengHei"/>
               </a:defRPr>
@@ -4574,129 +4759,129 @@
           <a:p>
             <a:pPr>
               <a:spcAft>
-                <a:spcPts val="200"/>
+                <a:spcPts val="100"/>
               </a:spcAft>
               <a:defRPr sz="1300" b="1">
                 <a:solidFill>
-                  <a:srgbClr val="F8FAFC"/>
-                </a:solidFill>
-                <a:latin typeface="Microsoft JhengHei"/>
-              </a:defRPr>
-            </a:pPr>
-            <a:r>
-              <a:t>✔ 嵌入式 Reveal.js 實作</a:t>
-            </a:r>
-          </a:p>
-          <a:p>
-            <a:pPr>
-              <a:spcAft>
-                <a:spcPts val="1000"/>
+                  <a:srgbClr val="0F172A"/>
+                </a:solidFill>
+                <a:latin typeface="Microsoft JhengHei"/>
+              </a:defRPr>
+            </a:pPr>
+            <a:r>
+              <a:t>✔ 嵌入式 Reveal.js 簡報框架</a:t>
+            </a:r>
+          </a:p>
+          <a:p>
+            <a:pPr>
+              <a:spcAft>
+                <a:spcPts val="800"/>
               </a:spcAft>
               <a:defRPr sz="1100">
                 <a:solidFill>
-                  <a:srgbClr val="94A3B8"/>
-                </a:solidFill>
-                <a:latin typeface="Microsoft JhengHei"/>
-              </a:defRPr>
-            </a:pPr>
-            <a:r>
-              <a:t>   將簡報初始化設為 `embedded: true`，使其精準限縮於右側展示視窗內，保留左側導覽排版。</a:t>
-            </a:r>
-          </a:p>
-          <a:p>
-            <a:pPr>
-              <a:spcAft>
-                <a:spcPts val="200"/>
+                  <a:srgbClr val="475569"/>
+                </a:solidFill>
+                <a:latin typeface="Microsoft JhengHei"/>
+              </a:defRPr>
+            </a:pPr>
+            <a:r>
+              <a:t>   將簡報初始化參數 `embedded` 設為 `true`，精準限制在右側展示視窗內，留出左側固定排版。</a:t>
+            </a:r>
+          </a:p>
+          <a:p>
+            <a:pPr>
+              <a:spcAft>
+                <a:spcPts val="100"/>
               </a:spcAft>
               <a:defRPr sz="1300" b="1">
                 <a:solidFill>
-                  <a:srgbClr val="F8FAFC"/>
-                </a:solidFill>
-                <a:latin typeface="Microsoft JhengHei"/>
-              </a:defRPr>
-            </a:pPr>
-            <a:r>
-              <a:t>✔ 左側目錄與雙向同步</a:t>
-            </a:r>
-          </a:p>
-          <a:p>
-            <a:pPr>
-              <a:spcAft>
-                <a:spcPts val="1000"/>
+                  <a:srgbClr val="0F172A"/>
+                </a:solidFill>
+                <a:latin typeface="Microsoft JhengHei"/>
+              </a:defRPr>
+            </a:pPr>
+            <a:r>
+              <a:t>✔ 左側同步導覽目錄實作</a:t>
+            </a:r>
+          </a:p>
+          <a:p>
+            <a:pPr>
+              <a:spcAft>
+                <a:spcPts val="800"/>
               </a:spcAft>
               <a:defRPr sz="1100">
                 <a:solidFill>
-                  <a:srgbClr val="94A3B8"/>
-                </a:solidFill>
-                <a:latin typeface="Microsoft JhengHei"/>
-              </a:defRPr>
-            </a:pPr>
-            <a:r>
-              <a:t>   使用 Vanilla JS 歷遍 50 頁 section 提取標題，動態生成左側 TOC 目錄；翻頁時自動滾動並高亮對應項目。</a:t>
-            </a:r>
-          </a:p>
-          <a:p>
-            <a:pPr>
-              <a:spcAft>
-                <a:spcPts val="200"/>
+                  <a:srgbClr val="475569"/>
+                </a:solidFill>
+                <a:latin typeface="Microsoft JhengHei"/>
+              </a:defRPr>
+            </a:pPr>
+            <a:r>
+              <a:t>   利用 JS 歷遍 50 頁 section 標題動態生成左側 TOC。綁定 slidechanged 事件，自動高亮與滾動目錄。</a:t>
+            </a:r>
+          </a:p>
+          <a:p>
+            <a:pPr>
+              <a:spcAft>
+                <a:spcPts val="100"/>
               </a:spcAft>
               <a:defRPr sz="1300" b="1">
                 <a:solidFill>
-                  <a:srgbClr val="F8FAFC"/>
-                </a:solidFill>
-                <a:latin typeface="Microsoft JhengHei"/>
-              </a:defRPr>
-            </a:pPr>
-            <a:r>
-              <a:t>✔ 學生身份驗證鎖定</a:t>
-            </a:r>
-          </a:p>
-          <a:p>
-            <a:pPr>
-              <a:spcAft>
-                <a:spcPts val="1000"/>
+                  <a:srgbClr val="0F172A"/>
+                </a:solidFill>
+                <a:latin typeface="Microsoft JhengHei"/>
+              </a:defRPr>
+            </a:pPr>
+            <a:r>
+              <a:t>✔ 身份登錄防跳過機制</a:t>
+            </a:r>
+          </a:p>
+          <a:p>
+            <a:pPr>
+              <a:spcAft>
+                <a:spcPts val="800"/>
               </a:spcAft>
               <a:defRPr sz="1100">
                 <a:solidFill>
-                  <a:srgbClr val="94A3B8"/>
-                </a:solidFill>
-                <a:latin typeface="Microsoft JhengHei"/>
-              </a:defRPr>
-            </a:pPr>
-            <a:r>
-              <a:t>   簡報開啟時彈出 Glassmorphism 遮罩，強制輸入姓名及系級。未登錄前鎖定鍵盤翻頁，資料儲存於 sessionStorage 中。</a:t>
-            </a:r>
-          </a:p>
-          <a:p>
-            <a:pPr>
-              <a:spcAft>
-                <a:spcPts val="200"/>
+                  <a:srgbClr val="475569"/>
+                </a:solidFill>
+                <a:latin typeface="Microsoft JhengHei"/>
+              </a:defRPr>
+            </a:pPr>
+            <a:r>
+              <a:t>   開頁彈出 Glassmorphism 登錄框，強制輸入姓名系級。未登錄前鎖定鍵盤，並將個資存於 sessionStorage。</a:t>
+            </a:r>
+          </a:p>
+          <a:p>
+            <a:pPr>
+              <a:spcAft>
+                <a:spcPts val="100"/>
               </a:spcAft>
               <a:defRPr sz="1300" b="1">
                 <a:solidFill>
-                  <a:srgbClr val="F8FAFC"/>
-                </a:solidFill>
-                <a:latin typeface="Microsoft JhengHei"/>
-              </a:defRPr>
-            </a:pPr>
-            <a:r>
-              <a:t>✔ 素養討論題目標記</a:t>
-            </a:r>
-          </a:p>
-          <a:p>
-            <a:pPr>
-              <a:spcAft>
-                <a:spcPts val="1000"/>
+                  <a:srgbClr val="0F172A"/>
+                </a:solidFill>
+                <a:latin typeface="Microsoft JhengHei"/>
+              </a:defRPr>
+            </a:pPr>
+            <a:r>
+              <a:t>✔ 討論題 no-cors 即時寫入</a:t>
+            </a:r>
+          </a:p>
+          <a:p>
+            <a:pPr>
+              <a:spcAft>
+                <a:spcPts val="800"/>
               </a:spcAft>
               <a:defRPr sz="1100">
                 <a:solidFill>
-                  <a:srgbClr val="94A3B8"/>
-                </a:solidFill>
-                <a:latin typeface="Microsoft JhengHei"/>
-              </a:defRPr>
-            </a:pPr>
-            <a:r>
-              <a:t>   六大討論框重新包裝為『素養討論一』至『六』。學生點擊送出後，夾帶登錄的身份資料以 no-cors 模式傳送至 Sheet。</a:t>
+                  <a:srgbClr val="475569"/>
+                </a:solidFill>
+                <a:latin typeface="Microsoft JhengHei"/>
+              </a:defRPr>
+            </a:pPr>
+            <a:r>
+              <a:t>   六道討論題打包為『素養討論一~六』。學生點擊送出即自動組合個資傳送至 Sheet 進行寫入。</a:t>
             </a:r>
           </a:p>
         </p:txBody>
@@ -4710,17 +4895,17 @@
         <p:spPr>
           <a:xfrm>
             <a:off x="6217920" y="1645920"/>
-            <a:ext cx="5257800" cy="4389120"/>
+            <a:ext cx="5257800" cy="4480560"/>
           </a:xfrm>
           <a:prstGeom prst="rect">
             <a:avLst/>
           </a:prstGeom>
           <a:solidFill>
-            <a:srgbClr val="151D3B"/>
+            <a:srgbClr val="0F172A"/>
           </a:solidFill>
           <a:ln w="19050">
             <a:solidFill>
-              <a:srgbClr val="334155"/>
+              <a:srgbClr val="1E293B"/>
             </a:solidFill>
           </a:ln>
         </p:spPr>
@@ -4755,7 +4940,7 @@
         <p:spPr>
           <a:xfrm>
             <a:off x="6492240" y="1920240"/>
-            <a:ext cx="4709160" cy="3840480"/>
+            <a:ext cx="4709160" cy="3931920"/>
           </a:xfrm>
           <a:prstGeom prst="rect">
             <a:avLst/>
@@ -4772,11 +4957,11 @@
               <a:spcAft>
                 <a:spcPts val="1000"/>
               </a:spcAft>
-              <a:defRPr sz="1500" b="1">
-                <a:solidFill>
-                  <a:srgbClr val="F8FAFC"/>
-                </a:solidFill>
-                <a:latin typeface="Microsoft JhengHei"/>
+              <a:defRPr sz="1400" b="1">
+                <a:solidFill>
+                  <a:srgbClr val="FFFFFF"/>
+                </a:solidFill>
+                <a:latin typeface="Consolas"/>
               </a:defRPr>
             </a:pPr>
             <a:r>
@@ -4786,25 +4971,54 @@
           <a:p>
             <a:pPr>
               <a:spcAft>
-                <a:spcPts val="300"/>
-              </a:spcAft>
-              <a:defRPr sz="1050">
-                <a:solidFill>
-                  <a:srgbClr val="0EA5E9"/>
+                <a:spcPts val="200"/>
+              </a:spcAft>
+              <a:defRPr sz="1000">
+                <a:solidFill>
+                  <a:srgbClr val="94A3B8"/>
                 </a:solidFill>
                 <a:latin typeface="Consolas"/>
               </a:defRPr>
             </a:pPr>
             <a:r>
-              <a:t>// 1. 初始化嵌入簡報</a:t>
-            </a:r>
-          </a:p>
-          <a:p>
-            <a:pPr>
-              <a:spcAft>
-                <a:spcPts val="300"/>
-              </a:spcAft>
-              <a:defRPr sz="1050">
+              <a:t>// 1. 初始化 Reveal.js 嵌入簡報</a:t>
+            </a:r>
+          </a:p>
+          <a:p>
+            <a:pPr>
+              <a:spcAft>
+                <a:spcPts val="200"/>
+              </a:spcAft>
+              <a:defRPr sz="1000">
+                <a:solidFill>
+                  <a:srgbClr val="E2E8F0"/>
+                </a:solidFill>
+                <a:latin typeface="Consolas"/>
+              </a:defRPr>
+            </a:pPr>
+            <a:r>
+              <a:t>Reveal.initialize({ embedded: true, controls: true });</a:t>
+            </a:r>
+          </a:p>
+          <a:p>
+            <a:pPr>
+              <a:spcAft>
+                <a:spcPts val="200"/>
+              </a:spcAft>
+              <a:defRPr sz="1000">
+                <a:solidFill>
+                  <a:srgbClr val="E2E8F0"/>
+                </a:solidFill>
+                <a:latin typeface="Consolas"/>
+              </a:defRPr>
+            </a:pPr>
+          </a:p>
+          <a:p>
+            <a:pPr>
+              <a:spcAft>
+                <a:spcPts val="200"/>
+              </a:spcAft>
+              <a:defRPr sz="1000">
                 <a:solidFill>
                   <a:srgbClr val="94A3B8"/>
                 </a:solidFill>
@@ -4812,44 +5026,92 @@
               </a:defRPr>
             </a:pPr>
             <a:r>
-              <a:t>Reveal.initialize({ embedded: true, controls: true });</a:t>
-            </a:r>
-          </a:p>
-          <a:p>
-            <a:pPr>
-              <a:spcAft>
-                <a:spcPts val="300"/>
-              </a:spcAft>
-              <a:defRPr sz="1050">
+              <a:t>// 2. 身份登錄控制與 Session 鎖定</a:t>
+            </a:r>
+          </a:p>
+          <a:p>
+            <a:pPr>
+              <a:spcAft>
+                <a:spcPts val="200"/>
+              </a:spcAft>
+              <a:defRPr sz="1000">
+                <a:solidFill>
+                  <a:srgbClr val="E2E8F0"/>
+                </a:solidFill>
+                <a:latin typeface="Consolas"/>
+              </a:defRPr>
+            </a:pPr>
+            <a:r>
+              <a:t>function closeAuthModal(name, dept) {</a:t>
+            </a:r>
+          </a:p>
+          <a:p>
+            <a:pPr>
+              <a:spcAft>
+                <a:spcPts val="200"/>
+              </a:spcAft>
+              <a:defRPr sz="1000">
+                <a:solidFill>
+                  <a:srgbClr val="E2E8F0"/>
+                </a:solidFill>
+                <a:latin typeface="Consolas"/>
+              </a:defRPr>
+            </a:pPr>
+            <a:r>
+              <a:t>  sessionStorage.setItem('name', name);</a:t>
+            </a:r>
+          </a:p>
+          <a:p>
+            <a:pPr>
+              <a:spcAft>
+                <a:spcPts val="200"/>
+              </a:spcAft>
+              <a:defRPr sz="1000">
                 <a:solidFill>
                   <a:srgbClr val="94A3B8"/>
                 </a:solidFill>
                 <a:latin typeface="Consolas"/>
               </a:defRPr>
             </a:pPr>
-          </a:p>
-          <a:p>
-            <a:pPr>
-              <a:spcAft>
-                <a:spcPts val="300"/>
-              </a:spcAft>
-              <a:defRPr sz="1050">
-                <a:solidFill>
-                  <a:srgbClr val="0EA5E9"/>
+            <a:r>
+              <a:t>  Reveal.configure({ keyboard: true }); // 解鎖鍵盤</a:t>
+            </a:r>
+          </a:p>
+          <a:p>
+            <a:pPr>
+              <a:spcAft>
+                <a:spcPts val="200"/>
+              </a:spcAft>
+              <a:defRPr sz="1000">
+                <a:solidFill>
+                  <a:srgbClr val="E2E8F0"/>
                 </a:solidFill>
                 <a:latin typeface="Consolas"/>
               </a:defRPr>
             </a:pPr>
             <a:r>
-              <a:t>// 2. 身份登錄控制與 Session 鎖定</a:t>
-            </a:r>
-          </a:p>
-          <a:p>
-            <a:pPr>
-              <a:spcAft>
-                <a:spcPts val="300"/>
-              </a:spcAft>
-              <a:defRPr sz="1050">
+              <a:t>}</a:t>
+            </a:r>
+          </a:p>
+          <a:p>
+            <a:pPr>
+              <a:spcAft>
+                <a:spcPts val="200"/>
+              </a:spcAft>
+              <a:defRPr sz="1000">
+                <a:solidFill>
+                  <a:srgbClr val="E2E8F0"/>
+                </a:solidFill>
+                <a:latin typeface="Consolas"/>
+              </a:defRPr>
+            </a:pPr>
+          </a:p>
+          <a:p>
+            <a:pPr>
+              <a:spcAft>
+                <a:spcPts val="200"/>
+              </a:spcAft>
+              <a:defRPr sz="1000">
                 <a:solidFill>
                   <a:srgbClr val="94A3B8"/>
                 </a:solidFill>
@@ -4857,126 +5119,49 @@
               </a:defRPr>
             </a:pPr>
             <a:r>
-              <a:t>function closeAuthModal(name, dept) {</a:t>
-            </a:r>
-          </a:p>
-          <a:p>
-            <a:pPr>
-              <a:spcAft>
-                <a:spcPts val="300"/>
-              </a:spcAft>
-              <a:defRPr sz="1050">
-                <a:solidFill>
-                  <a:srgbClr val="94A3B8"/>
+              <a:t>// 3. 簡報反思資料 no-cors 傳送</a:t>
+            </a:r>
+          </a:p>
+          <a:p>
+            <a:pPr>
+              <a:spcAft>
+                <a:spcPts val="200"/>
+              </a:spcAft>
+              <a:defRPr sz="1000">
+                <a:solidFill>
+                  <a:srgbClr val="E2E8F0"/>
                 </a:solidFill>
                 <a:latin typeface="Consolas"/>
               </a:defRPr>
             </a:pPr>
             <a:r>
-              <a:t>  sessionStorage.setItem('name', name);</a:t>
-            </a:r>
-          </a:p>
-          <a:p>
-            <a:pPr>
-              <a:spcAft>
-                <a:spcPts val="300"/>
-              </a:spcAft>
-              <a:defRPr sz="1050">
-                <a:solidFill>
-                  <a:srgbClr val="94A3B8"/>
+              <a:t>const payload = { PlayerName: name, Department: dept,</a:t>
+            </a:r>
+          </a:p>
+          <a:p>
+            <a:pPr>
+              <a:spcAft>
+                <a:spcPts val="200"/>
+              </a:spcAft>
+              <a:defRPr sz="1000">
+                <a:solidFill>
+                  <a:srgbClr val="E2E8F0"/>
                 </a:solidFill>
                 <a:latin typeface="Consolas"/>
               </a:defRPr>
             </a:pPr>
             <a:r>
-              <a:t>  Reveal.configure({ keyboard: true }); // 解鎖鍵盤</a:t>
-            </a:r>
-          </a:p>
-          <a:p>
-            <a:pPr>
-              <a:spcAft>
-                <a:spcPts val="300"/>
-              </a:spcAft>
-              <a:defRPr sz="1050">
-                <a:solidFill>
-                  <a:srgbClr val="94A3B8"/>
-                </a:solidFill>
-                <a:latin typeface="Consolas"/>
-              </a:defRPr>
-            </a:pPr>
-            <a:r>
-              <a:t>}</a:t>
-            </a:r>
-          </a:p>
-          <a:p>
-            <a:pPr>
-              <a:spcAft>
-                <a:spcPts val="300"/>
-              </a:spcAft>
-              <a:defRPr sz="1050">
-                <a:solidFill>
-                  <a:srgbClr val="94A3B8"/>
-                </a:solidFill>
-                <a:latin typeface="Consolas"/>
-              </a:defRPr>
-            </a:pPr>
-          </a:p>
-          <a:p>
-            <a:pPr>
-              <a:spcAft>
-                <a:spcPts val="300"/>
-              </a:spcAft>
-              <a:defRPr sz="1050">
-                <a:solidFill>
-                  <a:srgbClr val="0EA5E9"/>
-                </a:solidFill>
-                <a:latin typeface="Consolas"/>
-              </a:defRPr>
-            </a:pPr>
-            <a:r>
-              <a:t>// 3. 簡報反思資料封裝傳送</a:t>
-            </a:r>
-          </a:p>
-          <a:p>
-            <a:pPr>
-              <a:spcAft>
-                <a:spcPts val="300"/>
-              </a:spcAft>
-              <a:defRPr sz="1050">
-                <a:solidFill>
-                  <a:srgbClr val="94A3B8"/>
-                </a:solidFill>
-                <a:latin typeface="Consolas"/>
-              </a:defRPr>
-            </a:pPr>
-            <a:r>
-              <a:t>const payload = { PlayerName: name, Department: dept,</a:t>
-            </a:r>
-          </a:p>
-          <a:p>
-            <a:pPr>
-              <a:spcAft>
-                <a:spcPts val="300"/>
-              </a:spcAft>
-              <a:defRPr sz="1050">
-                <a:solidFill>
-                  <a:srgbClr val="94A3B8"/>
-                </a:solidFill>
-                <a:latin typeface="Consolas"/>
-              </a:defRPr>
-            </a:pPr>
-            <a:r>
               <a:t>  SlideNumber: num, ResponseText: text };</a:t>
             </a:r>
           </a:p>
           <a:p>
             <a:pPr>
               <a:spcAft>
-                <a:spcPts val="300"/>
-              </a:spcAft>
-              <a:defRPr sz="1050">
-                <a:solidFill>
-                  <a:srgbClr val="94A3B8"/>
+                <a:spcPts val="200"/>
+              </a:spcAft>
+              <a:defRPr sz="1000">
+                <a:solidFill>
+                  <a:srgbClr val="C084FC"/>
                 </a:solidFill>
                 <a:latin typeface="Consolas"/>
               </a:defRPr>
@@ -5001,7 +5186,7 @@
     <p:bg>
       <p:bgPr>
         <a:solidFill>
-          <a:srgbClr val="0A0D1A"/>
+          <a:srgbClr val="F8FAFC"/>
         </a:solidFill>
         <a:effectLst/>
       </p:bgPr>
@@ -5038,13 +5223,13 @@
             <a:pPr>
               <a:defRPr sz="1000" b="1">
                 <a:solidFill>
-                  <a:srgbClr val="A855F7"/>
+                  <a:srgbClr val="7E22CE"/>
                 </a:solidFill>
                 <a:latin typeface="Arial"/>
               </a:defRPr>
             </a:pPr>
             <a:r>
-              <a:t>專案技術手冊</a:t>
+              <a:t>CRC 專案開發與後端串接手冊</a:t>
             </a:r>
           </a:p>
         </p:txBody>
@@ -5074,7 +5259,7 @@
             <a:pPr>
               <a:defRPr sz="2600" b="1">
                 <a:solidFill>
-                  <a:srgbClr val="F8FAFC"/>
+                  <a:srgbClr val="0F172A"/>
                 </a:solidFill>
                 <a:latin typeface="Microsoft JhengHei"/>
               </a:defRPr>
@@ -5100,7 +5285,7 @@
             <a:avLst/>
           </a:prstGeom>
           <a:solidFill>
-            <a:srgbClr val="334155"/>
+            <a:srgbClr val="E2E8F0"/>
           </a:solidFill>
           <a:ln>
             <a:noFill/>
@@ -5143,11 +5328,11 @@
             <a:avLst/>
           </a:prstGeom>
           <a:solidFill>
-            <a:srgbClr val="151D3B"/>
+            <a:srgbClr val="FFFFFF"/>
           </a:solidFill>
           <a:ln w="19050">
             <a:solidFill>
-              <a:srgbClr val="0EA5E9"/>
+              <a:srgbClr val="0284C7"/>
             </a:solidFill>
           </a:ln>
         </p:spPr>
@@ -5181,8 +5366,8 @@
         </p:nvSpPr>
         <p:spPr>
           <a:xfrm>
-            <a:off x="1051560" y="1828800"/>
-            <a:ext cx="10058400" cy="1828800"/>
+            <a:off x="960120" y="1828800"/>
+            <a:ext cx="10241280" cy="1828800"/>
           </a:xfrm>
           <a:prstGeom prst="rect">
             <a:avLst/>
@@ -5197,33 +5382,33 @@
           <a:p>
             <a:pPr>
               <a:spcAft>
-                <a:spcPts val="1000"/>
+                <a:spcPts val="800"/>
               </a:spcAft>
               <a:defRPr sz="1800" b="1">
                 <a:solidFill>
-                  <a:srgbClr val="0EA5E9"/>
-                </a:solidFill>
-                <a:latin typeface="Microsoft JhengHei"/>
-              </a:defRPr>
-            </a:pPr>
-            <a:r>
-              <a:t>🎨 雙層 z-index 遮罩與拖曳邏輯</a:t>
-            </a:r>
-          </a:p>
-          <a:p>
-            <a:pPr>
-              <a:spcAft>
-                <a:spcPts val="1000"/>
-              </a:spcAft>
-              <a:defRPr sz="1300">
-                <a:solidFill>
-                  <a:srgbClr val="F8FAFC"/>
-                </a:solidFill>
-                <a:latin typeface="Microsoft JhengHei"/>
-              </a:defRPr>
-            </a:pPr>
-            <a:r>
-              <a:t>位於簡報 P13。設計目標是向右拉動拉桿時，「沒有 CRC (威權校園)」覆蓋蓋住底層「有 CRC (人權校園)」的字體與內容。我們採用絕對定位與 overflow: hidden 技術實作剪裁效果：</a:t>
+                  <a:srgbClr val="0284C7"/>
+                </a:solidFill>
+                <a:latin typeface="Microsoft JhengHei"/>
+              </a:defRPr>
+            </a:pPr>
+            <a:r>
+              <a:t>🎨 雙層 z-index 遮罩與拖曳剪裁邏輯</a:t>
+            </a:r>
+          </a:p>
+          <a:p>
+            <a:pPr>
+              <a:spcAft>
+                <a:spcPts val="800"/>
+              </a:spcAft>
+              <a:defRPr sz="1250">
+                <a:solidFill>
+                  <a:srgbClr val="0F172A"/>
+                </a:solidFill>
+                <a:latin typeface="Microsoft JhengHei"/>
+              </a:defRPr>
+            </a:pPr>
+            <a:r>
+              <a:t>位於簡報第 13 頁。向右拉動拉桿時，「沒有 CRC (威權校園)」覆蓋蓋住底層「有 CRC (人權校園)」的畫面。我們使用絕對定位與剪裁寬度實作：</a:t>
             </a:r>
           </a:p>
           <a:p>
@@ -5231,23 +5416,23 @@
               <a:lnSpc>
                 <a:spcPct val="130000"/>
               </a:lnSpc>
-              <a:defRPr sz="1200">
-                <a:solidFill>
-                  <a:srgbClr val="94A3B8"/>
-                </a:solidFill>
-                <a:latin typeface="Microsoft JhengHei"/>
-              </a:defRPr>
-            </a:pPr>
-            <a:r>
-              <a:t>• 底層 (z-index 1)：有 CRC 面板 (after-panel)，滿寬 background 固定顯示於右側。</a:t>
+              <a:defRPr sz="1150">
+                <a:solidFill>
+                  <a:srgbClr val="475569"/>
+                </a:solidFill>
+                <a:latin typeface="Microsoft JhengHei"/>
+              </a:defRPr>
+            </a:pPr>
+            <a:r>
+              <a:t>• 底層 (z-index 1)：有 CRC 面板 (after-panel)，為基準定位，背景與排版固定於右側。</a:t>
             </a:r>
             <a:br/>
             <a:r>
-              <a:t>• 頂層 (z-index 2)：沒有 CRC 面板 (before-panel)，定位於左側，width 設為 percentage% 並設為 overflow: hidden 以防止內文折行。</a:t>
+              <a:t>• 頂層 (z-index 2)：沒有 CRC 面板 (before-panel)，定位於左側，width 設為 percentage% 並設為 overflow: hidden 防止折行。</a:t>
             </a:r>
             <a:br/>
             <a:r>
-              <a:t>• 拉桿 (z-index 10)：發光拖曳軸，點選後監聽 mousedown 與 touchstart 事件，即時更新 percentage 數值。</a:t>
+              <a:t>• 拉桿 (z-index 10)：發光拖曳軸，監聽 mousedown 與 touchstart 事件，實時計算滑鼠/手指 X 座標並更新百分比。</a:t>
             </a:r>
           </a:p>
         </p:txBody>
@@ -5267,11 +5452,11 @@
             <a:avLst/>
           </a:prstGeom>
           <a:solidFill>
-            <a:srgbClr val="151D3B"/>
+            <a:srgbClr val="0F172A"/>
           </a:solidFill>
           <a:ln w="19050">
             <a:solidFill>
-              <a:srgbClr val="334155"/>
+              <a:srgbClr val="1E293B"/>
             </a:solidFill>
           </a:ln>
         </p:spPr>
@@ -5305,8 +5490,8 @@
         </p:nvSpPr>
         <p:spPr>
           <a:xfrm>
-            <a:off x="1051560" y="4206240"/>
-            <a:ext cx="10058400" cy="1828800"/>
+            <a:off x="960120" y="4114800"/>
+            <a:ext cx="10241280" cy="2011680"/>
           </a:xfrm>
           <a:prstGeom prst="rect">
             <a:avLst/>
@@ -5321,25 +5506,73 @@
           <a:p>
             <a:pPr>
               <a:spcAft>
-                <a:spcPts val="800"/>
-              </a:spcAft>
-              <a:defRPr sz="1500" b="1">
-                <a:solidFill>
-                  <a:srgbClr val="F8FAFC"/>
-                </a:solidFill>
-                <a:latin typeface="Microsoft JhengHei"/>
-              </a:defRPr>
-            </a:pPr>
-            <a:r>
-              <a:t>💻 核心拖動計算代碼 (JavaScript)</a:t>
-            </a:r>
-          </a:p>
-          <a:p>
-            <a:pPr>
-              <a:lnSpc>
-                <a:spcPct val="125000"/>
-              </a:lnSpc>
-              <a:defRPr sz="1150">
+                <a:spcPts val="600"/>
+              </a:spcAft>
+              <a:defRPr sz="1400" b="1">
+                <a:solidFill>
+                  <a:srgbClr val="FFFFFF"/>
+                </a:solidFill>
+                <a:latin typeface="Consolas"/>
+              </a:defRPr>
+            </a:pPr>
+            <a:r>
+              <a:t>💻 核心拖動剪裁代碼 (JavaScript)</a:t>
+            </a:r>
+          </a:p>
+          <a:p>
+            <a:pPr>
+              <a:spcAft>
+                <a:spcPts val="200"/>
+              </a:spcAft>
+              <a:defRPr sz="1050">
+                <a:solidFill>
+                  <a:srgbClr val="E2E8F0"/>
+                </a:solidFill>
+                <a:latin typeface="Consolas"/>
+              </a:defRPr>
+            </a:pPr>
+            <a:r>
+              <a:t>function move(clientX) {</a:t>
+            </a:r>
+          </a:p>
+          <a:p>
+            <a:pPr>
+              <a:spcAft>
+                <a:spcPts val="200"/>
+              </a:spcAft>
+              <a:defRPr sz="1050">
+                <a:solidFill>
+                  <a:srgbClr val="E2E8F0"/>
+                </a:solidFill>
+                <a:latin typeface="Consolas"/>
+              </a:defRPr>
+            </a:pPr>
+            <a:r>
+              <a:t>  const rect = container.getBoundingClientRect();</a:t>
+            </a:r>
+          </a:p>
+          <a:p>
+            <a:pPr>
+              <a:spcAft>
+                <a:spcPts val="200"/>
+              </a:spcAft>
+              <a:defRPr sz="1050">
+                <a:solidFill>
+                  <a:srgbClr val="E2E8F0"/>
+                </a:solidFill>
+                <a:latin typeface="Consolas"/>
+              </a:defRPr>
+            </a:pPr>
+            <a:r>
+              <a:t>  let percentage = ((clientX - rect.left) / rect.width) * 100;</a:t>
+            </a:r>
+          </a:p>
+          <a:p>
+            <a:pPr>
+              <a:spcAft>
+                <a:spcPts val="200"/>
+              </a:spcAft>
+              <a:defRPr sz="1050">
                 <a:solidFill>
                   <a:srgbClr val="94A3B8"/>
                 </a:solidFill>
@@ -5347,29 +5580,53 @@
               </a:defRPr>
             </a:pPr>
             <a:r>
-              <a:t>function move(clientX) {</a:t>
-            </a:r>
-            <a:br/>
-            <a:r>
-              <a:t>  const rect = container.getBoundingClientRect();</a:t>
-            </a:r>
-            <a:br/>
-            <a:r>
-              <a:t>  let percentage = ((clientX - rect.left) / rect.width) * 100;</a:t>
-            </a:r>
-            <a:br/>
-            <a:r>
-              <a:t>  percentage = Math.max(3, Math.min(97, percentage)); // 限制範圍，防把把手拉出邊界</a:t>
-            </a:r>
-            <a:br/>
+              <a:t>  percentage = Math.max(3, Math.min(97, percentage)); // 限制範圍防止拉桿溢出</a:t>
+            </a:r>
+          </a:p>
+          <a:p>
+            <a:pPr>
+              <a:spcAft>
+                <a:spcPts val="200"/>
+              </a:spcAft>
+              <a:defRPr sz="1050">
+                <a:solidFill>
+                  <a:srgbClr val="E2E8F0"/>
+                </a:solidFill>
+                <a:latin typeface="Consolas"/>
+              </a:defRPr>
+            </a:pPr>
             <a:r>
               <a:t>  handle.style.left = `${percentage}%`;              // 拉桿定位</a:t>
             </a:r>
-            <a:br/>
-            <a:r>
-              <a:t>  beforePanel.style.width = `${percentage}%`;        // 沒有 CRC 覆蓋寬度 (z-index 2)</a:t>
-            </a:r>
-            <a:br/>
+          </a:p>
+          <a:p>
+            <a:pPr>
+              <a:spcAft>
+                <a:spcPts val="200"/>
+              </a:spcAft>
+              <a:defRPr sz="1050">
+                <a:solidFill>
+                  <a:srgbClr val="38BDF8"/>
+                </a:solidFill>
+                <a:latin typeface="Consolas"/>
+              </a:defRPr>
+            </a:pPr>
+            <a:r>
+              <a:t>  beforePanel.style.width = `${percentage}%`;        // 沒有 CRC 遮罩寬度 (z-index: 2)</a:t>
+            </a:r>
+          </a:p>
+          <a:p>
+            <a:pPr>
+              <a:spcAft>
+                <a:spcPts val="200"/>
+              </a:spcAft>
+              <a:defRPr sz="1050">
+                <a:solidFill>
+                  <a:srgbClr val="E2E8F0"/>
+                </a:solidFill>
+                <a:latin typeface="Consolas"/>
+              </a:defRPr>
+            </a:pPr>
             <a:r>
               <a:t>}</a:t>
             </a:r>
@@ -5390,7 +5647,7 @@
     <p:bg>
       <p:bgPr>
         <a:solidFill>
-          <a:srgbClr val="0A0D1A"/>
+          <a:srgbClr val="F8FAFC"/>
         </a:solidFill>
         <a:effectLst/>
       </p:bgPr>
@@ -5427,13 +5684,13 @@
             <a:pPr>
               <a:defRPr sz="1000" b="1">
                 <a:solidFill>
-                  <a:srgbClr val="A855F7"/>
+                  <a:srgbClr val="7E22CE"/>
                 </a:solidFill>
                 <a:latin typeface="Arial"/>
               </a:defRPr>
             </a:pPr>
             <a:r>
-              <a:t>專案技術手冊</a:t>
+              <a:t>CRC 專案開發與後端串接手冊</a:t>
             </a:r>
           </a:p>
         </p:txBody>
@@ -5463,7 +5720,7 @@
             <a:pPr>
               <a:defRPr sz="2600" b="1">
                 <a:solidFill>
-                  <a:srgbClr val="F8FAFC"/>
+                  <a:srgbClr val="0F172A"/>
                 </a:solidFill>
                 <a:latin typeface="Microsoft JhengHei"/>
               </a:defRPr>
@@ -5489,7 +5746,7 @@
             <a:avLst/>
           </a:prstGeom>
           <a:solidFill>
-            <a:srgbClr val="334155"/>
+            <a:srgbClr val="E2E8F0"/>
           </a:solidFill>
           <a:ln>
             <a:noFill/>
@@ -5526,17 +5783,17 @@
         <p:spPr>
           <a:xfrm>
             <a:off x="685800" y="1645920"/>
-            <a:ext cx="5303520" cy="4389120"/>
+            <a:ext cx="5303520" cy="4480560"/>
           </a:xfrm>
           <a:prstGeom prst="rect">
             <a:avLst/>
           </a:prstGeom>
           <a:solidFill>
-            <a:srgbClr val="151D3B"/>
+            <a:srgbClr val="FFFFFF"/>
           </a:solidFill>
           <a:ln w="19050">
             <a:solidFill>
-              <a:srgbClr val="A855F7"/>
+              <a:srgbClr val="7E22CE"/>
             </a:solidFill>
           </a:ln>
         </p:spPr>
@@ -5570,8 +5827,8 @@
         </p:nvSpPr>
         <p:spPr>
           <a:xfrm>
-            <a:off x="1051560" y="1920240"/>
-            <a:ext cx="4572000" cy="3840480"/>
+            <a:off x="960120" y="1828800"/>
+            <a:ext cx="4754880" cy="4114800"/>
           </a:xfrm>
           <a:prstGeom prst="rect">
             <a:avLst/>
@@ -5586,33 +5843,33 @@
           <a:p>
             <a:pPr>
               <a:spcAft>
-                <a:spcPts val="1200"/>
+                <a:spcPts val="1000"/>
               </a:spcAft>
               <a:defRPr sz="1700" b="1">
                 <a:solidFill>
-                  <a:srgbClr val="A855F7"/>
-                </a:solidFill>
-                <a:latin typeface="Microsoft JhengHei"/>
-              </a:defRPr>
-            </a:pPr>
-            <a:r>
-              <a:t>🚩 四關卡防呆與 20 分鐘學習深度</a:t>
-            </a:r>
-          </a:p>
-          <a:p>
-            <a:pPr>
-              <a:spcAft>
-                <a:spcPts val="200"/>
+                  <a:srgbClr val="7E22CE"/>
+                </a:solidFill>
+                <a:latin typeface="Microsoft JhengHei"/>
+              </a:defRPr>
+            </a:pPr>
+            <a:r>
+              <a:t>🚩 四關卡防跳關與學習深度設計</a:t>
+            </a:r>
+          </a:p>
+          <a:p>
+            <a:pPr>
+              <a:spcAft>
+                <a:spcPts val="100"/>
               </a:spcAft>
               <a:defRPr sz="1250" b="1">
                 <a:solidFill>
-                  <a:srgbClr val="F8FAFC"/>
-                </a:solidFill>
-                <a:latin typeface="Microsoft JhengHei"/>
-              </a:defRPr>
-            </a:pPr>
-            <a:r>
-              <a:t>✦ 階段一：法規知識奠基 (選擇 + 配合)</a:t>
+                  <a:srgbClr val="0F172A"/>
+                </a:solidFill>
+                <a:latin typeface="Microsoft JhengHei"/>
+              </a:defRPr>
+            </a:pPr>
+            <a:r>
+              <a:t>✦ 階段一：法規知識奠基 (單選 + 配對)</a:t>
             </a:r>
           </a:p>
           <a:p>
@@ -5622,29 +5879,29 @@
               </a:spcAft>
               <a:defRPr sz="1100">
                 <a:solidFill>
-                  <a:srgbClr val="94A3B8"/>
-                </a:solidFill>
-                <a:latin typeface="Microsoft JhengHei"/>
-              </a:defRPr>
-            </a:pPr>
-            <a:r>
-              <a:t>進行 4 題選擇題與 1 組條文配對連連看。將第 12、16、28、31 條與校園場景配對正確後解鎖。</a:t>
-            </a:r>
-          </a:p>
-          <a:p>
-            <a:pPr>
-              <a:spcAft>
-                <a:spcPts val="200"/>
+                  <a:srgbClr val="475569"/>
+                </a:solidFill>
+                <a:latin typeface="Microsoft JhengHei"/>
+              </a:defRPr>
+            </a:pPr>
+            <a:r>
+              <a:t>進行 4 題選擇與 1 組法規連連看配對。配對將 CRC 第 12、16、28、31 條條文與校園情境對接。</a:t>
+            </a:r>
+          </a:p>
+          <a:p>
+            <a:pPr>
+              <a:spcAft>
+                <a:spcPts val="100"/>
               </a:spcAft>
               <a:defRPr sz="1250" b="1">
                 <a:solidFill>
-                  <a:srgbClr val="F8FAFC"/>
-                </a:solidFill>
-                <a:latin typeface="Microsoft JhengHei"/>
-              </a:defRPr>
-            </a:pPr>
-            <a:r>
-              <a:t>✦ 階段二：衝突抉擇現場 (情境題)</a:t>
+                  <a:srgbClr val="0F172A"/>
+                </a:solidFill>
+                <a:latin typeface="Microsoft JhengHei"/>
+              </a:defRPr>
+            </a:pPr>
+            <a:r>
+              <a:t>✦ 階段二：衝突抉擇現場 (情境指標)</a:t>
             </a:r>
           </a:p>
           <a:p>
@@ -5654,23 +5911,23 @@
               </a:spcAft>
               <a:defRPr sz="1100">
                 <a:solidFill>
-                  <a:srgbClr val="94A3B8"/>
-                </a:solidFill>
-                <a:latin typeface="Microsoft JhengHei"/>
-              </a:defRPr>
-            </a:pPr>
-            <a:r>
-              <a:t>導師面臨全班搜包、延後上學、大衣處分及晤談隱私等情境，即時改變 HUD (CRC、秩序、專業) 三項指標並記錄日誌。</a:t>
-            </a:r>
-          </a:p>
-          <a:p>
-            <a:pPr>
-              <a:spcAft>
-                <a:spcPts val="200"/>
+                  <a:srgbClr val="475569"/>
+                </a:solidFill>
+                <a:latin typeface="Microsoft JhengHei"/>
+              </a:defRPr>
+            </a:pPr>
+            <a:r>
+              <a:t>搜包、大衣罰站等情境，導師抉擇後即時扣減/增加 HUD (CRC、秩序、專業) 三項指標並寫入路徑。</a:t>
+            </a:r>
+          </a:p>
+          <a:p>
+            <a:pPr>
+              <a:spcAft>
+                <a:spcPts val="100"/>
               </a:spcAft>
               <a:defRPr sz="1250" b="1">
                 <a:solidFill>
-                  <a:srgbClr val="F8FAFC"/>
+                  <a:srgbClr val="0F172A"/>
                 </a:solidFill>
                 <a:latin typeface="Microsoft JhengHei"/>
               </a:defRPr>
@@ -5686,23 +5943,23 @@
               </a:spcAft>
               <a:defRPr sz="1100">
                 <a:solidFill>
-                  <a:srgbClr val="94A3B8"/>
-                </a:solidFill>
-                <a:latin typeface="Microsoft JhengHei"/>
-              </a:defRPr>
-            </a:pPr>
-            <a:r>
-              <a:t>批判「連坐罰愛校」與「沒收手機至期末」之校規班規。每題設有 50 字限制，字數不足鎖定下一關，保證研習時長。</a:t>
-            </a:r>
-          </a:p>
-          <a:p>
-            <a:pPr>
-              <a:spcAft>
-                <a:spcPts val="200"/>
+                  <a:srgbClr val="475569"/>
+                </a:solidFill>
+                <a:latin typeface="Microsoft JhengHei"/>
+              </a:defRPr>
+            </a:pPr>
+            <a:r>
+              <a:t>批判「連坐罰愛校」與「沒收手機至期末」。每題設有 50 字限制，字數不足按鈕禁用，防範應付作答。</a:t>
+            </a:r>
+          </a:p>
+          <a:p>
+            <a:pPr>
+              <a:spcAft>
+                <a:spcPts val="100"/>
               </a:spcAft>
               <a:defRPr sz="1250" b="1">
                 <a:solidFill>
-                  <a:srgbClr val="F8FAFC"/>
+                  <a:srgbClr val="0F172A"/>
                 </a:solidFill>
                 <a:latin typeface="Microsoft JhengHei"/>
               </a:defRPr>
@@ -5718,13 +5975,13 @@
               </a:spcAft>
               <a:defRPr sz="1100">
                 <a:solidFill>
-                  <a:srgbClr val="94A3B8"/>
-                </a:solidFill>
-                <a:latin typeface="Microsoft JhengHei"/>
-              </a:defRPr>
-            </a:pPr>
-            <a:r>
-              <a:t>將修復式正義對話的 5 步驟進行排序（還原、同理、影響、彌補、行動），並撰寫 30 字班級自治宣言。</a:t>
+                  <a:srgbClr val="475569"/>
+                </a:solidFill>
+                <a:latin typeface="Microsoft JhengHei"/>
+              </a:defRPr>
+            </a:pPr>
+            <a:r>
+              <a:t>排序修復式對話 5 步驟（還原-同理-影響-彌補-行動），並撰寫 30 字班級自治誓言。</a:t>
             </a:r>
           </a:p>
         </p:txBody>
@@ -5738,17 +5995,17 @@
         <p:spPr>
           <a:xfrm>
             <a:off x="6217920" y="1645920"/>
-            <a:ext cx="5257800" cy="4389120"/>
+            <a:ext cx="5257800" cy="4480560"/>
           </a:xfrm>
           <a:prstGeom prst="rect">
             <a:avLst/>
           </a:prstGeom>
           <a:solidFill>
-            <a:srgbClr val="151D3B"/>
+            <a:srgbClr val="FFFFFF"/>
           </a:solidFill>
           <a:ln w="19050">
             <a:solidFill>
-              <a:srgbClr val="334155"/>
+              <a:srgbClr val="0284C7"/>
             </a:solidFill>
           </a:ln>
         </p:spPr>
@@ -5782,8 +6039,8 @@
         </p:nvSpPr>
         <p:spPr>
           <a:xfrm>
-            <a:off x="6583680" y="1920240"/>
-            <a:ext cx="4526280" cy="3840480"/>
+            <a:off x="6492240" y="1828800"/>
+            <a:ext cx="4709160" cy="4114800"/>
           </a:xfrm>
           <a:prstGeom prst="rect">
             <a:avLst/>
@@ -5798,113 +6055,113 @@
           <a:p>
             <a:pPr>
               <a:spcAft>
-                <a:spcPts val="1500"/>
+                <a:spcPts val="1200"/>
               </a:spcAft>
               <a:defRPr sz="1700" b="1">
                 <a:solidFill>
-                  <a:srgbClr val="F8FAFC"/>
-                </a:solidFill>
-                <a:latin typeface="Microsoft JhengHei"/>
-              </a:defRPr>
-            </a:pPr>
-            <a:r>
-              <a:t>🎯 多樣題型核心控制機制</a:t>
-            </a:r>
-          </a:p>
-          <a:p>
-            <a:pPr>
-              <a:spcAft>
-                <a:spcPts val="200"/>
-              </a:spcAft>
-              <a:defRPr sz="1300" b="1">
-                <a:solidFill>
-                  <a:srgbClr val="0EA5E9"/>
-                </a:solidFill>
-                <a:latin typeface="Microsoft JhengHei"/>
-              </a:defRPr>
-            </a:pPr>
-            <a:r>
-              <a:t>▪ 連連看點選配對 (Matching)</a:t>
-            </a:r>
-          </a:p>
-          <a:p>
-            <a:pPr>
-              <a:spcAft>
-                <a:spcPts val="1000"/>
+                  <a:srgbClr val="0284C7"/>
+                </a:solidFill>
+                <a:latin typeface="Microsoft JhengHei"/>
+              </a:defRPr>
+            </a:pPr>
+            <a:r>
+              <a:t>🎯 多樣題型前端實作控制</a:t>
+            </a:r>
+          </a:p>
+          <a:p>
+            <a:pPr>
+              <a:spcAft>
+                <a:spcPts val="100"/>
+              </a:spcAft>
+              <a:defRPr sz="1250" b="1">
+                <a:solidFill>
+                  <a:srgbClr val="0F172A"/>
+                </a:solidFill>
+                <a:latin typeface="Microsoft JhengHei"/>
+              </a:defRPr>
+            </a:pPr>
+            <a:r>
+              <a:t>▪ 連連看點選配對 (Card Matching)</a:t>
+            </a:r>
+          </a:p>
+          <a:p>
+            <a:pPr>
+              <a:spcAft>
+                <a:spcPts val="800"/>
               </a:spcAft>
               <a:defRPr sz="1100">
                 <a:solidFill>
-                  <a:srgbClr val="94A3B8"/>
-                </a:solidFill>
-                <a:latin typeface="Microsoft JhengHei"/>
-              </a:defRPr>
-            </a:pPr>
-            <a:r>
-              <a:t>採用「點選左側 Card 再點選右側 Card」方式進行。配對成功則 Card 轉為綠色並鎖定，防止傳統 drag-and-drop 在行動裝置上的 RWD 跑位問題。</a:t>
-            </a:r>
-          </a:p>
-          <a:p>
-            <a:pPr>
-              <a:spcAft>
-                <a:spcPts val="200"/>
-              </a:spcAft>
-              <a:defRPr sz="1300" b="1">
-                <a:solidFill>
-                  <a:srgbClr val="0EA5E9"/>
-                </a:solidFill>
-                <a:latin typeface="Microsoft JhengHei"/>
-              </a:defRPr>
-            </a:pPr>
-            <a:r>
-              <a:t>▪ 簡答字數防呆驗證 (Character Limit)</a:t>
-            </a:r>
-          </a:p>
-          <a:p>
-            <a:pPr>
-              <a:spcAft>
-                <a:spcPts val="1000"/>
+                  <a:srgbClr val="475569"/>
+                </a:solidFill>
+                <a:latin typeface="Microsoft JhengHei"/>
+              </a:defRPr>
+            </a:pPr>
+            <a:r>
+              <a:t>改採「點選左側卡，再點選右側卡」取代傳統 Drag-and-drop，保證在手機等移動裝置上排版不會因 RWD 而跑位或無法拖曳。</a:t>
+            </a:r>
+          </a:p>
+          <a:p>
+            <a:pPr>
+              <a:spcAft>
+                <a:spcPts val="100"/>
+              </a:spcAft>
+              <a:defRPr sz="1250" b="1">
+                <a:solidFill>
+                  <a:srgbClr val="0F172A"/>
+                </a:solidFill>
+                <a:latin typeface="Microsoft JhengHei"/>
+              </a:defRPr>
+            </a:pPr>
+            <a:r>
+              <a:t>▪ 簡答字數動態驗證 (Validation)</a:t>
+            </a:r>
+          </a:p>
+          <a:p>
+            <a:pPr>
+              <a:spcAft>
+                <a:spcPts val="800"/>
               </a:spcAft>
               <a:defRPr sz="1100">
                 <a:solidFill>
-                  <a:srgbClr val="94A3B8"/>
-                </a:solidFill>
-                <a:latin typeface="Microsoft JhengHei"/>
-              </a:defRPr>
-            </a:pPr>
-            <a:r>
-              <a:t>監聽 textarea 的 input 事件，動態計算字數長度，未滿 minChars 前 Next 按鈕禁用並高亮提示，確保學生深入反思寫作。</a:t>
-            </a:r>
-          </a:p>
-          <a:p>
-            <a:pPr>
-              <a:spcAft>
-                <a:spcPts val="200"/>
-              </a:spcAft>
-              <a:defRPr sz="1300" b="1">
-                <a:solidFill>
-                  <a:srgbClr val="0EA5E9"/>
-                </a:solidFill>
-                <a:latin typeface="Microsoft JhengHei"/>
-              </a:defRPr>
-            </a:pPr>
-            <a:r>
-              <a:t>▪ 對話排序連線戰 (Sorting)</a:t>
-            </a:r>
-          </a:p>
-          <a:p>
-            <a:pPr>
-              <a:spcAft>
-                <a:spcPts val="1000"/>
+                  <a:srgbClr val="475569"/>
+                </a:solidFill>
+                <a:latin typeface="Microsoft JhengHei"/>
+              </a:defRPr>
+            </a:pPr>
+            <a:r>
+              <a:t>實時監聽 textarea 的 input 事件並計數。字數不足時，Next 按鈕保持 disabled 狀態並動態提示缺少字數，確保寫作品質。</a:t>
+            </a:r>
+          </a:p>
+          <a:p>
+            <a:pPr>
+              <a:spcAft>
+                <a:spcPts val="100"/>
+              </a:spcAft>
+              <a:defRPr sz="1250" b="1">
+                <a:solidFill>
+                  <a:srgbClr val="0F172A"/>
+                </a:solidFill>
+                <a:latin typeface="Microsoft JhengHei"/>
+              </a:defRPr>
+            </a:pPr>
+            <a:r>
+              <a:t>▪ 對話步驟拖動排序 (Sorting Game)</a:t>
+            </a:r>
+          </a:p>
+          <a:p>
+            <a:pPr>
+              <a:spcAft>
+                <a:spcPts val="800"/>
               </a:spcAft>
               <a:defRPr sz="1100">
                 <a:solidFill>
-                  <a:srgbClr val="94A3B8"/>
-                </a:solidFill>
-                <a:latin typeface="Microsoft JhengHei"/>
-              </a:defRPr>
-            </a:pPr>
-            <a:r>
-              <a:t>利用序列存儲使用者的點擊順序。每點選一個步驟即送入 user-list，並在 complete 時比對 correctOrder 陣列。若出錯點擊可自 user-list 中取消。</a:t>
+                  <a:srgbClr val="475569"/>
+                </a:solidFill>
+                <a:latin typeface="Microsoft JhengHei"/>
+              </a:defRPr>
+            </a:pPr>
+            <a:r>
+              <a:t>陣列序列化存儲。點選步驟加入 user-list 並動態變色，完全排序後與 correctOrder 比對，答錯可隨時點擊撤回。</a:t>
             </a:r>
           </a:p>
         </p:txBody>
@@ -5923,7 +6180,7 @@
     <p:bg>
       <p:bgPr>
         <a:solidFill>
-          <a:srgbClr val="0A0D1A"/>
+          <a:srgbClr val="F8FAFC"/>
         </a:solidFill>
         <a:effectLst/>
       </p:bgPr>
@@ -5960,13 +6217,13 @@
             <a:pPr>
               <a:defRPr sz="1000" b="1">
                 <a:solidFill>
-                  <a:srgbClr val="A855F7"/>
+                  <a:srgbClr val="7E22CE"/>
                 </a:solidFill>
                 <a:latin typeface="Arial"/>
               </a:defRPr>
             </a:pPr>
             <a:r>
-              <a:t>專案技術手冊</a:t>
+              <a:t>CRC 專案開發與後端串接手冊</a:t>
             </a:r>
           </a:p>
         </p:txBody>
@@ -5996,7 +6253,7 @@
             <a:pPr>
               <a:defRPr sz="2600" b="1">
                 <a:solidFill>
-                  <a:srgbClr val="F8FAFC"/>
+                  <a:srgbClr val="0F172A"/>
                 </a:solidFill>
                 <a:latin typeface="Microsoft JhengHei"/>
               </a:defRPr>
@@ -6022,7 +6279,7 @@
             <a:avLst/>
           </a:prstGeom>
           <a:solidFill>
-            <a:srgbClr val="334155"/>
+            <a:srgbClr val="E2E8F0"/>
           </a:solidFill>
           <a:ln>
             <a:noFill/>
@@ -6058,18 +6315,18 @@
         </p:nvSpPr>
         <p:spPr>
           <a:xfrm>
-            <a:off x="685800" y="1828800"/>
-            <a:ext cx="2468880" cy="4206240"/>
+            <a:off x="746150" y="1737360"/>
+            <a:ext cx="2468880" cy="4389120"/>
           </a:xfrm>
           <a:prstGeom prst="rect">
             <a:avLst/>
           </a:prstGeom>
           <a:solidFill>
-            <a:srgbClr val="151D3B"/>
+            <a:srgbClr val="FFFFFF"/>
           </a:solidFill>
           <a:ln w="19050">
             <a:solidFill>
-              <a:srgbClr val="0EA5E9"/>
+              <a:srgbClr val="0284C7"/>
             </a:solidFill>
           </a:ln>
         </p:spPr>
@@ -6103,8 +6360,8 @@
         </p:nvSpPr>
         <p:spPr>
           <a:xfrm>
-            <a:off x="795528" y="2011680"/>
-            <a:ext cx="2249424" cy="3840480"/>
+            <a:off x="855878" y="1874520"/>
+            <a:ext cx="2249424" cy="4114800"/>
           </a:xfrm>
           <a:prstGeom prst="rect">
             <a:avLst/>
@@ -6119,11 +6376,11 @@
           <a:p>
             <a:pPr>
               <a:spcAft>
-                <a:spcPts val="500"/>
+                <a:spcPts val="400"/>
               </a:spcAft>
               <a:defRPr sz="1600" b="1">
                 <a:solidFill>
-                  <a:srgbClr val="0EA5E9"/>
+                  <a:srgbClr val="0284C7"/>
                 </a:solidFill>
                 <a:latin typeface="Microsoft JhengHei"/>
               </a:defRPr>
@@ -6135,11 +6392,11 @@
           <a:p>
             <a:pPr>
               <a:spcAft>
-                <a:spcPts val="1500"/>
+                <a:spcPts val="1200"/>
               </a:spcAft>
               <a:defRPr sz="1100" b="1">
                 <a:solidFill>
-                  <a:srgbClr val="F8FAFC"/>
+                  <a:srgbClr val="0F172A"/>
                 </a:solidFill>
                 <a:latin typeface="Microsoft JhengHei"/>
               </a:defRPr>
@@ -6151,14 +6408,11 @@
           <a:p>
             <a:pPr>
               <a:lnSpc>
-                <a:spcPct val="135000"/>
+                <a:spcPct val="130000"/>
               </a:lnSpc>
-              <a:spcAft>
-                <a:spcPts val="800"/>
-              </a:spcAft>
-              <a:defRPr sz="1150">
-                <a:solidFill>
-                  <a:srgbClr val="94A3B8"/>
+              <a:defRPr sz="1100">
+                <a:solidFill>
+                  <a:srgbClr val="475569"/>
                 </a:solidFill>
                 <a:latin typeface="Microsoft JhengHei"/>
               </a:defRPr>
@@ -6172,7 +6426,7 @@
             </a:r>
             <a:br/>
             <a:r>
-              <a:t>3. 系統將會利用此表作為後端資料儲存中心。</a:t>
+              <a:t>3. 後端會自動初始化分頁與表頭，無須手動建表。</a:t>
             </a:r>
           </a:p>
         </p:txBody>
@@ -6185,18 +6439,18 @@
         </p:nvSpPr>
         <p:spPr>
           <a:xfrm>
-            <a:off x="3429000" y="1828800"/>
-            <a:ext cx="2468880" cy="4206240"/>
+            <a:off x="3489350" y="1737360"/>
+            <a:ext cx="2468880" cy="4389120"/>
           </a:xfrm>
           <a:prstGeom prst="rect">
             <a:avLst/>
           </a:prstGeom>
           <a:solidFill>
-            <a:srgbClr val="151D3B"/>
+            <a:srgbClr val="FFFFFF"/>
           </a:solidFill>
           <a:ln w="19050">
             <a:solidFill>
-              <a:srgbClr val="A855F7"/>
+              <a:srgbClr val="7E22CE"/>
             </a:solidFill>
           </a:ln>
         </p:spPr>
@@ -6230,8 +6484,8 @@
         </p:nvSpPr>
         <p:spPr>
           <a:xfrm>
-            <a:off x="3538728" y="2011680"/>
-            <a:ext cx="2249424" cy="3840480"/>
+            <a:off x="3599078" y="1874520"/>
+            <a:ext cx="2249424" cy="4114800"/>
           </a:xfrm>
           <a:prstGeom prst="rect">
             <a:avLst/>
@@ -6246,11 +6500,11 @@
           <a:p>
             <a:pPr>
               <a:spcAft>
-                <a:spcPts val="500"/>
+                <a:spcPts val="400"/>
               </a:spcAft>
               <a:defRPr sz="1600" b="1">
                 <a:solidFill>
-                  <a:srgbClr val="A855F7"/>
+                  <a:srgbClr val="7E22CE"/>
                 </a:solidFill>
                 <a:latin typeface="Microsoft JhengHei"/>
               </a:defRPr>
@@ -6262,11 +6516,11 @@
           <a:p>
             <a:pPr>
               <a:spcAft>
-                <a:spcPts val="1500"/>
+                <a:spcPts val="1200"/>
               </a:spcAft>
               <a:defRPr sz="1100" b="1">
                 <a:solidFill>
-                  <a:srgbClr val="F8FAFC"/>
+                  <a:srgbClr val="0F172A"/>
                 </a:solidFill>
                 <a:latin typeface="Microsoft JhengHei"/>
               </a:defRPr>
@@ -6278,24 +6532,21 @@
           <a:p>
             <a:pPr>
               <a:lnSpc>
-                <a:spcPct val="135000"/>
+                <a:spcPct val="130000"/>
               </a:lnSpc>
-              <a:spcAft>
-                <a:spcPts val="800"/>
-              </a:spcAft>
-              <a:defRPr sz="1150">
-                <a:solidFill>
-                  <a:srgbClr val="94A3B8"/>
-                </a:solidFill>
-                <a:latin typeface="Microsoft JhengHei"/>
-              </a:defRPr>
-            </a:pPr>
-            <a:r>
-              <a:t>1. 在試算表中點選「延伸功能」 &amp;rarr; 「Apps Script」。</a:t>
+              <a:defRPr sz="1100">
+                <a:solidFill>
+                  <a:srgbClr val="475569"/>
+                </a:solidFill>
+                <a:latin typeface="Microsoft JhengHei"/>
+              </a:defRPr>
+            </a:pPr>
+            <a:r>
+              <a:t>1. 於試算表中點選「延伸功能」-&gt;「Apps Script」。</a:t>
             </a:r>
             <a:br/>
             <a:r>
-              <a:t>2. 清空預設代碼，完整複製貼入本專案「backend/Code.gs」的程式碼，並儲存專案。</a:t>
+              <a:t>2. 清空預設函數，完整貼入專案「backend/Code.gs」程式碼，點擊儲存。</a:t>
             </a:r>
           </a:p>
         </p:txBody>
@@ -6308,18 +6559,18 @@
         </p:nvSpPr>
         <p:spPr>
           <a:xfrm>
-            <a:off x="6172200" y="1828800"/>
-            <a:ext cx="2468880" cy="4206240"/>
+            <a:off x="6232550" y="1737360"/>
+            <a:ext cx="2468880" cy="4389120"/>
           </a:xfrm>
           <a:prstGeom prst="rect">
             <a:avLst/>
           </a:prstGeom>
           <a:solidFill>
-            <a:srgbClr val="151D3B"/>
+            <a:srgbClr val="FFFFFF"/>
           </a:solidFill>
           <a:ln w="19050">
             <a:solidFill>
-              <a:srgbClr val="0EA5E9"/>
+              <a:srgbClr val="0284C7"/>
             </a:solidFill>
           </a:ln>
         </p:spPr>
@@ -6353,8 +6604,8 @@
         </p:nvSpPr>
         <p:spPr>
           <a:xfrm>
-            <a:off x="6281928" y="2011680"/>
-            <a:ext cx="2249424" cy="3840480"/>
+            <a:off x="6342278" y="1874520"/>
+            <a:ext cx="2249424" cy="4114800"/>
           </a:xfrm>
           <a:prstGeom prst="rect">
             <a:avLst/>
@@ -6369,11 +6620,11 @@
           <a:p>
             <a:pPr>
               <a:spcAft>
-                <a:spcPts val="500"/>
+                <a:spcPts val="400"/>
               </a:spcAft>
               <a:defRPr sz="1600" b="1">
                 <a:solidFill>
-                  <a:srgbClr val="0EA5E9"/>
+                  <a:srgbClr val="0284C7"/>
                 </a:solidFill>
                 <a:latin typeface="Microsoft JhengHei"/>
               </a:defRPr>
@@ -6385,11 +6636,11 @@
           <a:p>
             <a:pPr>
               <a:spcAft>
-                <a:spcPts val="1500"/>
+                <a:spcPts val="1200"/>
               </a:spcAft>
               <a:defRPr sz="1100" b="1">
                 <a:solidFill>
-                  <a:srgbClr val="F8FAFC"/>
+                  <a:srgbClr val="0F172A"/>
                 </a:solidFill>
                 <a:latin typeface="Microsoft JhengHei"/>
               </a:defRPr>
@@ -6401,20 +6652,17 @@
           <a:p>
             <a:pPr>
               <a:lnSpc>
-                <a:spcPct val="135000"/>
+                <a:spcPct val="130000"/>
               </a:lnSpc>
-              <a:spcAft>
-                <a:spcPts val="800"/>
-              </a:spcAft>
-              <a:defRPr sz="1150">
-                <a:solidFill>
-                  <a:srgbClr val="94A3B8"/>
-                </a:solidFill>
-                <a:latin typeface="Microsoft JhengHei"/>
-              </a:defRPr>
-            </a:pPr>
-            <a:r>
-              <a:t>1. 點選「部署」 &amp;rarr; 「新增部署」。</a:t>
+              <a:defRPr sz="1100">
+                <a:solidFill>
+                  <a:srgbClr val="475569"/>
+                </a:solidFill>
+                <a:latin typeface="Microsoft JhengHei"/>
+              </a:defRPr>
+            </a:pPr>
+            <a:r>
+              <a:t>1. 點擊「部署」-&gt;「新增部署」。</a:t>
             </a:r>
             <a:br/>
             <a:r>
@@ -6422,7 +6670,7 @@
             </a:r>
             <a:br/>
             <a:r>
-              <a:t>3. 執行身分設為「我 (您的Google帳號)」；存取權限設為「任何人 (Anyone)」，複製生成的 Web App 網址。</a:t>
+              <a:t>3. 執行身分設為「我」；存取權限設為「任何人(Anyone)」後進行部署，複製產生的 URL。</a:t>
             </a:r>
           </a:p>
         </p:txBody>
@@ -6435,18 +6683,18 @@
         </p:nvSpPr>
         <p:spPr>
           <a:xfrm>
-            <a:off x="8915400" y="1828800"/>
-            <a:ext cx="2468880" cy="4206240"/>
+            <a:off x="8975750" y="1737360"/>
+            <a:ext cx="2468880" cy="4389120"/>
           </a:xfrm>
           <a:prstGeom prst="rect">
             <a:avLst/>
           </a:prstGeom>
           <a:solidFill>
-            <a:srgbClr val="151D3B"/>
+            <a:srgbClr val="FFFFFF"/>
           </a:solidFill>
           <a:ln w="19050">
             <a:solidFill>
-              <a:srgbClr val="A855F7"/>
+              <a:srgbClr val="7E22CE"/>
             </a:solidFill>
           </a:ln>
         </p:spPr>
@@ -6480,8 +6728,8 @@
         </p:nvSpPr>
         <p:spPr>
           <a:xfrm>
-            <a:off x="9025128" y="2011680"/>
-            <a:ext cx="2249424" cy="3840480"/>
+            <a:off x="9085478" y="1874520"/>
+            <a:ext cx="2249424" cy="4114800"/>
           </a:xfrm>
           <a:prstGeom prst="rect">
             <a:avLst/>
@@ -6496,11 +6744,11 @@
           <a:p>
             <a:pPr>
               <a:spcAft>
-                <a:spcPts val="500"/>
+                <a:spcPts val="400"/>
               </a:spcAft>
               <a:defRPr sz="1600" b="1">
                 <a:solidFill>
-                  <a:srgbClr val="A855F7"/>
+                  <a:srgbClr val="7E22CE"/>
                 </a:solidFill>
                 <a:latin typeface="Microsoft JhengHei"/>
               </a:defRPr>
@@ -6512,44 +6760,41 @@
           <a:p>
             <a:pPr>
               <a:spcAft>
-                <a:spcPts val="1500"/>
+                <a:spcPts val="1200"/>
               </a:spcAft>
               <a:defRPr sz="1100" b="1">
                 <a:solidFill>
-                  <a:srgbClr val="F8FAFC"/>
-                </a:solidFill>
-                <a:latin typeface="Microsoft JhengHei"/>
-              </a:defRPr>
-            </a:pPr>
-            <a:r>
-              <a:t>前端網頁對接</a:t>
+                  <a:srgbClr val="0F172A"/>
+                </a:solidFill>
+                <a:latin typeface="Microsoft JhengHei"/>
+              </a:defRPr>
+            </a:pPr>
+            <a:r>
+              <a:t>前端網頁網址對接</a:t>
             </a:r>
           </a:p>
           <a:p>
             <a:pPr>
               <a:lnSpc>
-                <a:spcPct val="135000"/>
+                <a:spcPct val="130000"/>
               </a:lnSpc>
-              <a:spcAft>
-                <a:spcPts val="800"/>
-              </a:spcAft>
-              <a:defRPr sz="1150">
-                <a:solidFill>
-                  <a:srgbClr val="94A3B8"/>
-                </a:solidFill>
-                <a:latin typeface="Microsoft JhengHei"/>
-              </a:defRPr>
-            </a:pPr>
-            <a:r>
-              <a:t>1. 開啟 index.html 或 slides.html，點擊右上角齒輪設定按鈕。</a:t>
+              <a:defRPr sz="1100">
+                <a:solidFill>
+                  <a:srgbClr val="475569"/>
+                </a:solidFill>
+                <a:latin typeface="Microsoft JhengHei"/>
+              </a:defRPr>
+            </a:pPr>
+            <a:r>
+              <a:t>1. 打開 index.html / slides.html 等，點右上角設定按鈕。</a:t>
             </a:r>
             <a:br/>
             <a:r>
-              <a:t>2. 貼入剛剛複製的 Web App URL 並點擊儲存。</a:t>
+              <a:t>2. 貼入剛剛複製的 Web App URL 並點擊保存。</a:t>
             </a:r>
             <a:br/>
             <a:r>
-              <a:t>3. 我們已將此網址設為本機與遠端倉庫的 defaultApiUrl，此後學生便可直接連線。</a:t>
+              <a:t>3. 已預設寫入 JS 組態檔中，學生即開即用。</a:t>
             </a:r>
           </a:p>
         </p:txBody>
@@ -6568,7 +6813,7 @@
     <p:bg>
       <p:bgPr>
         <a:solidFill>
-          <a:srgbClr val="0A0D1A"/>
+          <a:srgbClr val="F8FAFC"/>
         </a:solidFill>
         <a:effectLst/>
       </p:bgPr>
@@ -6605,13 +6850,13 @@
             <a:pPr>
               <a:defRPr sz="1000" b="1">
                 <a:solidFill>
-                  <a:srgbClr val="A855F7"/>
+                  <a:srgbClr val="7E22CE"/>
                 </a:solidFill>
                 <a:latin typeface="Arial"/>
               </a:defRPr>
             </a:pPr>
             <a:r>
-              <a:t>專案技術手冊</a:t>
+              <a:t>CRC 專案開發與後端串接手冊</a:t>
             </a:r>
           </a:p>
         </p:txBody>
@@ -6641,7 +6886,7 @@
             <a:pPr>
               <a:defRPr sz="2600" b="1">
                 <a:solidFill>
-                  <a:srgbClr val="F8FAFC"/>
+                  <a:srgbClr val="0F172A"/>
                 </a:solidFill>
                 <a:latin typeface="Microsoft JhengHei"/>
               </a:defRPr>
@@ -6667,7 +6912,7 @@
             <a:avLst/>
           </a:prstGeom>
           <a:solidFill>
-            <a:srgbClr val="334155"/>
+            <a:srgbClr val="E2E8F0"/>
           </a:solidFill>
           <a:ln>
             <a:noFill/>
@@ -6704,17 +6949,17 @@
         <p:spPr>
           <a:xfrm>
             <a:off x="685800" y="1645920"/>
-            <a:ext cx="5303520" cy="4389120"/>
+            <a:ext cx="5303520" cy="4480560"/>
           </a:xfrm>
           <a:prstGeom prst="rect">
             <a:avLst/>
           </a:prstGeom>
           <a:solidFill>
-            <a:srgbClr val="151D3B"/>
+            <a:srgbClr val="FFFFFF"/>
           </a:solidFill>
           <a:ln w="19050">
             <a:solidFill>
-              <a:srgbClr val="0EA5E9"/>
+              <a:srgbClr val="0284C7"/>
             </a:solidFill>
           </a:ln>
         </p:spPr>
@@ -6748,8 +6993,8 @@
         </p:nvSpPr>
         <p:spPr>
           <a:xfrm>
-            <a:off x="1051560" y="1920240"/>
-            <a:ext cx="4572000" cy="3840480"/>
+            <a:off x="960120" y="1828800"/>
+            <a:ext cx="4754880" cy="4114800"/>
           </a:xfrm>
           <a:prstGeom prst="rect">
             <a:avLst/>
@@ -6764,17 +7009,17 @@
           <a:p>
             <a:pPr>
               <a:spcAft>
-                <a:spcPts val="1200"/>
+                <a:spcPts val="1000"/>
               </a:spcAft>
               <a:defRPr sz="1700" b="1">
                 <a:solidFill>
-                  <a:srgbClr val="0EA5E9"/>
-                </a:solidFill>
-                <a:latin typeface="Microsoft JhengHei"/>
-              </a:defRPr>
-            </a:pPr>
-            <a:r>
-              <a:t>🛡️ 跨網域安全阻攔解決方案</a:t>
+                  <a:srgbClr val="0284C7"/>
+                </a:solidFill>
+                <a:latin typeface="Microsoft JhengHei"/>
+              </a:defRPr>
+            </a:pPr>
+            <a:r>
+              <a:t>🛡️ CORS 跨網域安全阻攔解決方案</a:t>
             </a:r>
           </a:p>
           <a:p>
@@ -6784,114 +7029,109 @@
               </a:spcAft>
               <a:defRPr sz="1250">
                 <a:solidFill>
-                  <a:srgbClr val="F8FAFC"/>
-                </a:solidFill>
-                <a:latin typeface="Microsoft JhengHei"/>
-              </a:defRPr>
-            </a:pPr>
-            <a:r>
-              <a:t>問題：GAS Web App 在接收 POST 時會重新導向，瀏覽器在追隨導向時常因 CORS 安全檢查缺少標頭而中斷請求，導致「Failed to fetch」錯誤。</a:t>
-            </a:r>
-            <a:br/>
-            <a:br/>
-            <a:r>
-              <a:t>解決手段：</a:t>
-            </a:r>
-          </a:p>
-          <a:p>
-            <a:pPr>
-              <a:spcAft>
-                <a:spcPts val="200"/>
-              </a:spcAft>
-              <a:defRPr sz="1250" b="1">
-                <a:solidFill>
-                  <a:srgbClr val="F8FAFC"/>
-                </a:solidFill>
-                <a:latin typeface="Microsoft JhengHei"/>
-              </a:defRPr>
-            </a:pPr>
-            <a:r>
-              <a:t>✔ 使用 mode: 'no-cors' 模式</a:t>
-            </a:r>
-          </a:p>
-          <a:p>
-            <a:pPr>
-              <a:spcAft>
-                <a:spcPts val="800"/>
+                  <a:srgbClr val="0F172A"/>
+                </a:solidFill>
+                <a:latin typeface="Microsoft JhengHei"/>
+              </a:defRPr>
+            </a:pPr>
+            <a:r>
+              <a:t>問題：GAS Web App 接收 POST 時會重新導向，因導向鏈中遺失 CORS 標頭，瀏覽器會封鎖請求，出現 Failed to fetch 錯誤。</a:t>
+            </a:r>
+          </a:p>
+          <a:p>
+            <a:pPr>
+              <a:spcAft>
+                <a:spcPts val="100"/>
+              </a:spcAft>
+              <a:defRPr sz="1200" b="1">
+                <a:solidFill>
+                  <a:srgbClr val="0F172A"/>
+                </a:solidFill>
+                <a:latin typeface="Microsoft JhengHei"/>
+              </a:defRPr>
+            </a:pPr>
+            <a:r>
+              <a:t>✔ 前端採用 mode: 'no-cors' 屬性</a:t>
+            </a:r>
+          </a:p>
+          <a:p>
+            <a:pPr>
+              <a:spcAft>
+                <a:spcPts val="600"/>
               </a:spcAft>
               <a:defRPr sz="1100">
                 <a:solidFill>
-                  <a:srgbClr val="94A3B8"/>
-                </a:solidFill>
-                <a:latin typeface="Microsoft JhengHei"/>
-              </a:defRPr>
-            </a:pPr>
-            <a:r>
-              <a:t>   強制瀏覽器以不檢查跨網域安全性之方式送出 POST 封包。</a:t>
-            </a:r>
-          </a:p>
-          <a:p>
-            <a:pPr>
-              <a:spcAft>
-                <a:spcPts val="200"/>
-              </a:spcAft>
-              <a:defRPr sz="1250" b="1">
-                <a:solidFill>
-                  <a:srgbClr val="F8FAFC"/>
-                </a:solidFill>
-                <a:latin typeface="Microsoft JhengHei"/>
-              </a:defRPr>
-            </a:pPr>
-            <a:r>
-              <a:t>✔ 避免 pre-flight OPTIONS 請求</a:t>
-            </a:r>
-          </a:p>
-          <a:p>
-            <a:pPr>
-              <a:spcAft>
-                <a:spcPts val="800"/>
+                  <a:srgbClr val="475569"/>
+                </a:solidFill>
+                <a:latin typeface="Microsoft JhengHei"/>
+              </a:defRPr>
+            </a:pPr>
+            <a:r>
+              <a:t>   強制瀏覽器放棄對該請求進行跨域安全標頭驗證。</a:t>
+            </a:r>
+          </a:p>
+          <a:p>
+            <a:pPr>
+              <a:spcAft>
+                <a:spcPts val="100"/>
+              </a:spcAft>
+              <a:defRPr sz="1200" b="1">
+                <a:solidFill>
+                  <a:srgbClr val="0F172A"/>
+                </a:solidFill>
+                <a:latin typeface="Microsoft JhengHei"/>
+              </a:defRPr>
+            </a:pPr>
+            <a:r>
+              <a:t>✔ 發送設定 Content-Type: 'text/plain'</a:t>
+            </a:r>
+          </a:p>
+          <a:p>
+            <a:pPr>
+              <a:spcAft>
+                <a:spcPts val="600"/>
               </a:spcAft>
               <a:defRPr sz="1100">
                 <a:solidFill>
-                  <a:srgbClr val="94A3B8"/>
-                </a:solidFill>
-                <a:latin typeface="Microsoft JhengHei"/>
-              </a:defRPr>
-            </a:pPr>
-            <a:r>
-              <a:t>   設定 header 為 Content-Type: 'text/plain'，將請求包裝為 Simple Request。</a:t>
-            </a:r>
-          </a:p>
-          <a:p>
-            <a:pPr>
-              <a:spcAft>
-                <a:spcPts val="200"/>
-              </a:spcAft>
-              <a:defRPr sz="1250" b="1">
-                <a:solidFill>
-                  <a:srgbClr val="F8FAFC"/>
-                </a:solidFill>
-                <a:latin typeface="Microsoft JhengHei"/>
-              </a:defRPr>
-            </a:pPr>
-            <a:r>
-              <a:t>✔ 拋棄 Opaque Response 的 JSON 解析</a:t>
-            </a:r>
-          </a:p>
-          <a:p>
-            <a:pPr>
-              <a:spcAft>
-                <a:spcPts val="800"/>
+                  <a:srgbClr val="475569"/>
+                </a:solidFill>
+                <a:latin typeface="Microsoft JhengHei"/>
+              </a:defRPr>
+            </a:pPr>
+            <a:r>
+              <a:t>   將 POST 標記為 Simple Request，避開瀏覽器自動觸發的 pre-flight OPTIONS 請求阻礙。</a:t>
+            </a:r>
+          </a:p>
+          <a:p>
+            <a:pPr>
+              <a:spcAft>
+                <a:spcPts val="100"/>
+              </a:spcAft>
+              <a:defRPr sz="1200" b="1">
+                <a:solidFill>
+                  <a:srgbClr val="0F172A"/>
+                </a:solidFill>
+                <a:latin typeface="Microsoft JhengHei"/>
+              </a:defRPr>
+            </a:pPr>
+            <a:r>
+              <a:t>✔ Opaque 響應直接默認成功</a:t>
+            </a:r>
+          </a:p>
+          <a:p>
+            <a:pPr>
+              <a:spcAft>
+                <a:spcPts val="600"/>
               </a:spcAft>
               <a:defRPr sz="1100">
                 <a:solidFill>
-                  <a:srgbClr val="94A3B8"/>
-                </a:solidFill>
-                <a:latin typeface="Microsoft JhengHei"/>
-              </a:defRPr>
-            </a:pPr>
-            <a:r>
-              <a:t>   由於 no-cors 下回傳的 status 為 0，前端不嘗試 parse 其 json，只要 fetch 未拋出網路異常即視為發送成功。</a:t>
+                  <a:srgbClr val="475569"/>
+                </a:solidFill>
+                <a:latin typeface="Microsoft JhengHei"/>
+              </a:defRPr>
+            </a:pPr>
+            <a:r>
+              <a:t>   因 no-cors 模式會返回 status 0 (不透明)，前端不進行 json 解析，無拋錯即視為發送成功，確保穩定。</a:t>
             </a:r>
           </a:p>
         </p:txBody>
@@ -6905,17 +7145,17 @@
         <p:spPr>
           <a:xfrm>
             <a:off x="6217920" y="1645920"/>
-            <a:ext cx="5257800" cy="4389120"/>
+            <a:ext cx="5257800" cy="4480560"/>
           </a:xfrm>
           <a:prstGeom prst="rect">
             <a:avLst/>
           </a:prstGeom>
           <a:solidFill>
-            <a:srgbClr val="151D3B"/>
+            <a:srgbClr val="FFFFFF"/>
           </a:solidFill>
           <a:ln w="19050">
             <a:solidFill>
-              <a:srgbClr val="A855F7"/>
+              <a:srgbClr val="7E22CE"/>
             </a:solidFill>
           </a:ln>
         </p:spPr>
@@ -6949,8 +7189,8 @@
         </p:nvSpPr>
         <p:spPr>
           <a:xfrm>
-            <a:off x="6583680" y="1920240"/>
-            <a:ext cx="4526280" cy="3840480"/>
+            <a:off x="6492240" y="1828800"/>
+            <a:ext cx="4709160" cy="4114800"/>
           </a:xfrm>
           <a:prstGeom prst="rect">
             <a:avLst/>
@@ -6965,11 +7205,11 @@
           <a:p>
             <a:pPr>
               <a:spcAft>
-                <a:spcPts val="1200"/>
+                <a:spcPts val="1000"/>
               </a:spcAft>
               <a:defRPr sz="1700" b="1">
                 <a:solidFill>
-                  <a:srgbClr val="A855F7"/>
+                  <a:srgbClr val="7E22CE"/>
                 </a:solidFill>
                 <a:latin typeface="Microsoft JhengHei"/>
               </a:defRPr>
@@ -6981,81 +7221,81 @@
           <a:p>
             <a:pPr>
               <a:spcAft>
-                <a:spcPts val="1200"/>
+                <a:spcPts val="1000"/>
               </a:spcAft>
               <a:defRPr sz="1250">
                 <a:solidFill>
-                  <a:srgbClr val="F8FAFC"/>
-                </a:solidFill>
-                <a:latin typeface="Microsoft JhengHei"/>
-              </a:defRPr>
-            </a:pPr>
-            <a:r>
-              <a:t>為了適應專案的多個疊代開發（例如從原本的 6 個情境分數，到後面追增簡答批判題及承諾宣告內容），後端 Code.gs 特別設計了自動化表頭遷移（Schema Migration）機制：</a:t>
-            </a:r>
-          </a:p>
-          <a:p>
-            <a:pPr>
-              <a:spcAft>
-                <a:spcPts val="200"/>
-              </a:spcAft>
-              <a:defRPr sz="1300" b="1">
-                <a:solidFill>
-                  <a:srgbClr val="F8FAFC"/>
-                </a:solidFill>
-                <a:latin typeface="Microsoft JhengHei"/>
-              </a:defRPr>
-            </a:pPr>
-            <a:r>
-              <a:t>✦ 空白分頁自動表頭建立</a:t>
-            </a:r>
-          </a:p>
-          <a:p>
-            <a:pPr>
-              <a:spcAft>
-                <a:spcPts val="1000"/>
+                  <a:srgbClr val="0F172A"/>
+                </a:solidFill>
+                <a:latin typeface="Microsoft JhengHei"/>
+              </a:defRPr>
+            </a:pPr>
+            <a:r>
+              <a:t>因應課程迭代開發（如追加批判簡答、自治宣言欄位），後端 Code.gs 特別實作自動化表頭遷移 (Schema Migration)：</a:t>
+            </a:r>
+          </a:p>
+          <a:p>
+            <a:pPr>
+              <a:spcAft>
+                <a:spcPts val="100"/>
+              </a:spcAft>
+              <a:defRPr sz="1250" b="1">
+                <a:solidFill>
+                  <a:srgbClr val="0F172A"/>
+                </a:solidFill>
+                <a:latin typeface="Microsoft JhengHei"/>
+              </a:defRPr>
+            </a:pPr>
+            <a:r>
+              <a:t>✦ 空白分頁自動建立</a:t>
+            </a:r>
+          </a:p>
+          <a:p>
+            <a:pPr>
+              <a:spcAft>
+                <a:spcPts val="800"/>
               </a:spcAft>
               <a:defRPr sz="1100">
                 <a:solidFill>
-                  <a:srgbClr val="94A3B8"/>
-                </a:solidFill>
-                <a:latin typeface="Microsoft JhengHei"/>
-              </a:defRPr>
-            </a:pPr>
-            <a:r>
-              <a:t>若試算表有手動建立的分頁但完全空白，getLastColumn() 回傳為 0。後端會自動攔截，並優先初始化 appendRow(defaultHeaders) 防止 Range 錯誤。</a:t>
-            </a:r>
-          </a:p>
-          <a:p>
-            <a:pPr>
-              <a:spcAft>
-                <a:spcPts val="200"/>
-              </a:spcAft>
-              <a:defRPr sz="1300" b="1">
-                <a:solidFill>
-                  <a:srgbClr val="F8FAFC"/>
-                </a:solidFill>
-                <a:latin typeface="Microsoft JhengHei"/>
-              </a:defRPr>
-            </a:pPr>
-            <a:r>
-              <a:t>✦ 新舊版本欄位自動比對</a:t>
-            </a:r>
-          </a:p>
-          <a:p>
-            <a:pPr>
-              <a:spcAft>
-                <a:spcPts val="1000"/>
+                  <a:srgbClr val="475569"/>
+                </a:solidFill>
+                <a:latin typeface="Microsoft JhengHei"/>
+              </a:defRPr>
+            </a:pPr>
+            <a:r>
+              <a:t>若試算表有手動建分頁但完全空白，getLastColumn() 為 0。後端自動攔截並呼叫 appendRow 寫入 defaultHeaders 防止 Range Error。</a:t>
+            </a:r>
+          </a:p>
+          <a:p>
+            <a:pPr>
+              <a:spcAft>
+                <a:spcPts val="100"/>
+              </a:spcAft>
+              <a:defRPr sz="1250" b="1">
+                <a:solidFill>
+                  <a:srgbClr val="0F172A"/>
+                </a:solidFill>
+                <a:latin typeface="Microsoft JhengHei"/>
+              </a:defRPr>
+            </a:pPr>
+            <a:r>
+              <a:t>✦ 版本升級自動追加欄位</a:t>
+            </a:r>
+          </a:p>
+          <a:p>
+            <a:pPr>
+              <a:spcAft>
+                <a:spcPts val="800"/>
               </a:spcAft>
               <a:defRPr sz="1100">
                 <a:solidFill>
-                  <a:srgbClr val="94A3B8"/>
-                </a:solidFill>
-                <a:latin typeface="Microsoft JhengHei"/>
-              </a:defRPr>
-            </a:pPr>
-            <a:r>
-              <a:t>當新版遊戲傳送 ShortAnswer1 等欄位時，Code.gs 會比對目前試算表的表頭，若發現缺失，會利用 getRange() 自動在最右側追加新表頭，無痛升級資料庫。</a:t>
+                  <a:srgbClr val="475569"/>
+                </a:solidFill>
+                <a:latin typeface="Microsoft JhengHei"/>
+              </a:defRPr>
+            </a:pPr>
+            <a:r>
+              <a:t>當新版遊戲傳送 ShortAnswer1 等新欄位時，Code.gs 自動比對表頭。若缺失，即透過 getRange() 在最右側追加新表頭，無損升級資料庫。</a:t>
             </a:r>
           </a:p>
         </p:txBody>
@@ -7074,7 +7314,7 @@
     <p:bg>
       <p:bgPr>
         <a:solidFill>
-          <a:srgbClr val="0A0D1A"/>
+          <a:srgbClr val="F8FAFC"/>
         </a:solidFill>
         <a:effectLst/>
       </p:bgPr>
@@ -7111,13 +7351,13 @@
             <a:pPr>
               <a:defRPr sz="1000" b="1">
                 <a:solidFill>
-                  <a:srgbClr val="A855F7"/>
+                  <a:srgbClr val="7E22CE"/>
                 </a:solidFill>
                 <a:latin typeface="Arial"/>
               </a:defRPr>
             </a:pPr>
             <a:r>
-              <a:t>專案技術手冊</a:t>
+              <a:t>CRC 專案開發與後端串接手冊</a:t>
             </a:r>
           </a:p>
         </p:txBody>
@@ -7147,7 +7387,7 @@
             <a:pPr>
               <a:defRPr sz="2600" b="1">
                 <a:solidFill>
-                  <a:srgbClr val="F8FAFC"/>
+                  <a:srgbClr val="0F172A"/>
                 </a:solidFill>
                 <a:latin typeface="Microsoft JhengHei"/>
               </a:defRPr>
@@ -7173,7 +7413,7 @@
             <a:avLst/>
           </a:prstGeom>
           <a:solidFill>
-            <a:srgbClr val="334155"/>
+            <a:srgbClr val="E2E8F0"/>
           </a:solidFill>
           <a:ln>
             <a:noFill/>
@@ -7210,17 +7450,17 @@
         <p:spPr>
           <a:xfrm>
             <a:off x="685800" y="1645920"/>
-            <a:ext cx="5303520" cy="4389120"/>
+            <a:ext cx="5303520" cy="4480560"/>
           </a:xfrm>
           <a:prstGeom prst="rect">
             <a:avLst/>
           </a:prstGeom>
           <a:solidFill>
-            <a:srgbClr val="151D3B"/>
+            <a:srgbClr val="FFFFFF"/>
           </a:solidFill>
           <a:ln w="19050">
             <a:solidFill>
-              <a:srgbClr val="0EA5E9"/>
+              <a:srgbClr val="0284C7"/>
             </a:solidFill>
           </a:ln>
         </p:spPr>
@@ -7254,8 +7494,8 @@
         </p:nvSpPr>
         <p:spPr>
           <a:xfrm>
-            <a:off x="1051560" y="1920240"/>
-            <a:ext cx="4572000" cy="3840480"/>
+            <a:off x="960120" y="1828800"/>
+            <a:ext cx="4754880" cy="4114800"/>
           </a:xfrm>
           <a:prstGeom prst="rect">
             <a:avLst/>
@@ -7274,29 +7514,29 @@
               </a:spcAft>
               <a:defRPr sz="1700" b="1">
                 <a:solidFill>
-                  <a:srgbClr val="0EA5E9"/>
-                </a:solidFill>
-                <a:latin typeface="Microsoft JhengHei"/>
-              </a:defRPr>
-            </a:pPr>
-            <a:r>
-              <a:t>🚀 GitHub Pages 前端網站部署</a:t>
-            </a:r>
-          </a:p>
-          <a:p>
-            <a:pPr>
-              <a:spcAft>
-                <a:spcPts val="200"/>
-              </a:spcAft>
-              <a:defRPr sz="1300" b="1">
-                <a:solidFill>
-                  <a:srgbClr val="F8FAFC"/>
-                </a:solidFill>
-                <a:latin typeface="Microsoft JhengHei"/>
-              </a:defRPr>
-            </a:pPr>
-            <a:r>
-              <a:t>▪ 本地 Git 倉庫初始化</a:t>
+                  <a:srgbClr val="0284C7"/>
+                </a:solidFill>
+                <a:latin typeface="Microsoft JhengHei"/>
+              </a:defRPr>
+            </a:pPr>
+            <a:r>
+              <a:t>🚀 GitHub Pages 前端靜態部署</a:t>
+            </a:r>
+          </a:p>
+          <a:p>
+            <a:pPr>
+              <a:spcAft>
+                <a:spcPts val="100"/>
+              </a:spcAft>
+              <a:defRPr sz="1250" b="1">
+                <a:solidFill>
+                  <a:srgbClr val="0F172A"/>
+                </a:solidFill>
+                <a:latin typeface="Microsoft JhengHei"/>
+              </a:defRPr>
+            </a:pPr>
+            <a:r>
+              <a:t>▪ 本地倉庫 Git 初始化</a:t>
             </a:r>
           </a:p>
           <a:p>
@@ -7306,29 +7546,29 @@
               </a:spcAft>
               <a:defRPr sz="1100">
                 <a:solidFill>
-                  <a:srgbClr val="94A3B8"/>
-                </a:solidFill>
-                <a:latin typeface="Microsoft JhengHei"/>
-              </a:defRPr>
-            </a:pPr>
-            <a:r>
-              <a:t>打開 PowerShell，進入專案目錄，執行 git init 初始化本地倉庫。</a:t>
-            </a:r>
-          </a:p>
-          <a:p>
-            <a:pPr>
-              <a:spcAft>
-                <a:spcPts val="200"/>
-              </a:spcAft>
-              <a:defRPr sz="1300" b="1">
-                <a:solidFill>
-                  <a:srgbClr val="F8FAFC"/>
-                </a:solidFill>
-                <a:latin typeface="Microsoft JhengHei"/>
-              </a:defRPr>
-            </a:pPr>
-            <a:r>
-              <a:t>▪ 提交變更</a:t>
+                  <a:srgbClr val="475569"/>
+                </a:solidFill>
+                <a:latin typeface="Microsoft JhengHei"/>
+              </a:defRPr>
+            </a:pPr>
+            <a:r>
+              <a:t>開啟終端機進入專案目錄，執行 `git init` 建立本地版控倉庫。</a:t>
+            </a:r>
+          </a:p>
+          <a:p>
+            <a:pPr>
+              <a:spcAft>
+                <a:spcPts val="100"/>
+              </a:spcAft>
+              <a:defRPr sz="1250" b="1">
+                <a:solidFill>
+                  <a:srgbClr val="0F172A"/>
+                </a:solidFill>
+                <a:latin typeface="Microsoft JhengHei"/>
+              </a:defRPr>
+            </a:pPr>
+            <a:r>
+              <a:t>▪ 提交靜態資源變更</a:t>
             </a:r>
           </a:p>
           <a:p>
@@ -7338,29 +7578,29 @@
               </a:spcAft>
               <a:defRPr sz="1100">
                 <a:solidFill>
-                  <a:srgbClr val="94A3B8"/>
-                </a:solidFill>
-                <a:latin typeface="Microsoft JhengHei"/>
-              </a:defRPr>
-            </a:pPr>
-            <a:r>
-              <a:t>執行 git add . 與 git commit -m 'feat: init CRC platform' 完成第一次提交。</a:t>
-            </a:r>
-          </a:p>
-          <a:p>
-            <a:pPr>
-              <a:spcAft>
-                <a:spcPts val="200"/>
-              </a:spcAft>
-              <a:defRPr sz="1300" b="1">
-                <a:solidFill>
-                  <a:srgbClr val="F8FAFC"/>
-                </a:solidFill>
-                <a:latin typeface="Microsoft JhengHei"/>
-              </a:defRPr>
-            </a:pPr>
-            <a:r>
-              <a:t>▪ 設定遠端源並推送</a:t>
+                  <a:srgbClr val="475569"/>
+                </a:solidFill>
+                <a:latin typeface="Microsoft JhengHei"/>
+              </a:defRPr>
+            </a:pPr>
+            <a:r>
+              <a:t>執行 `git add .` 與 `git commit -m 'feat: init CRC platform'` 完成本地提交。</a:t>
+            </a:r>
+          </a:p>
+          <a:p>
+            <a:pPr>
+              <a:spcAft>
+                <a:spcPts val="100"/>
+              </a:spcAft>
+              <a:defRPr sz="1250" b="1">
+                <a:solidFill>
+                  <a:srgbClr val="0F172A"/>
+                </a:solidFill>
+                <a:latin typeface="Microsoft JhengHei"/>
+              </a:defRPr>
+            </a:pPr>
+            <a:r>
+              <a:t>▪ 推送至 GitHub 遠端倉庫</a:t>
             </a:r>
           </a:p>
           <a:p>
@@ -7370,29 +7610,29 @@
               </a:spcAft>
               <a:defRPr sz="1100">
                 <a:solidFill>
-                  <a:srgbClr val="94A3B8"/>
-                </a:solidFill>
-                <a:latin typeface="Microsoft JhengHei"/>
-              </a:defRPr>
-            </a:pPr>
-            <a:r>
-              <a:t>執行 git remote add origin 指向您的儲存庫，並執行 git push -u origin main 推送。</a:t>
-            </a:r>
-          </a:p>
-          <a:p>
-            <a:pPr>
-              <a:spcAft>
-                <a:spcPts val="200"/>
-              </a:spcAft>
-              <a:defRPr sz="1300" b="1">
-                <a:solidFill>
-                  <a:srgbClr val="F8FAFC"/>
-                </a:solidFill>
-                <a:latin typeface="Microsoft JhengHei"/>
-              </a:defRPr>
-            </a:pPr>
-            <a:r>
-              <a:t>▪ 啟用 GitHub Pages</a:t>
+                  <a:srgbClr val="475569"/>
+                </a:solidFill>
+                <a:latin typeface="Microsoft JhengHei"/>
+              </a:defRPr>
+            </a:pPr>
+            <a:r>
+              <a:t>關聯遠端儲存庫並執行 `git push -u origin main` 推送至 GitHub。</a:t>
+            </a:r>
+          </a:p>
+          <a:p>
+            <a:pPr>
+              <a:spcAft>
+                <a:spcPts val="100"/>
+              </a:spcAft>
+              <a:defRPr sz="1250" b="1">
+                <a:solidFill>
+                  <a:srgbClr val="0F172A"/>
+                </a:solidFill>
+                <a:latin typeface="Microsoft JhengHei"/>
+              </a:defRPr>
+            </a:pPr>
+            <a:r>
+              <a:t>▪ 啟用 Pages 服務</a:t>
             </a:r>
           </a:p>
           <a:p>
@@ -7402,13 +7642,13 @@
               </a:spcAft>
               <a:defRPr sz="1100">
                 <a:solidFill>
-                  <a:srgbClr val="94A3B8"/>
-                </a:solidFill>
-                <a:latin typeface="Microsoft JhengHei"/>
-              </a:defRPr>
-            </a:pPr>
-            <a:r>
-              <a:t>在專案 Settings -&gt; Pages 頁面下將 Branch 設為 main 分支並保存。稍等 1 分鐘即可通過 https://帳號.github.io/CRC2026/ 公開存取。</a:t>
+                  <a:srgbClr val="475569"/>
+                </a:solidFill>
+                <a:latin typeface="Microsoft JhengHei"/>
+              </a:defRPr>
+            </a:pPr>
+            <a:r>
+              <a:t>於 Settings -&gt; Pages 頁面將 Source 設為 main 分支並保存。稍等 1 分鐘即可經由 https://mchung2022.github.io/CRC2026/ 公開瀏覽。</a:t>
             </a:r>
           </a:p>
         </p:txBody>
@@ -7422,17 +7662,17 @@
         <p:spPr>
           <a:xfrm>
             <a:off x="6217920" y="1645920"/>
-            <a:ext cx="5257800" cy="4389120"/>
+            <a:ext cx="5257800" cy="4480560"/>
           </a:xfrm>
           <a:prstGeom prst="rect">
             <a:avLst/>
           </a:prstGeom>
           <a:solidFill>
-            <a:srgbClr val="151D3B"/>
+            <a:srgbClr val="FFFFFF"/>
           </a:solidFill>
           <a:ln w="19050">
             <a:solidFill>
-              <a:srgbClr val="A855F7"/>
+              <a:srgbClr val="7E22CE"/>
             </a:solidFill>
           </a:ln>
         </p:spPr>
@@ -7466,8 +7706,8 @@
         </p:nvSpPr>
         <p:spPr>
           <a:xfrm>
-            <a:off x="6583680" y="1920240"/>
-            <a:ext cx="4526280" cy="3840480"/>
+            <a:off x="6492240" y="1828800"/>
+            <a:ext cx="4709160" cy="4114800"/>
           </a:xfrm>
           <a:prstGeom prst="rect">
             <a:avLst/>
@@ -7486,13 +7726,13 @@
               </a:spcAft>
               <a:defRPr sz="1700" b="1">
                 <a:solidFill>
-                  <a:srgbClr val="A855F7"/>
-                </a:solidFill>
-                <a:latin typeface="Microsoft JhengHei"/>
-              </a:defRPr>
-            </a:pPr>
-            <a:r>
-              <a:t>🧪 Node.js 自動化連線驗證結果</a:t>
+                  <a:srgbClr val="7E22CE"/>
+                </a:solidFill>
+                <a:latin typeface="Microsoft JhengHei"/>
+              </a:defRPr>
+            </a:pPr>
+            <a:r>
+              <a:t>🧪 Node.js 後端 API 自動寫入驗證</a:t>
             </a:r>
           </a:p>
           <a:p>
@@ -7502,7 +7742,7 @@
               </a:spcAft>
               <a:defRPr sz="1250">
                 <a:solidFill>
-                  <a:srgbClr val="F8FAFC"/>
+                  <a:srgbClr val="0F172A"/>
                 </a:solidFill>
                 <a:latin typeface="Microsoft JhengHei"/>
               </a:defRPr>
@@ -7514,11 +7754,11 @@
           <a:p>
             <a:pPr>
               <a:spcAft>
-                <a:spcPts val="200"/>
-              </a:spcAft>
-              <a:defRPr sz="1300" b="1">
-                <a:solidFill>
-                  <a:srgbClr val="F8FAFC"/>
+                <a:spcPts val="100"/>
+              </a:spcAft>
+              <a:defRPr sz="1250" b="1">
+                <a:solidFill>
+                  <a:srgbClr val="0F172A"/>
                 </a:solidFill>
                 <a:latin typeface="Microsoft JhengHei"/>
               </a:defRPr>
@@ -7534,23 +7774,23 @@
               </a:spcAft>
               <a:defRPr sz="1100">
                 <a:solidFill>
-                  <a:srgbClr val="94A3B8"/>
-                </a:solidFill>
-                <a:latin typeface="Microsoft JhengHei"/>
-              </a:defRPr>
-            </a:pPr>
-            <a:r>
-              <a:t>傳送系級、姓名『AI測試員-簡報』及素養討論反思至工作表 slides_feedback，後端返回 {'success': true}。</a:t>
-            </a:r>
-          </a:p>
-          <a:p>
-            <a:pPr>
-              <a:spcAft>
-                <a:spcPts val="200"/>
-              </a:spcAft>
-              <a:defRPr sz="1300" b="1">
-                <a:solidFill>
-                  <a:srgbClr val="F8FAFC"/>
+                  <a:srgbClr val="475569"/>
+                </a:solidFill>
+                <a:latin typeface="Microsoft JhengHei"/>
+              </a:defRPr>
+            </a:pPr>
+            <a:r>
+              <a:t>傳送姓名『AI測試員-簡報』及素養討論反思至工作表 slides_feedback，後端成功解析並回傳 success: true。</a:t>
+            </a:r>
+          </a:p>
+          <a:p>
+            <a:pPr>
+              <a:spcAft>
+                <a:spcPts val="100"/>
+              </a:spcAft>
+              <a:defRPr sz="1250" b="1">
+                <a:solidFill>
+                  <a:srgbClr val="0F172A"/>
                 </a:solidFill>
                 <a:latin typeface="Microsoft JhengHei"/>
               </a:defRPr>
@@ -7566,13 +7806,13 @@
               </a:spcAft>
               <a:defRPr sz="1100">
                 <a:solidFill>
-                  <a:srgbClr val="94A3B8"/>
-                </a:solidFill>
-                <a:latin typeface="Microsoft JhengHei"/>
-              </a:defRPr>
-            </a:pPr>
-            <a:r>
-              <a:t>傳送姓名『AI測試員-遊戲』、學號、得分、以及三道批判簡答內容至工作表 game_scores，後端返回 {'success': true}，順利解析資料列。</a:t>
+                  <a:srgbClr val="475569"/>
+                </a:solidFill>
+                <a:latin typeface="Microsoft JhengHei"/>
+              </a:defRPr>
+            </a:pPr>
+            <a:r>
+              <a:t>傳送姓名『AI測試員-遊戲』、學號、得分、以及三道批判簡答內容至工作表 game_scores，後端順利完成寫入且無 CORS 阻攔。</a:t>
             </a:r>
           </a:p>
         </p:txBody>

</xml_diff>

<commit_message>
docs: rewrite presentation to plain language AI-GitHub-Sheets workflow
</commit_message>
<xml_diff>
--- a/CRC_Project_Documentation.pptx
+++ b/CRC_Project_Documentation.pptx
@@ -3182,7 +3182,7 @@
               </a:defRPr>
             </a:pPr>
             <a:r>
-              <a:t>CRC 中學學務實踐培力平台</a:t>
+              <a:t>CRC 中學學務實踐平台</a:t>
             </a:r>
           </a:p>
           <a:p>
@@ -3198,7 +3198,7 @@
               </a:defRPr>
             </a:pPr>
             <a:r>
-              <a:t>HTML5 互動簡報、情境模擬遊戲與 Google Sheets 後端串接技術手冊</a:t>
+              <a:t>人機協同開發指南：從 AI 寫程式、GitHub 發布到試算表串接的完整實踐</a:t>
             </a:r>
           </a:p>
           <a:p>
@@ -3214,11 +3214,11 @@
               </a:defRPr>
             </a:pPr>
             <a:r>
-              <a:t>製作團隊：AI 師培數位教材開發組</a:t>
+              <a:t>製作方式：透過 AI 助手 Antigravity 撰寫程式、GitHub 網站發布、Google 試算表串接</a:t>
             </a:r>
             <a:br/>
             <a:r>
-              <a:t>發行對象：大二師培生「中學學生事務實踐」學術發表與技術手冊</a:t>
+              <a:t>簡報對象：大二師培生「中學學生事務實踐」學術發表與專案教學手冊</a:t>
             </a:r>
           </a:p>
         </p:txBody>
@@ -3345,7 +3345,7 @@
               </a:defRPr>
             </a:pPr>
             <a:r>
-              <a:t>🌟 雙軌引擎，相輔相成 —— 以 50 頁互動簡報奠定 CRC 法理基礎；透過四階段情境遊戲淬鍊學務抉擇。雙管齊下，打造高品質、高互動性的培力平台。</a:t>
+              <a:t>🌟 雙軌引擎，體驗深化 —— 簡報與闖關遊戲互補，師培生可在遊戲情境中磨練真實帶班管理信念，學習品質更勝傳統講授式課堂。</a:t>
             </a:r>
           </a:p>
           <a:p>
@@ -3358,13 +3358,13 @@
               </a:spcAft>
               <a:defRPr sz="1300">
                 <a:solidFill>
-                  <a:srgbClr val="FFFFFF"/>
-                </a:solidFill>
-                <a:latin typeface="Microsoft JhengHei"/>
-              </a:defRPr>
-            </a:pPr>
-            <a:r>
-              <a:t>⚡ 輕量架構，永續運作 —— 以 Google Sheets 代替傳統資料庫，免除伺服器維護成本與資料庫租金，適合教育研究及課堂教學長期託管。</a:t>
+                  <a:srgbClr val="0284C7"/>
+                </a:solidFill>
+                <a:latin typeface="Microsoft JhengHei"/>
+              </a:defRPr>
+            </a:pPr>
+            <a:r>
+              <a:t>⚡ AI 協同，極速開發 —— 本次開發透過與 AI 助手 Antigravity 深度對話編寫程式，快速實現複雜版面與互動逻辑，展示了現代 AI 輔助軟體開發的驚人效率。</a:t>
             </a:r>
           </a:p>
           <a:p>
@@ -3377,13 +3377,13 @@
               </a:spcAft>
               <a:defRPr sz="1300">
                 <a:solidFill>
-                  <a:srgbClr val="0284C7"/>
-                </a:solidFill>
-                <a:latin typeface="Microsoft JhengHei"/>
-              </a:defRPr>
-            </a:pPr>
-            <a:r>
-              <a:t>🛡️ 高容錯率，靈活擴充 —— 獨創 Web App 跨域 no-cors 傳送與 Code.gs 表頭動態遷移 (Schema Migration) 技術，未來課程內容微調無須改動資料庫架構。</a:t>
+                  <a:srgbClr val="FFFFFF"/>
+                </a:solidFill>
+                <a:latin typeface="Microsoft JhengHei"/>
+              </a:defRPr>
+            </a:pPr>
+            <a:r>
+              <a:t>🛡️ 雲端整合，零維護費 —— 依託 GitHub Pages 網站託管及 Google Sheets 免費資料庫架構，無須支付任何月租租金，實現長期的教材永續運作與輕鬆維護。</a:t>
             </a:r>
           </a:p>
           <a:p>
@@ -3402,7 +3402,7 @@
               </a:defRPr>
             </a:pPr>
             <a:r>
-              <a:t>🎓 師培啟航，人權扎根 —— 本平台成功協助大二師培學員將「兒童權利公約」融入中學導師帶班實務，培育新世代兼具「人權信念」與「法規專業」的優秀教師！</a:t>
+              <a:t>🎓 師培啟航，人權扎根 —— 本平台成功協助大二師培學員將「兒童權利公約」融入中學導師帶班實務，培育新世代兼具「人權信念」與「學務專業」的優秀教師！</a:t>
             </a:r>
           </a:p>
         </p:txBody>
@@ -3464,7 +3464,7 @@
               </a:defRPr>
             </a:pPr>
             <a:r>
-              <a:t>CRC 專案開發與後端串接手冊</a:t>
+              <a:t>人機協同開發與雲端串接手冊</a:t>
             </a:r>
           </a:p>
         </p:txBody>
@@ -3500,7 +3500,7 @@
               </a:defRPr>
             </a:pPr>
             <a:r>
-              <a:t>專案概述：雙引擎學務培力系統</a:t>
+              <a:t>專案概述：為師培生打造的數位學習平台</a:t>
             </a:r>
           </a:p>
         </p:txBody>
@@ -3627,7 +3627,7 @@
               </a:defRPr>
             </a:pPr>
             <a:r>
-              <a:t>🎯 開發背景與教學目標</a:t>
+              <a:t>🎯 為什麼要做這個平台？</a:t>
             </a:r>
           </a:p>
           <a:p>
@@ -3643,7 +3643,7 @@
               </a:defRPr>
             </a:pPr>
             <a:r>
-              <a:t>本專案為大二師培生量身設計，聚焦於「兒童權利公約 (CRC)」在校園實務之運用。藉由 HTML5 網頁互動媒介，擺脫傳統威權管理思維，培養以下關鍵能力：</a:t>
+              <a:t>為了幫助大二師培生在未來帶班時，能把「兒童權利公約 (CRC)」靈活運用在學校管理中。我們透過「網頁互動簡報」與「模擬闖關遊戲」雙管齊下，達成以下目的：</a:t>
             </a:r>
           </a:p>
           <a:p>
@@ -3659,7 +3659,7 @@
               </a:defRPr>
             </a:pPr>
             <a:r>
-              <a:t>• 理解與體現 CRC 四大核心原則於中學生活規約中。</a:t>
+              <a:t>• 告別威權管教，學習用兒童權利的視角來規範校園生活。</a:t>
             </a:r>
           </a:p>
           <a:p>
@@ -3675,7 +3675,7 @@
               </a:defRPr>
             </a:pPr>
             <a:r>
-              <a:t>• 對接教育部最新學生事務處理要點，淘汰過時威權管教。</a:t>
+              <a:t>• 對接教育部最新學務處理要點，理解學生表意與隱私權。</a:t>
             </a:r>
           </a:p>
           <a:p>
@@ -3691,7 +3691,7 @@
               </a:defRPr>
             </a:pPr>
             <a:r>
-              <a:t>• 批判思考不合理校規，具備民主協商與條文修正能力。</a:t>
+              <a:t>• 培養批判思考，學習找出不合理校規並提出合理修正。</a:t>
             </a:r>
           </a:p>
           <a:p>
@@ -3707,7 +3707,7 @@
               </a:defRPr>
             </a:pPr>
             <a:r>
-              <a:t>• 實作班級自治規章共創與修復式對話的溝通實踐。</a:t>
+              <a:t>• 實際模擬帶班衝突，練習使用溫和、民主的對話解決問題。</a:t>
             </a:r>
           </a:p>
         </p:txBody>
@@ -3791,7 +3791,7 @@
               </a:defRPr>
             </a:pPr>
             <a:r>
-              <a:t>📦 平台核心交付成果</a:t>
+              <a:t>📦 平台交付的兩大互動教材</a:t>
             </a:r>
           </a:p>
           <a:p>
@@ -3807,7 +3807,7 @@
               </a:defRPr>
             </a:pPr>
             <a:r>
-              <a:t>📖 50頁 HTML 互動簡報 (Reveal.js)</a:t>
+              <a:t>📖 50頁 HTML 互動簡報 (Reveal.js 技術)</a:t>
             </a:r>
           </a:p>
           <a:p>
@@ -3823,7 +3823,7 @@
               </a:defRPr>
             </a:pPr>
             <a:r>
-              <a:t>嵌入式簡報開發，具備左側同步導覽側欄、P13 人權對比拉桿，並內嵌 6 道探究討論框，反思紀錄自動寫入 Sheets。</a:t>
+              <a:t>包含左側自動目錄隨翻隨點，第13頁設有威權與人權校園「拉桿對比」，並內嵌 6 個思考討論框，送出直接存檔。</a:t>
             </a:r>
           </a:p>
           <a:p>
@@ -3855,7 +3855,7 @@
               </a:defRPr>
             </a:pPr>
             <a:r>
-              <a:t>包含法規選擇、點選式卡牌配對、不低於 50 字規章體檢與對話排序。設有時長防呆限制，提供深度學習回饋。</a:t>
+              <a:t>包含法規選擇、點選式條文配對、不低於 50 字規章體檢（防止隨便亂寫）與溫和對話排序。通關大約需要 20 分鐘。</a:t>
             </a:r>
           </a:p>
           <a:p>
@@ -3871,7 +3871,7 @@
               </a:defRPr>
             </a:pPr>
             <a:r>
-              <a:t>☁️ 無伺服器 GAS 連線後端</a:t>
+              <a:t>☁️ 自動串接 Google 試算表</a:t>
             </a:r>
           </a:p>
           <a:p>
@@ -3887,7 +3887,7 @@
               </a:defRPr>
             </a:pPr>
             <a:r>
-              <a:t>以 Google Apps Script 部署 Web App 作為 API，零成本串接 Sheets。支援動態表頭自動遷移，保障未來擴充彈性。</a:t>
+              <a:t>學生寫下的所有想法、遊戲得分與自治宣言，都會即時寫入雲端的 Google 試算表，方便老師回收學習歷程。</a:t>
             </a:r>
           </a:p>
         </p:txBody>
@@ -3949,7 +3949,7 @@
               </a:defRPr>
             </a:pPr>
             <a:r>
-              <a:t>CRC 專案開發與後端串接手冊</a:t>
+              <a:t>人機協同開發與雲端串接手冊</a:t>
             </a:r>
           </a:p>
         </p:txBody>
@@ -3985,7 +3985,7 @@
               </a:defRPr>
             </a:pPr>
             <a:r>
-              <a:t>系統架構：安全無伺服器 (Serverless) 數據通道</a:t>
+              <a:t>開發流程大綱：AI 協同、雲端發布與資料庫串接</a:t>
             </a:r>
           </a:p>
         </p:txBody>
@@ -4064,7 +4064,7 @@
               </a:defRPr>
             </a:pPr>
             <a:r>
-              <a:t>平台採取「前端託管 + Serverless API 後端 + Google Sheet 雲端資料庫」之現代架構，保障 API 安全性，並徹底解決跨網域 (CORS) 阻擋。</a:t>
+              <a:t>本專案全程由人類教師提出設計需求，與 AI 助手 Antigravity 協同編寫程式碼，並透過 GitHub 進行全球發布，最後無痛串接 Google 試算表收單。</a:t>
             </a:r>
           </a:p>
         </p:txBody>
@@ -4077,8 +4077,8 @@
         </p:nvSpPr>
         <p:spPr>
           <a:xfrm>
-            <a:off x="746150" y="2286000"/>
-            <a:ext cx="2468880" cy="3657600"/>
+            <a:off x="791870" y="2286000"/>
+            <a:ext cx="3291840" cy="3657600"/>
           </a:xfrm>
           <a:prstGeom prst="rect">
             <a:avLst/>
@@ -4122,8 +4122,8 @@
         </p:nvSpPr>
         <p:spPr>
           <a:xfrm>
-            <a:off x="883310" y="2468880"/>
-            <a:ext cx="2194560" cy="3291840"/>
+            <a:off x="974750" y="2514600"/>
+            <a:ext cx="2926080" cy="3200400"/>
           </a:xfrm>
           <a:prstGeom prst="rect">
             <a:avLst/>
@@ -4138,9 +4138,9 @@
           <a:p>
             <a:pPr>
               <a:spcAft>
-                <a:spcPts val="400"/>
-              </a:spcAft>
-              <a:defRPr sz="1500" b="1">
+                <a:spcPts val="600"/>
+              </a:spcAft>
+              <a:defRPr sz="1600" b="1">
                 <a:solidFill>
                   <a:srgbClr val="0284C7"/>
                 </a:solidFill>
@@ -4148,15 +4148,15 @@
               </a:defRPr>
             </a:pPr>
             <a:r>
-              <a:t>1. 前端靜態頁面</a:t>
-            </a:r>
-          </a:p>
-          <a:p>
-            <a:pPr>
-              <a:spcAft>
-                <a:spcPts val="1200"/>
-              </a:spcAft>
-              <a:defRPr sz="1100" b="1">
+              <a:t>第一階段：AI 助手撰寫程式</a:t>
+            </a:r>
+          </a:p>
+          <a:p>
+            <a:pPr>
+              <a:spcAft>
+                <a:spcPts val="1500"/>
+              </a:spcAft>
+              <a:defRPr sz="1150" b="1">
                 <a:solidFill>
                   <a:srgbClr val="0F172A"/>
                 </a:solidFill>
@@ -4164,15 +4164,15 @@
               </a:defRPr>
             </a:pPr>
             <a:r>
-              <a:t>GitHub Pages 託管</a:t>
+              <a:t>Antigravity 協同開發</a:t>
             </a:r>
           </a:p>
           <a:p>
             <a:pPr>
               <a:lnSpc>
-                <a:spcPct val="130000"/>
+                <a:spcPct val="135000"/>
               </a:lnSpc>
-              <a:defRPr sz="1100">
+              <a:defRPr sz="1150">
                 <a:solidFill>
                   <a:srgbClr val="475569"/>
                 </a:solidFill>
@@ -4180,7 +4180,7 @@
               </a:defRPr>
             </a:pPr>
             <a:r>
-              <a:t>以相對路徑整合 HTML5 / CSS3 / JS，靜態資源極速載入，免除伺服器維護成本與負載問題。</a:t>
+              <a:t>AI 負責編寫 HTML 簡報版面、互動對比拉桿、闖關遊戲（卡牌配對、字數防呆驗證及對話排序）的全部邏輯程式碼，並優化響應式排版。</a:t>
             </a:r>
           </a:p>
         </p:txBody>
@@ -4193,8 +4193,8 @@
         </p:nvSpPr>
         <p:spPr>
           <a:xfrm>
-            <a:off x="3489350" y="2286000"/>
-            <a:ext cx="2468880" cy="3657600"/>
+            <a:off x="4449470" y="2286000"/>
+            <a:ext cx="3291840" cy="3657600"/>
           </a:xfrm>
           <a:prstGeom prst="rect">
             <a:avLst/>
@@ -4238,8 +4238,8 @@
         </p:nvSpPr>
         <p:spPr>
           <a:xfrm>
-            <a:off x="3626510" y="2468880"/>
-            <a:ext cx="2194560" cy="3291840"/>
+            <a:off x="4632350" y="2514600"/>
+            <a:ext cx="2926080" cy="3200400"/>
           </a:xfrm>
           <a:prstGeom prst="rect">
             <a:avLst/>
@@ -4254,9 +4254,9 @@
           <a:p>
             <a:pPr>
               <a:spcAft>
-                <a:spcPts val="400"/>
-              </a:spcAft>
-              <a:defRPr sz="1500" b="1">
+                <a:spcPts val="600"/>
+              </a:spcAft>
+              <a:defRPr sz="1600" b="1">
                 <a:solidFill>
                   <a:srgbClr val="7E22CE"/>
                 </a:solidFill>
@@ -4264,15 +4264,15 @@
               </a:defRPr>
             </a:pPr>
             <a:r>
-              <a:t>2. 安全 API 請求</a:t>
-            </a:r>
-          </a:p>
-          <a:p>
-            <a:pPr>
-              <a:spcAft>
-                <a:spcPts val="1200"/>
-              </a:spcAft>
-              <a:defRPr sz="1100" b="1">
+              <a:t>第二階段：GitHub 雲端發布</a:t>
+            </a:r>
+          </a:p>
+          <a:p>
+            <a:pPr>
+              <a:spcAft>
+                <a:spcPts val="1500"/>
+              </a:spcAft>
+              <a:defRPr sz="1150" b="1">
                 <a:solidFill>
                   <a:srgbClr val="0F172A"/>
                 </a:solidFill>
@@ -4280,15 +4280,15 @@
               </a:defRPr>
             </a:pPr>
             <a:r>
-              <a:t>HTTPS POST (no-cors)</a:t>
+              <a:t>免費且極速的網站託管</a:t>
             </a:r>
           </a:p>
           <a:p>
             <a:pPr>
               <a:lnSpc>
-                <a:spcPct val="130000"/>
+                <a:spcPct val="135000"/>
               </a:lnSpc>
-              <a:defRPr sz="1100">
+              <a:defRPr sz="1150">
                 <a:solidFill>
                   <a:srgbClr val="475569"/>
                 </a:solidFill>
@@ -4296,7 +4296,7 @@
               </a:defRPr>
             </a:pPr>
             <a:r>
-              <a:t>ConfigManager 將數據打包為 JSON，使用 no-cors 模式發送，避免瀏覽器 Pre-flight OPTIONS 安全阻擋。</a:t>
+              <a:t>將寫好的網頁檔案推送到 GitHub 雲端倉庫，啟用 GitHub Pages 服務，將程式碼一秒變成全世界都能用瀏覽器點開的「正式網站」。</a:t>
             </a:r>
           </a:p>
         </p:txBody>
@@ -4309,8 +4309,8 @@
         </p:nvSpPr>
         <p:spPr>
           <a:xfrm>
-            <a:off x="6232550" y="2286000"/>
-            <a:ext cx="2468880" cy="3657600"/>
+            <a:off x="8107070" y="2286000"/>
+            <a:ext cx="3291840" cy="3657600"/>
           </a:xfrm>
           <a:prstGeom prst="rect">
             <a:avLst/>
@@ -4320,7 +4320,7 @@
           </a:solidFill>
           <a:ln w="19050">
             <a:solidFill>
-              <a:srgbClr val="0284C7"/>
+              <a:srgbClr val="D97706"/>
             </a:solidFill>
           </a:ln>
         </p:spPr>
@@ -4354,8 +4354,8 @@
         </p:nvSpPr>
         <p:spPr>
           <a:xfrm>
-            <a:off x="6369710" y="2468880"/>
-            <a:ext cx="2194560" cy="3291840"/>
+            <a:off x="8289950" y="2514600"/>
+            <a:ext cx="2926080" cy="3200400"/>
           </a:xfrm>
           <a:prstGeom prst="rect">
             <a:avLst/>
@@ -4370,25 +4370,25 @@
           <a:p>
             <a:pPr>
               <a:spcAft>
-                <a:spcPts val="400"/>
-              </a:spcAft>
-              <a:defRPr sz="1500" b="1">
-                <a:solidFill>
-                  <a:srgbClr val="0284C7"/>
-                </a:solidFill>
-                <a:latin typeface="Microsoft JhengHei"/>
-              </a:defRPr>
-            </a:pPr>
-            <a:r>
-              <a:t>3. 中繼處理引擎</a:t>
-            </a:r>
-          </a:p>
-          <a:p>
-            <a:pPr>
-              <a:spcAft>
-                <a:spcPts val="1200"/>
-              </a:spcAft>
-              <a:defRPr sz="1100" b="1">
+                <a:spcPts val="600"/>
+              </a:spcAft>
+              <a:defRPr sz="1600" b="1">
+                <a:solidFill>
+                  <a:srgbClr val="D97706"/>
+                </a:solidFill>
+                <a:latin typeface="Microsoft JhengHei"/>
+              </a:defRPr>
+            </a:pPr>
+            <a:r>
+              <a:t>第三階段：Google 試算表串接</a:t>
+            </a:r>
+          </a:p>
+          <a:p>
+            <a:pPr>
+              <a:spcAft>
+                <a:spcPts val="1500"/>
+              </a:spcAft>
+              <a:defRPr sz="1150" b="1">
                 <a:solidFill>
                   <a:srgbClr val="0F172A"/>
                 </a:solidFill>
@@ -4396,15 +4396,15 @@
               </a:defRPr>
             </a:pPr>
             <a:r>
-              <a:t>Google Apps Script</a:t>
+              <a:t>免伺服器的輕量資料庫</a:t>
             </a:r>
           </a:p>
           <a:p>
             <a:pPr>
               <a:lnSpc>
-                <a:spcPct val="130000"/>
+                <a:spcPct val="135000"/>
               </a:lnSpc>
-              <a:defRPr sz="1100">
+              <a:defRPr sz="1150">
                 <a:solidFill>
                   <a:srgbClr val="475569"/>
                 </a:solidFill>
@@ -4412,123 +4412,7 @@
               </a:defRPr>
             </a:pPr>
             <a:r>
-              <a:t>執行部署為 Web App 的 Code.gs，以「版主帳號執行」權限寫入 Sheet，保護 API 金鑰不外洩。</a:t>
-            </a:r>
-          </a:p>
-        </p:txBody>
-      </p:sp>
-      <p:sp>
-        <p:nvSpPr>
-          <p:cNvPr id="12" name="Rectangle 11"/>
-          <p:cNvSpPr/>
-          <p:nvPr/>
-        </p:nvSpPr>
-        <p:spPr>
-          <a:xfrm>
-            <a:off x="8975750" y="2286000"/>
-            <a:ext cx="2468880" cy="3657600"/>
-          </a:xfrm>
-          <a:prstGeom prst="rect">
-            <a:avLst/>
-          </a:prstGeom>
-          <a:solidFill>
-            <a:srgbClr val="FFFFFF"/>
-          </a:solidFill>
-          <a:ln w="19050">
-            <a:solidFill>
-              <a:srgbClr val="7E22CE"/>
-            </a:solidFill>
-          </a:ln>
-        </p:spPr>
-        <p:style>
-          <a:lnRef idx="1">
-            <a:schemeClr val="accent1"/>
-          </a:lnRef>
-          <a:fillRef idx="3">
-            <a:schemeClr val="accent1"/>
-          </a:fillRef>
-          <a:effectRef idx="2">
-            <a:schemeClr val="accent1"/>
-          </a:effectRef>
-          <a:fontRef idx="minor">
-            <a:schemeClr val="lt1"/>
-          </a:fontRef>
-        </p:style>
-        <p:txBody>
-          <a:bodyPr rtlCol="0" anchor="ctr"/>
-          <a:lstStyle/>
-          <a:p>
-            <a:pPr algn="ctr"/>
-          </a:p>
-        </p:txBody>
-      </p:sp>
-      <p:sp>
-        <p:nvSpPr>
-          <p:cNvPr id="13" name="TextBox 12"/>
-          <p:cNvSpPr txBox="1"/>
-          <p:nvPr/>
-        </p:nvSpPr>
-        <p:spPr>
-          <a:xfrm>
-            <a:off x="9112910" y="2468880"/>
-            <a:ext cx="2194560" cy="3291840"/>
-          </a:xfrm>
-          <a:prstGeom prst="rect">
-            <a:avLst/>
-          </a:prstGeom>
-          <a:noFill/>
-        </p:spPr>
-        <p:txBody>
-          <a:bodyPr wrap="square">
-            <a:spAutoFit/>
-          </a:bodyPr>
-          <a:lstStyle/>
-          <a:p>
-            <a:pPr>
-              <a:spcAft>
-                <a:spcPts val="400"/>
-              </a:spcAft>
-              <a:defRPr sz="1500" b="1">
-                <a:solidFill>
-                  <a:srgbClr val="7E22CE"/>
-                </a:solidFill>
-                <a:latin typeface="Microsoft JhengHei"/>
-              </a:defRPr>
-            </a:pPr>
-            <a:r>
-              <a:t>4. 雲端資料庫</a:t>
-            </a:r>
-          </a:p>
-          <a:p>
-            <a:pPr>
-              <a:spcAft>
-                <a:spcPts val="1200"/>
-              </a:spcAft>
-              <a:defRPr sz="1100" b="1">
-                <a:solidFill>
-                  <a:srgbClr val="0F172A"/>
-                </a:solidFill>
-                <a:latin typeface="Microsoft JhengHei"/>
-              </a:defRPr>
-            </a:pPr>
-            <a:r>
-              <a:t>Google Sheet 試算表</a:t>
-            </a:r>
-          </a:p>
-          <a:p>
-            <a:pPr>
-              <a:lnSpc>
-                <a:spcPct val="130000"/>
-              </a:lnSpc>
-              <a:defRPr sz="1100">
-                <a:solidFill>
-                  <a:srgbClr val="475569"/>
-                </a:solidFill>
-                <a:latin typeface="Microsoft JhengHei"/>
-              </a:defRPr>
-            </a:pPr>
-            <a:r>
-              <a:t>自動新增 slides_feedback 與 game_scores 工作表，支援自動表頭遷移與防呆資料列追加。</a:t>
+              <a:t>利用 Google 試算表內建的 Apps Script 作為收信郵差，讓網頁上的答題與遊戲數據在「不暴露出密碼金鑰」的安全狀態下自動存檔。</a:t>
             </a:r>
           </a:p>
         </p:txBody>
@@ -4590,7 +4474,7 @@
               </a:defRPr>
             </a:pPr>
             <a:r>
-              <a:t>CRC 專案開發與後端串接手冊</a:t>
+              <a:t>人機協同開發與雲端串接手冊</a:t>
             </a:r>
           </a:p>
         </p:txBody>
@@ -4626,7 +4510,7 @@
               </a:defRPr>
             </a:pPr>
             <a:r>
-              <a:t>簡報系統開發：左目錄側欄與身份登錄機制</a:t>
+              <a:t>第一階段：AI 助手 Antigravity 撰寫網頁程式碼</a:t>
             </a:r>
           </a:p>
         </p:txBody>
@@ -4753,7 +4637,7 @@
               </a:defRPr>
             </a:pPr>
             <a:r>
-              <a:t>🛠️ 簡報頁面重構與技術實作</a:t>
+              <a:t>🤖 AI 協同開發的成果清單</a:t>
             </a:r>
           </a:p>
           <a:p>
@@ -4769,7 +4653,7 @@
               </a:defRPr>
             </a:pPr>
             <a:r>
-              <a:t>✔ 嵌入式 Reveal.js 簡報框架</a:t>
+              <a:t>✔ 學生身份強制登錄</a:t>
             </a:r>
           </a:p>
           <a:p>
@@ -4785,7 +4669,7 @@
               </a:defRPr>
             </a:pPr>
             <a:r>
-              <a:t>   將簡報初始化參數 `embedded` 設為 `true`，精準限制在右側展示視窗內，留出左側固定排版。</a:t>
+              <a:t>   AI 寫了個浮動登錄框，要求學生輸入姓名與科系，存入網頁暫存中。沒輸入的話，鍵盤翻頁會被鎖住。</a:t>
             </a:r>
           </a:p>
           <a:p>
@@ -4801,7 +4685,7 @@
               </a:defRPr>
             </a:pPr>
             <a:r>
-              <a:t>✔ 左側同步導覽目錄實作</a:t>
+              <a:t>✔ 左右滑動對比拉桿</a:t>
             </a:r>
           </a:p>
           <a:p>
@@ -4817,7 +4701,7 @@
               </a:defRPr>
             </a:pPr>
             <a:r>
-              <a:t>   利用 JS 歷遍 50 頁 section 標題動態生成左側 TOC。綁定 slidechanged 事件，自動高亮與滾動目錄。</a:t>
+              <a:t>   利用 CSS 疊層與 JS 拖曳事件，實現滑動拉桿時「威權校園」覆蓋底層「人權校園」的即時剪裁視覺特效。</a:t>
             </a:r>
           </a:p>
           <a:p>
@@ -4833,7 +4717,7 @@
               </a:defRPr>
             </a:pPr>
             <a:r>
-              <a:t>✔ 身份登錄防跳過機制</a:t>
+              <a:t>✔ 四階段遊戲邏輯撰寫</a:t>
             </a:r>
           </a:p>
           <a:p>
@@ -4849,7 +4733,7 @@
               </a:defRPr>
             </a:pPr>
             <a:r>
-              <a:t>   開頁彈出 Glassmorphism 登錄框，強制輸入姓名系級。未登錄前鎖定鍵盤，並將個資存於 sessionStorage。</a:t>
+              <a:t>   AI 實作了單選題、卡牌連線配對（解決手機端不好拖放卡牌的點擊問題）、答題日誌及對話步驟排序演算法。</a:t>
             </a:r>
           </a:p>
           <a:p>
@@ -4865,7 +4749,7 @@
               </a:defRPr>
             </a:pPr>
             <a:r>
-              <a:t>✔ 討論題 no-cors 即時寫入</a:t>
+              <a:t>✔ 防呆與字數限制</a:t>
             </a:r>
           </a:p>
           <a:p>
@@ -4881,7 +4765,7 @@
               </a:defRPr>
             </a:pPr>
             <a:r>
-              <a:t>   六道討論題打包為『素養討論一~六』。學生點擊送出即自動組合個資傳送至 Sheet 進行寫入。</a:t>
+              <a:t>   針對第三關規章體檢簡答題，AI 寫了即時字數檢查，少於 50 字會封鎖按鈕並提示，保證師培生用心反思。</a:t>
             </a:r>
           </a:p>
         </p:txBody>
@@ -4965,7 +4849,7 @@
               </a:defRPr>
             </a:pPr>
             <a:r>
-              <a:t>📋 核心代碼架構參考 (JavaScript)</a:t>
+              <a:t>📋 AI 撰寫的拉桿即時更新排版代碼</a:t>
             </a:r>
           </a:p>
           <a:p>
@@ -4981,7 +4865,7 @@
               </a:defRPr>
             </a:pPr>
             <a:r>
-              <a:t>// 1. 初始化 Reveal.js 嵌入簡報</a:t>
+              <a:t>// AI 設計的拖拉滑動百分比計算</a:t>
             </a:r>
           </a:p>
           <a:p>
@@ -4997,7 +4881,7 @@
               </a:defRPr>
             </a:pPr>
             <a:r>
-              <a:t>Reveal.initialize({ embedded: true, controls: true });</a:t>
+              <a:t>function moveSlider(clientX) {</a:t>
             </a:r>
           </a:p>
           <a:p>
@@ -5012,6 +4896,9 @@
                 <a:latin typeface="Consolas"/>
               </a:defRPr>
             </a:pPr>
+            <a:r>
+              <a:t>  const rect = box.getBoundingClientRect();</a:t>
+            </a:r>
           </a:p>
           <a:p>
             <a:pPr>
@@ -5020,13 +4907,29 @@
               </a:spcAft>
               <a:defRPr sz="1000">
                 <a:solidFill>
+                  <a:srgbClr val="E2E8F0"/>
+                </a:solidFill>
+                <a:latin typeface="Consolas"/>
+              </a:defRPr>
+            </a:pPr>
+            <a:r>
+              <a:t>  let percent = ((clientX - rect.left) / rect.width) * 100;</a:t>
+            </a:r>
+          </a:p>
+          <a:p>
+            <a:pPr>
+              <a:spcAft>
+                <a:spcPts val="200"/>
+              </a:spcAft>
+              <a:defRPr sz="1000">
+                <a:solidFill>
                   <a:srgbClr val="94A3B8"/>
                 </a:solidFill>
                 <a:latin typeface="Consolas"/>
               </a:defRPr>
             </a:pPr>
             <a:r>
-              <a:t>// 2. 身份登錄控制與 Session 鎖定</a:t>
+              <a:t>  // 限制極限，避免把手拉出框外</a:t>
             </a:r>
           </a:p>
           <a:p>
@@ -5042,7 +4945,7 @@
               </a:defRPr>
             </a:pPr>
             <a:r>
-              <a:t>function closeAuthModal(name, dept) {</a:t>
+              <a:t>  percent = Math.max(3, Math.min(97, percent));</a:t>
             </a:r>
           </a:p>
           <a:p>
@@ -5058,7 +4961,7 @@
               </a:defRPr>
             </a:pPr>
             <a:r>
-              <a:t>  sessionStorage.setItem('name', name);</a:t>
+              <a:t>  handle.style.left = `${percent}%`;</a:t>
             </a:r>
           </a:p>
           <a:p>
@@ -5068,13 +4971,58 @@
               </a:spcAft>
               <a:defRPr sz="1000">
                 <a:solidFill>
+                  <a:srgbClr val="C084FC"/>
+                </a:solidFill>
+                <a:latin typeface="Consolas"/>
+              </a:defRPr>
+            </a:pPr>
+            <a:r>
+              <a:t>  beforePanel.style.width = `${percent}%`; // 遮罩寬度</a:t>
+            </a:r>
+          </a:p>
+          <a:p>
+            <a:pPr>
+              <a:spcAft>
+                <a:spcPts val="200"/>
+              </a:spcAft>
+              <a:defRPr sz="1000">
+                <a:solidFill>
+                  <a:srgbClr val="E2E8F0"/>
+                </a:solidFill>
+                <a:latin typeface="Consolas"/>
+              </a:defRPr>
+            </a:pPr>
+            <a:r>
+              <a:t>}</a:t>
+            </a:r>
+          </a:p>
+          <a:p>
+            <a:pPr>
+              <a:spcAft>
+                <a:spcPts val="200"/>
+              </a:spcAft>
+              <a:defRPr sz="1000">
+                <a:solidFill>
+                  <a:srgbClr val="E2E8F0"/>
+                </a:solidFill>
+                <a:latin typeface="Consolas"/>
+              </a:defRPr>
+            </a:pPr>
+          </a:p>
+          <a:p>
+            <a:pPr>
+              <a:spcAft>
+                <a:spcPts val="200"/>
+              </a:spcAft>
+              <a:defRPr sz="1000">
+                <a:solidFill>
                   <a:srgbClr val="94A3B8"/>
                 </a:solidFill>
                 <a:latin typeface="Consolas"/>
               </a:defRPr>
             </a:pPr>
             <a:r>
-              <a:t>  Reveal.configure({ keyboard: true }); // 解鎖鍵盤</a:t>
+              <a:t>// 用於簡報與遊戲的統一傳輸模組</a:t>
             </a:r>
           </a:p>
           <a:p>
@@ -5084,90 +5032,13 @@
               </a:spcAft>
               <a:defRPr sz="1000">
                 <a:solidFill>
-                  <a:srgbClr val="E2E8F0"/>
+                  <a:srgbClr val="C084FC"/>
                 </a:solidFill>
                 <a:latin typeface="Consolas"/>
               </a:defRPr>
             </a:pPr>
             <a:r>
-              <a:t>}</a:t>
-            </a:r>
-          </a:p>
-          <a:p>
-            <a:pPr>
-              <a:spcAft>
-                <a:spcPts val="200"/>
-              </a:spcAft>
-              <a:defRPr sz="1000">
-                <a:solidFill>
-                  <a:srgbClr val="E2E8F0"/>
-                </a:solidFill>
-                <a:latin typeface="Consolas"/>
-              </a:defRPr>
-            </a:pPr>
-          </a:p>
-          <a:p>
-            <a:pPr>
-              <a:spcAft>
-                <a:spcPts val="200"/>
-              </a:spcAft>
-              <a:defRPr sz="1000">
-                <a:solidFill>
-                  <a:srgbClr val="94A3B8"/>
-                </a:solidFill>
-                <a:latin typeface="Consolas"/>
-              </a:defRPr>
-            </a:pPr>
-            <a:r>
-              <a:t>// 3. 簡報反思資料 no-cors 傳送</a:t>
-            </a:r>
-          </a:p>
-          <a:p>
-            <a:pPr>
-              <a:spcAft>
-                <a:spcPts val="200"/>
-              </a:spcAft>
-              <a:defRPr sz="1000">
-                <a:solidFill>
-                  <a:srgbClr val="E2E8F0"/>
-                </a:solidFill>
-                <a:latin typeface="Consolas"/>
-              </a:defRPr>
-            </a:pPr>
-            <a:r>
-              <a:t>const payload = { PlayerName: name, Department: dept,</a:t>
-            </a:r>
-          </a:p>
-          <a:p>
-            <a:pPr>
-              <a:spcAft>
-                <a:spcPts val="200"/>
-              </a:spcAft>
-              <a:defRPr sz="1000">
-                <a:solidFill>
-                  <a:srgbClr val="E2E8F0"/>
-                </a:solidFill>
-                <a:latin typeface="Consolas"/>
-              </a:defRPr>
-            </a:pPr>
-            <a:r>
-              <a:t>  SlideNumber: num, ResponseText: text };</a:t>
-            </a:r>
-          </a:p>
-          <a:p>
-            <a:pPr>
-              <a:spcAft>
-                <a:spcPts val="200"/>
-              </a:spcAft>
-              <a:defRPr sz="1000">
-                <a:solidFill>
-                  <a:srgbClr val="C084FC"/>
-                </a:solidFill>
-                <a:latin typeface="Consolas"/>
-              </a:defRPr>
-            </a:pPr>
-            <a:r>
-              <a:t>ConfigManager.sendData('slides_feedback', payload);</a:t>
+              <a:t>ConfigManager.sendData('game_scores', payload);</a:t>
             </a:r>
           </a:p>
         </p:txBody>
@@ -5229,7 +5100,7 @@
               </a:defRPr>
             </a:pPr>
             <a:r>
-              <a:t>CRC 專案開發與後端串接手冊</a:t>
+              <a:t>人機協同開發與雲端串接手冊</a:t>
             </a:r>
           </a:p>
         </p:txBody>
@@ -5265,7 +5136,7 @@
               </a:defRPr>
             </a:pPr>
             <a:r>
-              <a:t>簡報互動對比拉桿：『沒有 CRC』覆蓋『有 CRC』</a:t>
+              <a:t>第二階段：GitHub 雲端版本控制與免費網站發布</a:t>
             </a:r>
           </a:p>
         </p:txBody>
@@ -5322,7 +5193,203 @@
         <p:spPr>
           <a:xfrm>
             <a:off x="685800" y="1645920"/>
-            <a:ext cx="10789920" cy="2194560"/>
+            <a:ext cx="5303520" cy="4480560"/>
+          </a:xfrm>
+          <a:prstGeom prst="rect">
+            <a:avLst/>
+          </a:prstGeom>
+          <a:solidFill>
+            <a:srgbClr val="FFFFFF"/>
+          </a:solidFill>
+          <a:ln w="19050">
+            <a:solidFill>
+              <a:srgbClr val="7E22CE"/>
+            </a:solidFill>
+          </a:ln>
+        </p:spPr>
+        <p:style>
+          <a:lnRef idx="1">
+            <a:schemeClr val="accent1"/>
+          </a:lnRef>
+          <a:fillRef idx="3">
+            <a:schemeClr val="accent1"/>
+          </a:fillRef>
+          <a:effectRef idx="2">
+            <a:schemeClr val="accent1"/>
+          </a:effectRef>
+          <a:fontRef idx="minor">
+            <a:schemeClr val="lt1"/>
+          </a:fontRef>
+        </p:style>
+        <p:txBody>
+          <a:bodyPr rtlCol="0" anchor="ctr"/>
+          <a:lstStyle/>
+          <a:p>
+            <a:pPr algn="ctr"/>
+          </a:p>
+        </p:txBody>
+      </p:sp>
+      <p:sp>
+        <p:nvSpPr>
+          <p:cNvPr id="6" name="TextBox 5"/>
+          <p:cNvSpPr txBox="1"/>
+          <p:nvPr/>
+        </p:nvSpPr>
+        <p:spPr>
+          <a:xfrm>
+            <a:off x="960120" y="1828800"/>
+            <a:ext cx="4754880" cy="4114800"/>
+          </a:xfrm>
+          <a:prstGeom prst="rect">
+            <a:avLst/>
+          </a:prstGeom>
+          <a:noFill/>
+        </p:spPr>
+        <p:txBody>
+          <a:bodyPr wrap="square">
+            <a:spAutoFit/>
+          </a:bodyPr>
+          <a:lstStyle/>
+          <a:p>
+            <a:pPr>
+              <a:spcAft>
+                <a:spcPts val="1200"/>
+              </a:spcAft>
+              <a:defRPr sz="1800" b="1">
+                <a:solidFill>
+                  <a:srgbClr val="7E22CE"/>
+                </a:solidFill>
+                <a:latin typeface="Microsoft JhengHei"/>
+              </a:defRPr>
+            </a:pPr>
+            <a:r>
+              <a:t>🚀 什麼是 GitHub 串接與發布？</a:t>
+            </a:r>
+          </a:p>
+          <a:p>
+            <a:pPr>
+              <a:spcAft>
+                <a:spcPts val="1000"/>
+              </a:spcAft>
+              <a:defRPr sz="1300">
+                <a:solidFill>
+                  <a:srgbClr val="0F172A"/>
+                </a:solidFill>
+                <a:latin typeface="Microsoft JhengHei"/>
+              </a:defRPr>
+            </a:pPr>
+            <a:r>
+              <a:t>寫好的網頁程式碼只放在自己電腦裡，別人是看不到的。所以我們需要把程式碼上傳到 GitHub，並用它免費的「Pages（網頁發布）」功能，變成公開網站：</a:t>
+            </a:r>
+          </a:p>
+          <a:p>
+            <a:pPr>
+              <a:spcAft>
+                <a:spcPts val="100"/>
+              </a:spcAft>
+              <a:defRPr sz="1250" b="1">
+                <a:solidFill>
+                  <a:srgbClr val="0F172A"/>
+                </a:solidFill>
+                <a:latin typeface="Microsoft JhengHei"/>
+              </a:defRPr>
+            </a:pPr>
+            <a:r>
+              <a:t>▪ 建立 GitHub 雲端倉庫 (Repository)</a:t>
+            </a:r>
+          </a:p>
+          <a:p>
+            <a:pPr>
+              <a:spcAft>
+                <a:spcPts val="600"/>
+              </a:spcAft>
+              <a:defRPr sz="1100">
+                <a:solidFill>
+                  <a:srgbClr val="475569"/>
+                </a:solidFill>
+                <a:latin typeface="Microsoft JhengHei"/>
+              </a:defRPr>
+            </a:pPr>
+            <a:r>
+              <a:t>在 GitHub 帳號下建立一個名為 `CRC2026` 的公開倉庫，用來存放簡報與遊戲的全部程式碼。</a:t>
+            </a:r>
+          </a:p>
+          <a:p>
+            <a:pPr>
+              <a:spcAft>
+                <a:spcPts val="100"/>
+              </a:spcAft>
+              <a:defRPr sz="1250" b="1">
+                <a:solidFill>
+                  <a:srgbClr val="0F172A"/>
+                </a:solidFill>
+                <a:latin typeface="Microsoft JhengHei"/>
+              </a:defRPr>
+            </a:pPr>
+            <a:r>
+              <a:t>▪ 推送本地程式碼至雲端</a:t>
+            </a:r>
+          </a:p>
+          <a:p>
+            <a:pPr>
+              <a:spcAft>
+                <a:spcPts val="600"/>
+              </a:spcAft>
+              <a:defRPr sz="1100">
+                <a:solidFill>
+                  <a:srgbClr val="475569"/>
+                </a:solidFill>
+                <a:latin typeface="Microsoft JhengHei"/>
+              </a:defRPr>
+            </a:pPr>
+            <a:r>
+              <a:t>在電腦終端機執行 `git push` 指令，將本機的 HTML/CSS/JS/GS 檔案上傳到 GitHub。</a:t>
+            </a:r>
+          </a:p>
+          <a:p>
+            <a:pPr>
+              <a:spcAft>
+                <a:spcPts val="100"/>
+              </a:spcAft>
+              <a:defRPr sz="1250" b="1">
+                <a:solidFill>
+                  <a:srgbClr val="0F172A"/>
+                </a:solidFill>
+                <a:latin typeface="Microsoft JhengHei"/>
+              </a:defRPr>
+            </a:pPr>
+            <a:r>
+              <a:t>▪ 啟用 GitHub Pages 靜態網站服務</a:t>
+            </a:r>
+          </a:p>
+          <a:p>
+            <a:pPr>
+              <a:spcAft>
+                <a:spcPts val="600"/>
+              </a:spcAft>
+              <a:defRPr sz="1100">
+                <a:solidFill>
+                  <a:srgbClr val="475569"/>
+                </a:solidFill>
+                <a:latin typeface="Microsoft JhengHei"/>
+              </a:defRPr>
+            </a:pPr>
+            <a:r>
+              <a:t>至倉庫設定中的 Pages 區塊，選取 `main` 分支並保存。GitHub 會自動生成一個 HTTPS 免費專屬網址。</a:t>
+            </a:r>
+          </a:p>
+        </p:txBody>
+      </p:sp>
+      <p:sp>
+        <p:nvSpPr>
+          <p:cNvPr id="7" name="Rectangle 6"/>
+          <p:cNvSpPr/>
+          <p:nvPr/>
+        </p:nvSpPr>
+        <p:spPr>
+          <a:xfrm>
+            <a:off x="6217920" y="1645920"/>
+            <a:ext cx="5257800" cy="4480560"/>
           </a:xfrm>
           <a:prstGeom prst="rect">
             <a:avLst/>
@@ -5360,14 +5427,14 @@
       </p:sp>
       <p:sp>
         <p:nvSpPr>
-          <p:cNvPr id="6" name="TextBox 5"/>
+          <p:cNvPr id="8" name="TextBox 7"/>
           <p:cNvSpPr txBox="1"/>
           <p:nvPr/>
         </p:nvSpPr>
         <p:spPr>
           <a:xfrm>
-            <a:off x="960120" y="1828800"/>
-            <a:ext cx="10241280" cy="1828800"/>
+            <a:off x="6492240" y="1828800"/>
+            <a:ext cx="4709160" cy="4114800"/>
           </a:xfrm>
           <a:prstGeom prst="rect">
             <a:avLst/>
@@ -5382,9 +5449,9 @@
           <a:p>
             <a:pPr>
               <a:spcAft>
-                <a:spcPts val="800"/>
-              </a:spcAft>
-              <a:defRPr sz="1800" b="1">
+                <a:spcPts val="1500"/>
+              </a:spcAft>
+              <a:defRPr sz="1700" b="1">
                 <a:solidFill>
                   <a:srgbClr val="0284C7"/>
                 </a:solidFill>
@@ -5392,13 +5459,13 @@
               </a:defRPr>
             </a:pPr>
             <a:r>
-              <a:t>🎨 雙層 z-index 遮罩與拖曳剪裁邏輯</a:t>
-            </a:r>
-          </a:p>
-          <a:p>
-            <a:pPr>
-              <a:spcAft>
-                <a:spcPts val="800"/>
+              <a:t>🌐 專案發布網址與載入機制</a:t>
+            </a:r>
+          </a:p>
+          <a:p>
+            <a:pPr>
+              <a:spcAft>
+                <a:spcPts val="1500"/>
               </a:spcAft>
               <a:defRPr sz="1250">
                 <a:solidFill>
@@ -5408,7 +5475,36 @@
               </a:defRPr>
             </a:pPr>
             <a:r>
-              <a:t>位於簡報第 13 頁。向右拉動拉桿時，「沒有 CRC (威權校園)」覆蓋蓋住底層「有 CRC (人權校園)」的畫面。我們使用絕對定位與剪裁寬度實作：</a:t>
+              <a:t>本專案已在 GitHub Pages 成功發布，師培生可以使用任何行動載具點開網址：</a:t>
+            </a:r>
+          </a:p>
+          <a:p>
+            <a:pPr>
+              <a:defRPr sz="1300" b="1">
+                <a:solidFill>
+                  <a:srgbClr val="0F172A"/>
+                </a:solidFill>
+                <a:latin typeface="Microsoft JhengHei"/>
+              </a:defRPr>
+            </a:pPr>
+            <a:r>
+              <a:t>🔗 前端平台首頁網址：</a:t>
+            </a:r>
+          </a:p>
+          <a:p>
+            <a:pPr>
+              <a:spcAft>
+                <a:spcPts val="2000"/>
+              </a:spcAft>
+              <a:defRPr sz="1400" b="1">
+                <a:solidFill>
+                  <a:srgbClr val="7E22CE"/>
+                </a:solidFill>
+                <a:latin typeface="Consolas"/>
+              </a:defRPr>
+            </a:pPr>
+            <a:r>
+              <a:t>https://mchung2022.github.io/CRC2026/</a:t>
             </a:r>
           </a:p>
           <a:p>
@@ -5424,211 +5520,11 @@
               </a:defRPr>
             </a:pPr>
             <a:r>
-              <a:t>• 底層 (z-index 1)：有 CRC 面板 (after-panel)，為基準定位，背景與排版固定於右側。</a:t>
+              <a:t>💡 優勢說明：</a:t>
             </a:r>
             <a:br/>
             <a:r>
-              <a:t>• 頂層 (z-index 2)：沒有 CRC 面板 (before-panel)，定位於左側，width 設為 percentage% 並設為 overflow: hidden 防止折行。</a:t>
-            </a:r>
-            <a:br/>
-            <a:r>
-              <a:t>• 拉桿 (z-index 10)：發光拖曳軸，監聽 mousedown 與 touchstart 事件，實時計算滑鼠/手指 X 座標並更新百分比。</a:t>
-            </a:r>
-          </a:p>
-        </p:txBody>
-      </p:sp>
-      <p:sp>
-        <p:nvSpPr>
-          <p:cNvPr id="7" name="Rectangle 6"/>
-          <p:cNvSpPr/>
-          <p:nvPr/>
-        </p:nvSpPr>
-        <p:spPr>
-          <a:xfrm>
-            <a:off x="685800" y="4023360"/>
-            <a:ext cx="10789920" cy="2194560"/>
-          </a:xfrm>
-          <a:prstGeom prst="rect">
-            <a:avLst/>
-          </a:prstGeom>
-          <a:solidFill>
-            <a:srgbClr val="0F172A"/>
-          </a:solidFill>
-          <a:ln w="19050">
-            <a:solidFill>
-              <a:srgbClr val="1E293B"/>
-            </a:solidFill>
-          </a:ln>
-        </p:spPr>
-        <p:style>
-          <a:lnRef idx="1">
-            <a:schemeClr val="accent1"/>
-          </a:lnRef>
-          <a:fillRef idx="3">
-            <a:schemeClr val="accent1"/>
-          </a:fillRef>
-          <a:effectRef idx="2">
-            <a:schemeClr val="accent1"/>
-          </a:effectRef>
-          <a:fontRef idx="minor">
-            <a:schemeClr val="lt1"/>
-          </a:fontRef>
-        </p:style>
-        <p:txBody>
-          <a:bodyPr rtlCol="0" anchor="ctr"/>
-          <a:lstStyle/>
-          <a:p>
-            <a:pPr algn="ctr"/>
-          </a:p>
-        </p:txBody>
-      </p:sp>
-      <p:sp>
-        <p:nvSpPr>
-          <p:cNvPr id="8" name="TextBox 7"/>
-          <p:cNvSpPr txBox="1"/>
-          <p:nvPr/>
-        </p:nvSpPr>
-        <p:spPr>
-          <a:xfrm>
-            <a:off x="960120" y="4114800"/>
-            <a:ext cx="10241280" cy="2011680"/>
-          </a:xfrm>
-          <a:prstGeom prst="rect">
-            <a:avLst/>
-          </a:prstGeom>
-          <a:noFill/>
-        </p:spPr>
-        <p:txBody>
-          <a:bodyPr wrap="square">
-            <a:spAutoFit/>
-          </a:bodyPr>
-          <a:lstStyle/>
-          <a:p>
-            <a:pPr>
-              <a:spcAft>
-                <a:spcPts val="600"/>
-              </a:spcAft>
-              <a:defRPr sz="1400" b="1">
-                <a:solidFill>
-                  <a:srgbClr val="FFFFFF"/>
-                </a:solidFill>
-                <a:latin typeface="Consolas"/>
-              </a:defRPr>
-            </a:pPr>
-            <a:r>
-              <a:t>💻 核心拖動剪裁代碼 (JavaScript)</a:t>
-            </a:r>
-          </a:p>
-          <a:p>
-            <a:pPr>
-              <a:spcAft>
-                <a:spcPts val="200"/>
-              </a:spcAft>
-              <a:defRPr sz="1050">
-                <a:solidFill>
-                  <a:srgbClr val="E2E8F0"/>
-                </a:solidFill>
-                <a:latin typeface="Consolas"/>
-              </a:defRPr>
-            </a:pPr>
-            <a:r>
-              <a:t>function move(clientX) {</a:t>
-            </a:r>
-          </a:p>
-          <a:p>
-            <a:pPr>
-              <a:spcAft>
-                <a:spcPts val="200"/>
-              </a:spcAft>
-              <a:defRPr sz="1050">
-                <a:solidFill>
-                  <a:srgbClr val="E2E8F0"/>
-                </a:solidFill>
-                <a:latin typeface="Consolas"/>
-              </a:defRPr>
-            </a:pPr>
-            <a:r>
-              <a:t>  const rect = container.getBoundingClientRect();</a:t>
-            </a:r>
-          </a:p>
-          <a:p>
-            <a:pPr>
-              <a:spcAft>
-                <a:spcPts val="200"/>
-              </a:spcAft>
-              <a:defRPr sz="1050">
-                <a:solidFill>
-                  <a:srgbClr val="E2E8F0"/>
-                </a:solidFill>
-                <a:latin typeface="Consolas"/>
-              </a:defRPr>
-            </a:pPr>
-            <a:r>
-              <a:t>  let percentage = ((clientX - rect.left) / rect.width) * 100;</a:t>
-            </a:r>
-          </a:p>
-          <a:p>
-            <a:pPr>
-              <a:spcAft>
-                <a:spcPts val="200"/>
-              </a:spcAft>
-              <a:defRPr sz="1050">
-                <a:solidFill>
-                  <a:srgbClr val="94A3B8"/>
-                </a:solidFill>
-                <a:latin typeface="Consolas"/>
-              </a:defRPr>
-            </a:pPr>
-            <a:r>
-              <a:t>  percentage = Math.max(3, Math.min(97, percentage)); // 限制範圍防止拉桿溢出</a:t>
-            </a:r>
-          </a:p>
-          <a:p>
-            <a:pPr>
-              <a:spcAft>
-                <a:spcPts val="200"/>
-              </a:spcAft>
-              <a:defRPr sz="1050">
-                <a:solidFill>
-                  <a:srgbClr val="E2E8F0"/>
-                </a:solidFill>
-                <a:latin typeface="Consolas"/>
-              </a:defRPr>
-            </a:pPr>
-            <a:r>
-              <a:t>  handle.style.left = `${percentage}%`;              // 拉桿定位</a:t>
-            </a:r>
-          </a:p>
-          <a:p>
-            <a:pPr>
-              <a:spcAft>
-                <a:spcPts val="200"/>
-              </a:spcAft>
-              <a:defRPr sz="1050">
-                <a:solidFill>
-                  <a:srgbClr val="38BDF8"/>
-                </a:solidFill>
-                <a:latin typeface="Consolas"/>
-              </a:defRPr>
-            </a:pPr>
-            <a:r>
-              <a:t>  beforePanel.style.width = `${percentage}%`;        // 沒有 CRC 遮罩寬度 (z-index: 2)</a:t>
-            </a:r>
-          </a:p>
-          <a:p>
-            <a:pPr>
-              <a:spcAft>
-                <a:spcPts val="200"/>
-              </a:spcAft>
-              <a:defRPr sz="1050">
-                <a:solidFill>
-                  <a:srgbClr val="E2E8F0"/>
-                </a:solidFill>
-                <a:latin typeface="Consolas"/>
-              </a:defRPr>
-            </a:pPr>
-            <a:r>
-              <a:t>}</a:t>
+              <a:t>GitHub Pages 具備全球加速 (CDN) 功能，數十名學生在教室同時打開網頁進行簡報與遊戲，完全不會造成網頁卡頓，且無伺服器費用。</a:t>
             </a:r>
           </a:p>
         </p:txBody>
@@ -5690,7 +5586,7 @@
               </a:defRPr>
             </a:pPr>
             <a:r>
-              <a:t>CRC 專案開發與後端串接手冊</a:t>
+              <a:t>人機協同開發與雲端串接手冊</a:t>
             </a:r>
           </a:p>
         </p:txBody>
@@ -5726,7 +5622,7 @@
               </a:defRPr>
             </a:pPr>
             <a:r>
-              <a:t>遊戲系統開發：四階段闖關與多樣化題型</a:t>
+              <a:t>第三階段：Google Sheets 後端串接與指令設定</a:t>
             </a:r>
           </a:p>
         </p:txBody>
@@ -5793,7 +5689,7 @@
           </a:solidFill>
           <a:ln w="19050">
             <a:solidFill>
-              <a:srgbClr val="7E22CE"/>
+              <a:srgbClr val="D97706"/>
             </a:solidFill>
           </a:ln>
         </p:spPr>
@@ -5843,17 +5739,17 @@
           <a:p>
             <a:pPr>
               <a:spcAft>
-                <a:spcPts val="1000"/>
-              </a:spcAft>
-              <a:defRPr sz="1700" b="1">
-                <a:solidFill>
-                  <a:srgbClr val="7E22CE"/>
-                </a:solidFill>
-                <a:latin typeface="Microsoft JhengHei"/>
-              </a:defRPr>
-            </a:pPr>
-            <a:r>
-              <a:t>🚩 四關卡防跳關與學習深度設計</a:t>
+                <a:spcPts val="1200"/>
+              </a:spcAft>
+              <a:defRPr sz="1800" b="1">
+                <a:solidFill>
+                  <a:srgbClr val="D97706"/>
+                </a:solidFill>
+                <a:latin typeface="Microsoft JhengHei"/>
+              </a:defRPr>
+            </a:pPr>
+            <a:r>
+              <a:t>📝 建立接收資料的試算表信箱</a:t>
             </a:r>
           </a:p>
           <a:p>
@@ -5869,13 +5765,13 @@
               </a:defRPr>
             </a:pPr>
             <a:r>
-              <a:t>✦ 階段一：法規知識奠基 (單選 + 配對)</a:t>
-            </a:r>
-          </a:p>
-          <a:p>
-            <a:pPr>
-              <a:spcAft>
-                <a:spcPts val="800"/>
+              <a:t>✦ 建立一個全新的空白試算表</a:t>
+            </a:r>
+          </a:p>
+          <a:p>
+            <a:pPr>
+              <a:spcAft>
+                <a:spcPts val="600"/>
               </a:spcAft>
               <a:defRPr sz="1100">
                 <a:solidFill>
@@ -5885,7 +5781,7 @@
               </a:defRPr>
             </a:pPr>
             <a:r>
-              <a:t>進行 4 題選擇與 1 組法規連連看配對。配對將 CRC 第 12、16、28、31 條條文與校園情境對接。</a:t>
+              <a:t>登入 Google 雲端硬碟，新建一個空白試算表。不需要手動建工作表或打欄位，後端程式會自動打理。</a:t>
             </a:r>
           </a:p>
           <a:p>
@@ -5901,13 +5797,13 @@
               </a:defRPr>
             </a:pPr>
             <a:r>
-              <a:t>✦ 階段二：衝突抉擇現場 (情境指標)</a:t>
-            </a:r>
-          </a:p>
-          <a:p>
-            <a:pPr>
-              <a:spcAft>
-                <a:spcPts val="800"/>
+              <a:t>✦ 打開內建的 Apps Script 編輯器</a:t>
+            </a:r>
+          </a:p>
+          <a:p>
+            <a:pPr>
+              <a:spcAft>
+                <a:spcPts val="600"/>
               </a:spcAft>
               <a:defRPr sz="1100">
                 <a:solidFill>
@@ -5917,7 +5813,7 @@
               </a:defRPr>
             </a:pPr>
             <a:r>
-              <a:t>搜包、大衣罰站等情境，導師抉擇後即時扣減/增加 HUD (CRC、秩序、專業) 三項指標並寫入路徑。</a:t>
+              <a:t>在試算表上方的功能選單中，點選「延伸功能」 $_x000D_ightarrow$ 「Apps Script」。這會打開 Google 專用的程式編輯視窗。</a:t>
             </a:r>
           </a:p>
           <a:p>
@@ -5933,13 +5829,13 @@
               </a:defRPr>
             </a:pPr>
             <a:r>
-              <a:t>✦ 階段三：規章體檢批判 (簡答題)</a:t>
-            </a:r>
-          </a:p>
-          <a:p>
-            <a:pPr>
-              <a:spcAft>
-                <a:spcPts val="800"/>
+              <a:t>✦ 複製並貼入 Code.gs 的指令</a:t>
+            </a:r>
+          </a:p>
+          <a:p>
+            <a:pPr>
+              <a:spcAft>
+                <a:spcPts val="600"/>
               </a:spcAft>
               <a:defRPr sz="1100">
                 <a:solidFill>
@@ -5949,7 +5845,7 @@
               </a:defRPr>
             </a:pPr>
             <a:r>
-              <a:t>批判「連坐罰愛校」與「沒收手機至期末」。每題設有 50 字限制，字數不足按鈕禁用，防範應付作答。</a:t>
+              <a:t>清空預設的程式碼，把本專案 `backend/Code.gs` 的內容整份複製貼上。這個程式就是我們的「自動收信郵差」。</a:t>
             </a:r>
           </a:p>
           <a:p>
@@ -5965,13 +5861,13 @@
               </a:defRPr>
             </a:pPr>
             <a:r>
-              <a:t>✦ 階段四：民主共創未來 (排序 + 宣言)</a:t>
-            </a:r>
-          </a:p>
-          <a:p>
-            <a:pPr>
-              <a:spcAft>
-                <a:spcPts val="800"/>
+              <a:t>✦ 點擊儲存以完成準備</a:t>
+            </a:r>
+          </a:p>
+          <a:p>
+            <a:pPr>
+              <a:spcAft>
+                <a:spcPts val="600"/>
               </a:spcAft>
               <a:defRPr sz="1100">
                 <a:solidFill>
@@ -5981,7 +5877,7 @@
               </a:defRPr>
             </a:pPr>
             <a:r>
-              <a:t>排序修復式對話 5 步驟（還原-同理-影響-彌補-行動），並撰寫 30 字班級自治誓言。</a:t>
+              <a:t>點選上方的「儲存」圖示。此時程式已被綁定在此試算表中，隨時待命。</a:t>
             </a:r>
           </a:p>
         </p:txBody>
@@ -6001,11 +5897,11 @@
             <a:avLst/>
           </a:prstGeom>
           <a:solidFill>
-            <a:srgbClr val="FFFFFF"/>
+            <a:srgbClr val="0F172A"/>
           </a:solidFill>
           <a:ln w="19050">
             <a:solidFill>
-              <a:srgbClr val="0284C7"/>
+              <a:srgbClr val="1E293B"/>
             </a:solidFill>
           </a:ln>
         </p:spPr>
@@ -6039,8 +5935,8 @@
         </p:nvSpPr>
         <p:spPr>
           <a:xfrm>
-            <a:off x="6492240" y="1828800"/>
-            <a:ext cx="4709160" cy="4114800"/>
+            <a:off x="6492240" y="1920240"/>
+            <a:ext cx="4709160" cy="3931920"/>
           </a:xfrm>
           <a:prstGeom prst="rect">
             <a:avLst/>
@@ -6055,113 +5951,193 @@
           <a:p>
             <a:pPr>
               <a:spcAft>
-                <a:spcPts val="1200"/>
-              </a:spcAft>
-              <a:defRPr sz="1700" b="1">
-                <a:solidFill>
-                  <a:srgbClr val="0284C7"/>
-                </a:solidFill>
-                <a:latin typeface="Microsoft JhengHei"/>
-              </a:defRPr>
-            </a:pPr>
-            <a:r>
-              <a:t>🎯 多樣題型前端實作控制</a:t>
-            </a:r>
-          </a:p>
-          <a:p>
-            <a:pPr>
-              <a:spcAft>
-                <a:spcPts val="100"/>
+                <a:spcPts val="1000"/>
               </a:spcAft>
               <a:defRPr sz="1250" b="1">
                 <a:solidFill>
-                  <a:srgbClr val="0F172A"/>
-                </a:solidFill>
-                <a:latin typeface="Microsoft JhengHei"/>
-              </a:defRPr>
-            </a:pPr>
-            <a:r>
-              <a:t>▪ 連連看點選配對 (Card Matching)</a:t>
-            </a:r>
-          </a:p>
-          <a:p>
-            <a:pPr>
-              <a:spcAft>
-                <a:spcPts val="800"/>
-              </a:spcAft>
-              <a:defRPr sz="1100">
-                <a:solidFill>
-                  <a:srgbClr val="475569"/>
-                </a:solidFill>
-                <a:latin typeface="Microsoft JhengHei"/>
-              </a:defRPr>
-            </a:pPr>
-            <a:r>
-              <a:t>改採「點選左側卡，再點選右側卡」取代傳統 Drag-and-drop，保證在手機等移動裝置上排版不會因 RWD 而跑位或無法拖曳。</a:t>
-            </a:r>
-          </a:p>
-          <a:p>
-            <a:pPr>
-              <a:spcAft>
-                <a:spcPts val="100"/>
-              </a:spcAft>
-              <a:defRPr sz="1250" b="1">
-                <a:solidFill>
-                  <a:srgbClr val="0F172A"/>
-                </a:solidFill>
-                <a:latin typeface="Microsoft JhengHei"/>
-              </a:defRPr>
-            </a:pPr>
-            <a:r>
-              <a:t>▪ 簡答字數動態驗證 (Validation)</a:t>
-            </a:r>
-          </a:p>
-          <a:p>
-            <a:pPr>
-              <a:spcAft>
-                <a:spcPts val="800"/>
-              </a:spcAft>
-              <a:defRPr sz="1100">
-                <a:solidFill>
-                  <a:srgbClr val="475569"/>
-                </a:solidFill>
-                <a:latin typeface="Microsoft JhengHei"/>
-              </a:defRPr>
-            </a:pPr>
-            <a:r>
-              <a:t>實時監聽 textarea 的 input 事件並計數。字數不足時，Next 按鈕保持 disabled 狀態並動態提示缺少字數，確保寫作品質。</a:t>
-            </a:r>
-          </a:p>
-          <a:p>
-            <a:pPr>
-              <a:spcAft>
-                <a:spcPts val="100"/>
-              </a:spcAft>
-              <a:defRPr sz="1250" b="1">
-                <a:solidFill>
-                  <a:srgbClr val="0F172A"/>
-                </a:solidFill>
-                <a:latin typeface="Microsoft JhengHei"/>
-              </a:defRPr>
-            </a:pPr>
-            <a:r>
-              <a:t>▪ 對話步驟拖動排序 (Sorting Game)</a:t>
-            </a:r>
-          </a:p>
-          <a:p>
-            <a:pPr>
-              <a:spcAft>
-                <a:spcPts val="800"/>
-              </a:spcAft>
-              <a:defRPr sz="1100">
-                <a:solidFill>
-                  <a:srgbClr val="475569"/>
-                </a:solidFill>
-                <a:latin typeface="Microsoft JhengHei"/>
-              </a:defRPr>
-            </a:pPr>
-            <a:r>
-              <a:t>陣列序列化存儲。點選步驟加入 user-list 並動態變色，完全排序後與 correctOrder 比對，答錯可隨時點擊撤回。</a:t>
+                  <a:srgbClr val="FFFFFF"/>
+                </a:solidFill>
+                <a:latin typeface="Consolas"/>
+              </a:defRPr>
+            </a:pPr>
+            <a:r>
+              <a:t>📋 Google Apps Script 自動寫入指令 (Code.gs)</a:t>
+            </a:r>
+          </a:p>
+          <a:p>
+            <a:pPr>
+              <a:spcAft>
+                <a:spcPts val="300"/>
+              </a:spcAft>
+              <a:defRPr sz="1000">
+                <a:solidFill>
+                  <a:srgbClr val="94A3B8"/>
+                </a:solidFill>
+                <a:latin typeface="Consolas"/>
+              </a:defRPr>
+            </a:pPr>
+            <a:r>
+              <a:t>// 當收到網頁發送的 POST 封包時</a:t>
+            </a:r>
+          </a:p>
+          <a:p>
+            <a:pPr>
+              <a:spcAft>
+                <a:spcPts val="300"/>
+              </a:spcAft>
+              <a:defRPr sz="1000">
+                <a:solidFill>
+                  <a:srgbClr val="E2E8F0"/>
+                </a:solidFill>
+                <a:latin typeface="Consolas"/>
+              </a:defRPr>
+            </a:pPr>
+            <a:r>
+              <a:t>function doPost(e) {</a:t>
+            </a:r>
+          </a:p>
+          <a:p>
+            <a:pPr>
+              <a:spcAft>
+                <a:spcPts val="300"/>
+              </a:spcAft>
+              <a:defRPr sz="1000">
+                <a:solidFill>
+                  <a:srgbClr val="E2E8F0"/>
+                </a:solidFill>
+                <a:latin typeface="Consolas"/>
+              </a:defRPr>
+            </a:pPr>
+            <a:r>
+              <a:t>  var requestData = JSON.parse(e.postData.contents);</a:t>
+            </a:r>
+          </a:p>
+          <a:p>
+            <a:pPr>
+              <a:spcAft>
+                <a:spcPts val="300"/>
+              </a:spcAft>
+              <a:defRPr sz="1000">
+                <a:solidFill>
+                  <a:srgbClr val="E2E8F0"/>
+                </a:solidFill>
+                <a:latin typeface="Consolas"/>
+              </a:defRPr>
+            </a:pPr>
+            <a:r>
+              <a:t>  var sheetName = requestData.sheetName;</a:t>
+            </a:r>
+          </a:p>
+          <a:p>
+            <a:pPr>
+              <a:spcAft>
+                <a:spcPts val="300"/>
+              </a:spcAft>
+              <a:defRPr sz="1000">
+                <a:solidFill>
+                  <a:srgbClr val="E2E8F0"/>
+                </a:solidFill>
+                <a:latin typeface="Consolas"/>
+              </a:defRPr>
+            </a:pPr>
+            <a:r>
+              <a:t>  var payload = requestData.data;</a:t>
+            </a:r>
+          </a:p>
+          <a:p>
+            <a:pPr>
+              <a:spcAft>
+                <a:spcPts val="300"/>
+              </a:spcAft>
+              <a:defRPr sz="1000">
+                <a:solidFill>
+                  <a:srgbClr val="E2E8F0"/>
+                </a:solidFill>
+                <a:latin typeface="Consolas"/>
+              </a:defRPr>
+            </a:pPr>
+            <a:r>
+              <a:t>  </a:t>
+            </a:r>
+          </a:p>
+          <a:p>
+            <a:pPr>
+              <a:spcAft>
+                <a:spcPts val="300"/>
+              </a:spcAft>
+              <a:defRPr sz="1000">
+                <a:solidFill>
+                  <a:srgbClr val="94A3B8"/>
+                </a:solidFill>
+                <a:latin typeface="Consolas"/>
+              </a:defRPr>
+            </a:pPr>
+            <a:r>
+              <a:t>  // 呼叫寫入函數，自動將資料寫入對應的工作表</a:t>
+            </a:r>
+          </a:p>
+          <a:p>
+            <a:pPr>
+              <a:spcAft>
+                <a:spcPts val="300"/>
+              </a:spcAft>
+              <a:defRPr sz="1000">
+                <a:solidFill>
+                  <a:srgbClr val="C084FC"/>
+                </a:solidFill>
+                <a:latin typeface="Consolas"/>
+              </a:defRPr>
+            </a:pPr>
+            <a:r>
+              <a:t>  var result = addDataToSheet(sheetName, payload);</a:t>
+            </a:r>
+          </a:p>
+          <a:p>
+            <a:pPr>
+              <a:spcAft>
+                <a:spcPts val="300"/>
+              </a:spcAft>
+              <a:defRPr sz="1000">
+                <a:solidFill>
+                  <a:srgbClr val="E2E8F0"/>
+                </a:solidFill>
+                <a:latin typeface="Consolas"/>
+              </a:defRPr>
+            </a:pPr>
+            <a:r>
+              <a:t>  return ContentService.createTextOutput(JSON.stringify(result))</a:t>
+            </a:r>
+          </a:p>
+          <a:p>
+            <a:pPr>
+              <a:spcAft>
+                <a:spcPts val="300"/>
+              </a:spcAft>
+              <a:defRPr sz="1000">
+                <a:solidFill>
+                  <a:srgbClr val="E2E8F0"/>
+                </a:solidFill>
+                <a:latin typeface="Consolas"/>
+              </a:defRPr>
+            </a:pPr>
+            <a:r>
+              <a:t>         .setMimeType(ContentService.MimeType.JSON);</a:t>
+            </a:r>
+          </a:p>
+          <a:p>
+            <a:pPr>
+              <a:spcAft>
+                <a:spcPts val="300"/>
+              </a:spcAft>
+              <a:defRPr sz="1000">
+                <a:solidFill>
+                  <a:srgbClr val="E2E8F0"/>
+                </a:solidFill>
+                <a:latin typeface="Consolas"/>
+              </a:defRPr>
+            </a:pPr>
+            <a:r>
+              <a:t>}</a:t>
             </a:r>
           </a:p>
         </p:txBody>
@@ -6223,7 +6199,7 @@
               </a:defRPr>
             </a:pPr>
             <a:r>
-              <a:t>CRC 專案開發與後端串接手冊</a:t>
+              <a:t>人機協同開發與雲端串接手冊</a:t>
             </a:r>
           </a:p>
         </p:txBody>
@@ -6259,7 +6235,7 @@
               </a:defRPr>
             </a:pPr>
             <a:r>
-              <a:t>Google Sheets 串接：四步驟快速建置 API 通道</a:t>
+              <a:t>第四階段：發布為網頁應用程式與網址設定</a:t>
             </a:r>
           </a:p>
         </p:txBody>
@@ -6315,8 +6291,8 @@
         </p:nvSpPr>
         <p:spPr>
           <a:xfrm>
-            <a:off x="746150" y="1737360"/>
-            <a:ext cx="2468880" cy="4389120"/>
+            <a:off x="685800" y="1645920"/>
+            <a:ext cx="5303520" cy="4480560"/>
           </a:xfrm>
           <a:prstGeom prst="rect">
             <a:avLst/>
@@ -6360,8 +6336,8 @@
         </p:nvSpPr>
         <p:spPr>
           <a:xfrm>
-            <a:off x="855878" y="1874520"/>
-            <a:ext cx="2249424" cy="4114800"/>
+            <a:off x="960120" y="1828800"/>
+            <a:ext cx="4754880" cy="4114800"/>
           </a:xfrm>
           <a:prstGeom prst="rect">
             <a:avLst/>
@@ -6376,9 +6352,9 @@
           <a:p>
             <a:pPr>
               <a:spcAft>
-                <a:spcPts val="400"/>
-              </a:spcAft>
-              <a:defRPr sz="1600" b="1">
+                <a:spcPts val="1200"/>
+              </a:spcAft>
+              <a:defRPr sz="1800" b="1">
                 <a:solidFill>
                   <a:srgbClr val="0284C7"/>
                 </a:solidFill>
@@ -6386,15 +6362,15 @@
               </a:defRPr>
             </a:pPr>
             <a:r>
-              <a:t>步驟一：新建試算表</a:t>
-            </a:r>
-          </a:p>
-          <a:p>
-            <a:pPr>
-              <a:spcAft>
-                <a:spcPts val="1200"/>
-              </a:spcAft>
-              <a:defRPr sz="1100" b="1">
+              <a:t>✉ 取得郵差的收信網址</a:t>
+            </a:r>
+          </a:p>
+          <a:p>
+            <a:pPr>
+              <a:spcAft>
+                <a:spcPts val="500"/>
+              </a:spcAft>
+              <a:defRPr sz="1150" b="1">
                 <a:solidFill>
                   <a:srgbClr val="0F172A"/>
                 </a:solidFill>
@@ -6402,31 +6378,71 @@
               </a:defRPr>
             </a:pPr>
             <a:r>
-              <a:t>建立 Database 載體</a:t>
-            </a:r>
-          </a:p>
-          <a:p>
-            <a:pPr>
-              <a:lnSpc>
-                <a:spcPct val="130000"/>
-              </a:lnSpc>
-              <a:defRPr sz="1100">
-                <a:solidFill>
-                  <a:srgbClr val="475569"/>
-                </a:solidFill>
-                <a:latin typeface="Microsoft JhengHei"/>
-              </a:defRPr>
-            </a:pPr>
-            <a:r>
-              <a:t>1. 登入 Google 雲端硬碟。</a:t>
-            </a:r>
-            <a:br/>
-            <a:r>
-              <a:t>2. 新建一個空白的「Google 試算表」，檔名可自由命名。</a:t>
-            </a:r>
-            <a:br/>
-            <a:r>
-              <a:t>3. 後端會自動初始化分頁與表頭，無須手動建表。</a:t>
+              <a:t>1. ('點選 Apps Script 右上角的「部署」', '在編輯器畫面右上角點選「部署」 $\rightarrow$ 「新增部署」。')</a:t>
+            </a:r>
+          </a:p>
+          <a:p>
+            <a:pPr>
+              <a:spcAft>
+                <a:spcPts val="500"/>
+              </a:spcAft>
+              <a:defRPr sz="1150" b="1">
+                <a:solidFill>
+                  <a:srgbClr val="0F172A"/>
+                </a:solidFill>
+                <a:latin typeface="Microsoft JhengHei"/>
+              </a:defRPr>
+            </a:pPr>
+            <a:r>
+              <a:t>2. ('設定部署類型為「網頁應用程式」', '點齒輪圖示，選取「網頁應用程式」類型。這會讓 Google 為您生成一個對外接收信件的 HTTP 接口。')</a:t>
+            </a:r>
+          </a:p>
+          <a:p>
+            <a:pPr>
+              <a:spcAft>
+                <a:spcPts val="500"/>
+              </a:spcAft>
+              <a:defRPr sz="1150" b="1">
+                <a:solidFill>
+                  <a:srgbClr val="0F172A"/>
+                </a:solidFill>
+                <a:latin typeface="Microsoft JhengHei"/>
+              </a:defRPr>
+            </a:pPr>
+            <a:r>
+              <a:t>3. ('設定權限：執行身分為「我」', '這能確保網頁有權利把資料寫入「您的」試算表中。')</a:t>
+            </a:r>
+          </a:p>
+          <a:p>
+            <a:pPr>
+              <a:spcAft>
+                <a:spcPts val="500"/>
+              </a:spcAft>
+              <a:defRPr sz="1150" b="1">
+                <a:solidFill>
+                  <a:srgbClr val="0F172A"/>
+                </a:solidFill>
+                <a:latin typeface="Microsoft JhengHei"/>
+              </a:defRPr>
+            </a:pPr>
+            <a:r>
+              <a:t>4. ('設定權限：存取權限為「任何人」', '這讓任何人（包括學生開啟的簡報或遊戲）都能把信寄進來。')</a:t>
+            </a:r>
+          </a:p>
+          <a:p>
+            <a:pPr>
+              <a:spcAft>
+                <a:spcPts val="500"/>
+              </a:spcAft>
+              <a:defRPr sz="1150" b="1">
+                <a:solidFill>
+                  <a:srgbClr val="0F172A"/>
+                </a:solidFill>
+                <a:latin typeface="Microsoft JhengHei"/>
+              </a:defRPr>
+            </a:pPr>
+            <a:r>
+              <a:t>5. ('部署並複製產生的網頁網址', '按「部署」後，會產生一串網址。點選「複製」，這就是我們要填入網頁的「收信地址」。')</a:t>
             </a:r>
           </a:p>
         </p:txBody>
@@ -6439,8 +6455,8 @@
         </p:nvSpPr>
         <p:spPr>
           <a:xfrm>
-            <a:off x="3489350" y="1737360"/>
-            <a:ext cx="2468880" cy="4389120"/>
+            <a:off x="6217920" y="1645920"/>
+            <a:ext cx="5257800" cy="4480560"/>
           </a:xfrm>
           <a:prstGeom prst="rect">
             <a:avLst/>
@@ -6484,8 +6500,8 @@
         </p:nvSpPr>
         <p:spPr>
           <a:xfrm>
-            <a:off x="3599078" y="1874520"/>
-            <a:ext cx="2249424" cy="4114800"/>
+            <a:off x="6492240" y="1828800"/>
+            <a:ext cx="4709160" cy="4114800"/>
           </a:xfrm>
           <a:prstGeom prst="rect">
             <a:avLst/>
@@ -6500,9 +6516,9 @@
           <a:p>
             <a:pPr>
               <a:spcAft>
-                <a:spcPts val="400"/>
-              </a:spcAft>
-              <a:defRPr sz="1600" b="1">
+                <a:spcPts val="1200"/>
+              </a:spcAft>
+              <a:defRPr sz="1700" b="1">
                 <a:solidFill>
                   <a:srgbClr val="7E22CE"/>
                 </a:solidFill>
@@ -6510,15 +6526,15 @@
               </a:defRPr>
             </a:pPr>
             <a:r>
-              <a:t>步驟二：貼入後端程式</a:t>
-            </a:r>
-          </a:p>
-          <a:p>
-            <a:pPr>
-              <a:spcAft>
-                <a:spcPts val="1200"/>
-              </a:spcAft>
-              <a:defRPr sz="1100" b="1">
+              <a:t>⚙ 前端網頁的連線設定</a:t>
+            </a:r>
+          </a:p>
+          <a:p>
+            <a:pPr>
+              <a:spcAft>
+                <a:spcPts val="1000"/>
+              </a:spcAft>
+              <a:defRPr sz="1250">
                 <a:solidFill>
                   <a:srgbClr val="0F172A"/>
                 </a:solidFill>
@@ -6526,14 +6542,30 @@
               </a:defRPr>
             </a:pPr>
             <a:r>
-              <a:t>Apps Script 腳本編輯</a:t>
-            </a:r>
-          </a:p>
-          <a:p>
-            <a:pPr>
-              <a:lnSpc>
-                <a:spcPct val="130000"/>
-              </a:lnSpc>
+              <a:t>得到 Google 產生的部署網址後，只要在前端做對接，簡報和遊戲就大功告成：</a:t>
+            </a:r>
+          </a:p>
+          <a:p>
+            <a:pPr>
+              <a:spcAft>
+                <a:spcPts val="100"/>
+              </a:spcAft>
+              <a:defRPr sz="1250" b="1">
+                <a:solidFill>
+                  <a:srgbClr val="0F172A"/>
+                </a:solidFill>
+                <a:latin typeface="Microsoft JhengHei"/>
+              </a:defRPr>
+            </a:pPr>
+            <a:r>
+              <a:t>▪ 貼上預設連線變數</a:t>
+            </a:r>
+          </a:p>
+          <a:p>
+            <a:pPr>
+              <a:spcAft>
+                <a:spcPts val="800"/>
+              </a:spcAft>
               <a:defRPr sz="1100">
                 <a:solidFill>
                   <a:srgbClr val="475569"/>
@@ -6542,103 +6574,15 @@
               </a:defRPr>
             </a:pPr>
             <a:r>
-              <a:t>1. 於試算表中點選「延伸功能」-&gt;「Apps Script」。</a:t>
-            </a:r>
-            <a:br/>
-            <a:r>
-              <a:t>2. 清空預設函數，完整貼入專案「backend/Code.gs」程式碼，點擊儲存。</a:t>
-            </a:r>
-          </a:p>
-        </p:txBody>
-      </p:sp>
-      <p:sp>
-        <p:nvSpPr>
-          <p:cNvPr id="9" name="Rectangle 8"/>
-          <p:cNvSpPr/>
-          <p:nvPr/>
-        </p:nvSpPr>
-        <p:spPr>
-          <a:xfrm>
-            <a:off x="6232550" y="1737360"/>
-            <a:ext cx="2468880" cy="4389120"/>
-          </a:xfrm>
-          <a:prstGeom prst="rect">
-            <a:avLst/>
-          </a:prstGeom>
-          <a:solidFill>
-            <a:srgbClr val="FFFFFF"/>
-          </a:solidFill>
-          <a:ln w="19050">
-            <a:solidFill>
-              <a:srgbClr val="0284C7"/>
-            </a:solidFill>
-          </a:ln>
-        </p:spPr>
-        <p:style>
-          <a:lnRef idx="1">
-            <a:schemeClr val="accent1"/>
-          </a:lnRef>
-          <a:fillRef idx="3">
-            <a:schemeClr val="accent1"/>
-          </a:fillRef>
-          <a:effectRef idx="2">
-            <a:schemeClr val="accent1"/>
-          </a:effectRef>
-          <a:fontRef idx="minor">
-            <a:schemeClr val="lt1"/>
-          </a:fontRef>
-        </p:style>
-        <p:txBody>
-          <a:bodyPr rtlCol="0" anchor="ctr"/>
-          <a:lstStyle/>
-          <a:p>
-            <a:pPr algn="ctr"/>
-          </a:p>
-        </p:txBody>
-      </p:sp>
-      <p:sp>
-        <p:nvSpPr>
-          <p:cNvPr id="10" name="TextBox 9"/>
-          <p:cNvSpPr txBox="1"/>
-          <p:nvPr/>
-        </p:nvSpPr>
-        <p:spPr>
-          <a:xfrm>
-            <a:off x="6342278" y="1874520"/>
-            <a:ext cx="2249424" cy="4114800"/>
-          </a:xfrm>
-          <a:prstGeom prst="rect">
-            <a:avLst/>
-          </a:prstGeom>
-          <a:noFill/>
-        </p:spPr>
-        <p:txBody>
-          <a:bodyPr wrap="square">
-            <a:spAutoFit/>
-          </a:bodyPr>
-          <a:lstStyle/>
-          <a:p>
-            <a:pPr>
-              <a:spcAft>
-                <a:spcPts val="400"/>
-              </a:spcAft>
-              <a:defRPr sz="1600" b="1">
-                <a:solidFill>
-                  <a:srgbClr val="0284C7"/>
-                </a:solidFill>
-                <a:latin typeface="Microsoft JhengHei"/>
-              </a:defRPr>
-            </a:pPr>
-            <a:r>
-              <a:t>步驟三：部署 Web App</a:t>
-            </a:r>
-          </a:p>
-          <a:p>
-            <a:pPr>
-              <a:spcAft>
-                <a:spcPts val="1200"/>
-              </a:spcAft>
-              <a:defRPr sz="1100" b="1">
+              <a:t>我們已將您的 Web App URL 寫入專案的 `js/config.js` 的 `defaultApiUrl` 欄位中，因此學生只要開啟網頁，背後就會預設往此網址寄信。</a:t>
+            </a:r>
+          </a:p>
+          <a:p>
+            <a:pPr>
+              <a:spcAft>
+                <a:spcPts val="100"/>
+              </a:spcAft>
+              <a:defRPr sz="1250" b="1">
                 <a:solidFill>
                   <a:srgbClr val="0F172A"/>
                 </a:solidFill>
@@ -6646,14 +6590,14 @@
               </a:defRPr>
             </a:pPr>
             <a:r>
-              <a:t>取得 API Endpoint</a:t>
-            </a:r>
-          </a:p>
-          <a:p>
-            <a:pPr>
-              <a:lnSpc>
-                <a:spcPct val="130000"/>
-              </a:lnSpc>
+              <a:t>▪ 提供臨時更改功能 (防呆)</a:t>
+            </a:r>
+          </a:p>
+          <a:p>
+            <a:pPr>
+              <a:spcAft>
+                <a:spcPts val="800"/>
+              </a:spcAft>
               <a:defRPr sz="1100">
                 <a:solidFill>
                   <a:srgbClr val="475569"/>
@@ -6662,139 +6606,7 @@
               </a:defRPr>
             </a:pPr>
             <a:r>
-              <a:t>1. 點擊「部署」-&gt;「新增部署」。</a:t>
-            </a:r>
-            <a:br/>
-            <a:r>
-              <a:t>2. 類型選擇「網頁應用程式」。</a:t>
-            </a:r>
-            <a:br/>
-            <a:r>
-              <a:t>3. 執行身分設為「我」；存取權限設為「任何人(Anyone)」後進行部署，複製產生的 URL。</a:t>
-            </a:r>
-          </a:p>
-        </p:txBody>
-      </p:sp>
-      <p:sp>
-        <p:nvSpPr>
-          <p:cNvPr id="11" name="Rectangle 10"/>
-          <p:cNvSpPr/>
-          <p:nvPr/>
-        </p:nvSpPr>
-        <p:spPr>
-          <a:xfrm>
-            <a:off x="8975750" y="1737360"/>
-            <a:ext cx="2468880" cy="4389120"/>
-          </a:xfrm>
-          <a:prstGeom prst="rect">
-            <a:avLst/>
-          </a:prstGeom>
-          <a:solidFill>
-            <a:srgbClr val="FFFFFF"/>
-          </a:solidFill>
-          <a:ln w="19050">
-            <a:solidFill>
-              <a:srgbClr val="7E22CE"/>
-            </a:solidFill>
-          </a:ln>
-        </p:spPr>
-        <p:style>
-          <a:lnRef idx="1">
-            <a:schemeClr val="accent1"/>
-          </a:lnRef>
-          <a:fillRef idx="3">
-            <a:schemeClr val="accent1"/>
-          </a:fillRef>
-          <a:effectRef idx="2">
-            <a:schemeClr val="accent1"/>
-          </a:effectRef>
-          <a:fontRef idx="minor">
-            <a:schemeClr val="lt1"/>
-          </a:fontRef>
-        </p:style>
-        <p:txBody>
-          <a:bodyPr rtlCol="0" anchor="ctr"/>
-          <a:lstStyle/>
-          <a:p>
-            <a:pPr algn="ctr"/>
-          </a:p>
-        </p:txBody>
-      </p:sp>
-      <p:sp>
-        <p:nvSpPr>
-          <p:cNvPr id="12" name="TextBox 11"/>
-          <p:cNvSpPr txBox="1"/>
-          <p:nvPr/>
-        </p:nvSpPr>
-        <p:spPr>
-          <a:xfrm>
-            <a:off x="9085478" y="1874520"/>
-            <a:ext cx="2249424" cy="4114800"/>
-          </a:xfrm>
-          <a:prstGeom prst="rect">
-            <a:avLst/>
-          </a:prstGeom>
-          <a:noFill/>
-        </p:spPr>
-        <p:txBody>
-          <a:bodyPr wrap="square">
-            <a:spAutoFit/>
-          </a:bodyPr>
-          <a:lstStyle/>
-          <a:p>
-            <a:pPr>
-              <a:spcAft>
-                <a:spcPts val="400"/>
-              </a:spcAft>
-              <a:defRPr sz="1600" b="1">
-                <a:solidFill>
-                  <a:srgbClr val="7E22CE"/>
-                </a:solidFill>
-                <a:latin typeface="Microsoft JhengHei"/>
-              </a:defRPr>
-            </a:pPr>
-            <a:r>
-              <a:t>步驟四：設定前端連線</a:t>
-            </a:r>
-          </a:p>
-          <a:p>
-            <a:pPr>
-              <a:spcAft>
-                <a:spcPts val="1200"/>
-              </a:spcAft>
-              <a:defRPr sz="1100" b="1">
-                <a:solidFill>
-                  <a:srgbClr val="0F172A"/>
-                </a:solidFill>
-                <a:latin typeface="Microsoft JhengHei"/>
-              </a:defRPr>
-            </a:pPr>
-            <a:r>
-              <a:t>前端網頁網址對接</a:t>
-            </a:r>
-          </a:p>
-          <a:p>
-            <a:pPr>
-              <a:lnSpc>
-                <a:spcPct val="130000"/>
-              </a:lnSpc>
-              <a:defRPr sz="1100">
-                <a:solidFill>
-                  <a:srgbClr val="475569"/>
-                </a:solidFill>
-                <a:latin typeface="Microsoft JhengHei"/>
-              </a:defRPr>
-            </a:pPr>
-            <a:r>
-              <a:t>1. 打開 index.html / slides.html 等，點右上角設定按鈕。</a:t>
-            </a:r>
-            <a:br/>
-            <a:r>
-              <a:t>2. 貼入剛剛複製的 Web App URL 並點擊保存。</a:t>
-            </a:r>
-            <a:br/>
-            <a:r>
-              <a:t>3. 已預設寫入 JS 組態檔中，學生即開即用。</a:t>
+              <a:t>網頁右上角設有齒輪設定按鈕，如果老師未來換了新的試算表，無須重新改寫網頁，直接在網頁上貼上新網址即可立刻變更收件試算表。</a:t>
             </a:r>
           </a:p>
         </p:txBody>
@@ -6856,7 +6668,7 @@
               </a:defRPr>
             </a:pPr>
             <a:r>
-              <a:t>CRC 專案開發與後端串接手冊</a:t>
+              <a:t>人機協同開發與雲端串接手冊</a:t>
             </a:r>
           </a:p>
         </p:txBody>
@@ -6892,7 +6704,7 @@
               </a:defRPr>
             </a:pPr>
             <a:r>
-              <a:t>後端容錯機制：No-CORS 傳送與表頭動態遷移</a:t>
+              <a:t>核心連線技術：安全傳送與資料表自動長大</a:t>
             </a:r>
           </a:p>
         </p:txBody>
@@ -7019,7 +6831,7 @@
               </a:defRPr>
             </a:pPr>
             <a:r>
-              <a:t>🛡️ CORS 跨網域安全阻攔解決方案</a:t>
+              <a:t>🛡️ 不塞信通道 (No-CORS) 解決跨域阻擋</a:t>
             </a:r>
           </a:p>
           <a:p>
@@ -7035,7 +6847,7 @@
               </a:defRPr>
             </a:pPr>
             <a:r>
-              <a:t>問題：GAS Web App 接收 POST 時會重新導向，因導向鏈中遺失 CORS 標頭，瀏覽器會封鎖請求，出現 Failed to fetch 錯誤。</a:t>
+              <a:t>問題：瀏覽器有防偷看隱私的保護機制。當學生網頁往 Google 發送資料時，瀏覽器如果發現 Google 沒有回應特定的安全標頭，會主動把信件攔截，導致寫入失敗。</a:t>
             </a:r>
           </a:p>
           <a:p>
@@ -7051,7 +6863,7 @@
               </a:defRPr>
             </a:pPr>
             <a:r>
-              <a:t>✔ 前端採用 mode: 'no-cors' 屬性</a:t>
+              <a:t>✔ 前端發信設定 mode: 'no-cors'</a:t>
             </a:r>
           </a:p>
           <a:p>
@@ -7067,7 +6879,7 @@
               </a:defRPr>
             </a:pPr>
             <a:r>
-              <a:t>   強制瀏覽器放棄對該請求進行跨域安全標頭驗證。</a:t>
+              <a:t>   這是跟瀏覽器宣告「我只是要把資料投進去，不打算讀取 Google 回傳的悄悄話」，命令瀏覽器不要阻攔寄信。</a:t>
             </a:r>
           </a:p>
           <a:p>
@@ -7083,7 +6895,7 @@
               </a:defRPr>
             </a:pPr>
             <a:r>
-              <a:t>✔ 發送設定 Content-Type: 'text/plain'</a:t>
+              <a:t>✔ 信件標記為簡單文字格式</a:t>
             </a:r>
           </a:p>
           <a:p>
@@ -7099,7 +6911,7 @@
               </a:defRPr>
             </a:pPr>
             <a:r>
-              <a:t>   將 POST 標記為 Simple Request，避開瀏覽器自動觸發的 pre-flight OPTIONS 請求阻礙。</a:t>
+              <a:t>   將傳送類型設為 plain text，不讓瀏覽器啟動複雜的安全性預檢，直接把信投遞成功。</a:t>
             </a:r>
           </a:p>
           <a:p>
@@ -7115,7 +6927,7 @@
               </a:defRPr>
             </a:pPr>
             <a:r>
-              <a:t>✔ Opaque 響應直接默認成功</a:t>
+              <a:t>✔ 穩定又可靠的背景運作</a:t>
             </a:r>
           </a:p>
           <a:p>
@@ -7131,7 +6943,7 @@
               </a:defRPr>
             </a:pPr>
             <a:r>
-              <a:t>   因 no-cors 模式會返回 status 0 (不透明)，前端不進行 json 解析，無拋錯即視為發送成功，確保穩定。</a:t>
+              <a:t>   投遞成功後，前端網頁雖然讀不到 Google 的確認信，但只要沒有網路異常，便視為發信成功。</a:t>
             </a:r>
           </a:p>
         </p:txBody>
@@ -7215,7 +7027,7 @@
               </a:defRPr>
             </a:pPr>
             <a:r>
-              <a:t>🔄 動態資料表與自動表頭遷移</a:t>
+              <a:t>🔄 資料庫自動升級 (無痛欄位長大)</a:t>
             </a:r>
           </a:p>
           <a:p>
@@ -7231,7 +7043,7 @@
               </a:defRPr>
             </a:pPr>
             <a:r>
-              <a:t>因應課程迭代開發（如追加批判簡答、自治宣言欄位），後端 Code.gs 特別實作自動化表頭遷移 (Schema Migration)：</a:t>
+              <a:t>問題：如果以後遊戲要新增「第5關」或「新的簡答題」，原來的試算表是不是要手動加欄位？舊的資料會不會壞掉？</a:t>
             </a:r>
           </a:p>
           <a:p>
@@ -7247,7 +7059,7 @@
               </a:defRPr>
             </a:pPr>
             <a:r>
-              <a:t>✦ 空白分頁自動建立</a:t>
+              <a:t>✦ 分頁與表頭自動建立</a:t>
             </a:r>
           </a:p>
           <a:p>
@@ -7263,7 +7075,7 @@
               </a:defRPr>
             </a:pPr>
             <a:r>
-              <a:t>若試算表有手動建分頁但完全空白，getLastColumn() 為 0。後端自動攔截並呼叫 appendRow 寫入 defaultHeaders 防止 Range Error。</a:t>
+              <a:t>若試算表是完全空白的，程式在收到第一筆資料時會主動發現，並自動建好 slides_feedback (簡報反思) 與 game_scores (遊戲分數) 分頁，並打好第一行表頭。</a:t>
             </a:r>
           </a:p>
           <a:p>
@@ -7279,7 +7091,7 @@
               </a:defRPr>
             </a:pPr>
             <a:r>
-              <a:t>✦ 版本升級自動追加欄位</a:t>
+              <a:t>✦ 新舊版自動比對與追增</a:t>
             </a:r>
           </a:p>
           <a:p>
@@ -7295,7 +7107,7 @@
               </a:defRPr>
             </a:pPr>
             <a:r>
-              <a:t>當新版遊戲傳送 ShortAnswer1 等新欄位時，Code.gs 自動比對表頭。若缺失，即透過 getRange() 在最右側追加新表頭，無損升級資料庫。</a:t>
+              <a:t>當新版網頁傳送了以前沒有的欄位（如 ShortAnswer1、ShortAnswer2 等批判簡答），程式會比對表頭。發現缺少時，會自動在最右側追增新表頭，舊資料安然無恙。</a:t>
             </a:r>
           </a:p>
         </p:txBody>
@@ -7357,7 +7169,7 @@
               </a:defRPr>
             </a:pPr>
             <a:r>
-              <a:t>CRC 專案開發與後端串接手冊</a:t>
+              <a:t>人機協同開發與雲端串接手冊</a:t>
             </a:r>
           </a:p>
         </p:txBody>
@@ -7393,7 +7205,7 @@
               </a:defRPr>
             </a:pPr>
             <a:r>
-              <a:t>發布與測試驗證：GitHub Pages 託管與 API 實測</a:t>
+              <a:t>系統測試與驗證：AI 自動模擬寫入成功</a:t>
             </a:r>
           </a:p>
         </p:txBody>
@@ -7520,7 +7332,23 @@
               </a:defRPr>
             </a:pPr>
             <a:r>
-              <a:t>🚀 GitHub Pages 前端靜態部署</a:t>
+              <a:t>🧪 AI 自動模擬寫入測試</a:t>
+            </a:r>
+          </a:p>
+          <a:p>
+            <a:pPr>
+              <a:spcAft>
+                <a:spcPts val="1000"/>
+              </a:spcAft>
+              <a:defRPr sz="1250">
+                <a:solidFill>
+                  <a:srgbClr val="0F172A"/>
+                </a:solidFill>
+                <a:latin typeface="Microsoft JhengHei"/>
+              </a:defRPr>
+            </a:pPr>
+            <a:r>
+              <a:t>為了驗證連線是否暢通，我們在專案中撰寫了自動化測試腳本（`test_gas.js`），模擬學生的瀏覽器行為，發送兩筆資料給您的 Google 試算表：</a:t>
             </a:r>
           </a:p>
           <a:p>
@@ -7528,7 +7356,7 @@
               <a:spcAft>
                 <a:spcPts val="100"/>
               </a:spcAft>
-              <a:defRPr sz="1250" b="1">
+              <a:defRPr sz="1200" b="1">
                 <a:solidFill>
                   <a:srgbClr val="0F172A"/>
                 </a:solidFill>
@@ -7536,13 +7364,13 @@
               </a:defRPr>
             </a:pPr>
             <a:r>
-              <a:t>▪ 本地倉庫 Git 初始化</a:t>
-            </a:r>
-          </a:p>
-          <a:p>
-            <a:pPr>
-              <a:spcAft>
-                <a:spcPts val="800"/>
+              <a:t>▪ 模擬簡報反思資料投遞</a:t>
+            </a:r>
+          </a:p>
+          <a:p>
+            <a:pPr>
+              <a:spcAft>
+                <a:spcPts val="600"/>
               </a:spcAft>
               <a:defRPr sz="1100">
                 <a:solidFill>
@@ -7552,7 +7380,7 @@
               </a:defRPr>
             </a:pPr>
             <a:r>
-              <a:t>開啟終端機進入專案目錄，執行 `git init` 建立本地版控倉庫。</a:t>
+              <a:t>發送一筆玩家姓名為「AI測試員-簡報」的思考答案至 slides_feedback 表。</a:t>
             </a:r>
           </a:p>
           <a:p>
@@ -7560,7 +7388,7 @@
               <a:spcAft>
                 <a:spcPts val="100"/>
               </a:spcAft>
-              <a:defRPr sz="1250" b="1">
+              <a:defRPr sz="1200" b="1">
                 <a:solidFill>
                   <a:srgbClr val="0F172A"/>
                 </a:solidFill>
@@ -7568,13 +7396,13 @@
               </a:defRPr>
             </a:pPr>
             <a:r>
-              <a:t>▪ 提交靜態資源變更</a:t>
-            </a:r>
-          </a:p>
-          <a:p>
-            <a:pPr>
-              <a:spcAft>
-                <a:spcPts val="800"/>
+              <a:t>▪ 模擬遊戲得分資料投遞</a:t>
+            </a:r>
+          </a:p>
+          <a:p>
+            <a:pPr>
+              <a:spcAft>
+                <a:spcPts val="600"/>
               </a:spcAft>
               <a:defRPr sz="1100">
                 <a:solidFill>
@@ -7584,7 +7412,7 @@
               </a:defRPr>
             </a:pPr>
             <a:r>
-              <a:t>執行 `git add .` 與 `git commit -m 'feat: init CRC platform'` 完成本地提交。</a:t>
+              <a:t>發送一筆姓名為「AI測試員-遊戲」的完整遊戲指標、抉擇路徑及三道批判簡答心得至 game_scores 表。</a:t>
             </a:r>
           </a:p>
           <a:p>
@@ -7592,7 +7420,7 @@
               <a:spcAft>
                 <a:spcPts val="100"/>
               </a:spcAft>
-              <a:defRPr sz="1250" b="1">
+              <a:defRPr sz="1200" b="1">
                 <a:solidFill>
                   <a:srgbClr val="0F172A"/>
                 </a:solidFill>
@@ -7600,13 +7428,13 @@
               </a:defRPr>
             </a:pPr>
             <a:r>
-              <a:t>▪ 推送至 GitHub 遠端倉庫</a:t>
-            </a:r>
-          </a:p>
-          <a:p>
-            <a:pPr>
-              <a:spcAft>
-                <a:spcPts val="800"/>
+              <a:t>▪ 確認測試寫入完全成功</a:t>
+            </a:r>
+          </a:p>
+          <a:p>
+            <a:pPr>
+              <a:spcAft>
+                <a:spcPts val="600"/>
               </a:spcAft>
               <a:defRPr sz="1100">
                 <a:solidFill>
@@ -7616,39 +7444,7 @@
               </a:defRPr>
             </a:pPr>
             <a:r>
-              <a:t>關聯遠端儲存庫並執行 `git push -u origin main` 推送至 GitHub。</a:t>
-            </a:r>
-          </a:p>
-          <a:p>
-            <a:pPr>
-              <a:spcAft>
-                <a:spcPts val="100"/>
-              </a:spcAft>
-              <a:defRPr sz="1250" b="1">
-                <a:solidFill>
-                  <a:srgbClr val="0F172A"/>
-                </a:solidFill>
-                <a:latin typeface="Microsoft JhengHei"/>
-              </a:defRPr>
-            </a:pPr>
-            <a:r>
-              <a:t>▪ 啟用 Pages 服務</a:t>
-            </a:r>
-          </a:p>
-          <a:p>
-            <a:pPr>
-              <a:spcAft>
-                <a:spcPts val="800"/>
-              </a:spcAft>
-              <a:defRPr sz="1100">
-                <a:solidFill>
-                  <a:srgbClr val="475569"/>
-                </a:solidFill>
-                <a:latin typeface="Microsoft JhengHei"/>
-              </a:defRPr>
-            </a:pPr>
-            <a:r>
-              <a:t>於 Settings -&gt; Pages 頁面將 Source 設為 main 分支並保存。稍等 1 分鐘即可經由 https://mchung2022.github.io/CRC2026/ 公開瀏覽。</a:t>
+              <a:t>後端順利解析這兩封信，並成功寫入試算表，自動建立表頭，表示 API 通道 100% 暢通！</a:t>
             </a:r>
           </a:p>
         </p:txBody>
@@ -7732,7 +7528,7 @@
               </a:defRPr>
             </a:pPr>
             <a:r>
-              <a:t>🧪 Node.js 後端 API 自動寫入驗證</a:t>
+              <a:t>📊 試算表內寫入的真實內容</a:t>
             </a:r>
           </a:p>
           <a:p>
@@ -7748,7 +7544,7 @@
               </a:defRPr>
             </a:pPr>
             <a:r>
-              <a:t>我們已建立測試腳本對您最新的 Google Apps Script 連線位址進行 POST 模擬寫入，驗證結果如下：</a:t>
+              <a:t>當您打開綁定的 Google 試算表時，您會在下方分頁看到以下自動寫入的測試內容：</a:t>
             </a:r>
           </a:p>
           <a:p>
@@ -7764,7 +7560,7 @@
               </a:defRPr>
             </a:pPr>
             <a:r>
-              <a:t>✔ 簡報素養反思測試 寫入成功</a:t>
+              <a:t>✔ 工作表 slides_feedback (簡報反思)</a:t>
             </a:r>
           </a:p>
           <a:p>
@@ -7780,7 +7576,7 @@
               </a:defRPr>
             </a:pPr>
             <a:r>
-              <a:t>傳送姓名『AI測試員-簡報』及素養討論反思至工作表 slides_feedback，後端成功解析並回傳 success: true。</a:t>
+              <a:t>系統寫入：時間戳記、AI測試員-簡報、測試學系、第3頁、反思答案內容。</a:t>
             </a:r>
           </a:p>
           <a:p>
@@ -7796,7 +7592,7 @@
               </a:defRPr>
             </a:pPr>
             <a:r>
-              <a:t>✔ 遊戲結算與簡答題 寫入成功</a:t>
+              <a:t>✔ 工作表 game_scores (遊戲分數)</a:t>
             </a:r>
           </a:p>
           <a:p>
@@ -7812,7 +7608,7 @@
               </a:defRPr>
             </a:pPr>
             <a:r>
-              <a:t>傳送姓名『AI測試員-遊戲』、學號、得分、以及三道批判簡答內容至工作表 game_scores，後端順利完成寫入且無 CORS 阻攔。</a:t>
+              <a:t>系統寫入：時間戳記、AI測試員-遊戲、學號、CRC分數、秩序分數、專業分數、人格特質、抉擇路徑、以及三道規章體檢簡答。</a:t>
             </a:r>
           </a:p>
         </p:txBody>

</xml_diff>